<commit_message>
Slide 2 rebuild, title slide name only, VRR occupancy reframe, quadrant slider fix
</commit_message>
<xml_diff>
--- a/docs/executive_deck.pptx
+++ b/docs/executive_deck.pptx
@@ -1047,7 +1047,11 @@
           <a:p>
             <a:r>
               <a:rPr lang="en-US" dirty="0"/>
-              <a:t>5 min. Lead with the telemetry story — it's the same problem as this case study: the product IS the number. Don't walk the resume chronologically; use the three principles as the spine.</a:t>
+              <a:t>5 min — this is you talking, not the slide. Keep the slide bare and carry the proof in the script.
+CUSTOMER CENTRICITY — Teams Queues App. I prioritized the metrics call-centre supervisors actually needed over the ones that were easy to instrument. Wait times down 50%, 25x adoption in six months.
+PLATFORM THINKING — M365's first compliant streaming platform. 1M events per second, phishing response from two hours to under five minutes, model recall 60% to 90%. And a unified telemetry product across Event Hubs and Service Bus that surfaced $200K a month in billing discrepancies nobody knew existed. You cannot fix what you cannot see.
+LEARNING — this case study. BigQuery, dbt-style SQL and Streamlit, none of which I had used before last week. Say this one out loud: it makes Learning a demonstration rather than a claim, and it pre-empts 'you have never worked in BigQuery.'
+Close on the quote, then go straight into the four questions.</a:t>
             </a:r>
             <a:endParaRPr lang="en-US" dirty="0"/>
           </a:p>
@@ -1225,9 +1229,14 @@
           <a:p>
             <a:r>
               <a:rPr lang="en-US" dirty="0"/>
-              <a:t>5 min — slowest slide in the deck. Walk the arithmetic out loud.
-If they remember one thing, it's this multiplication.
-Expect: 'why not a weighted average?' — because averaging lets a strong factor hide a weak one.</a:t>
+              <a:t>5 min — the most important slide in the deck. Do not rush it.
+Lead with the square, not the formula: 'Everything a customer could get from a SKU is a square — all their features on one side, all their capacity on the other. VRR is how much of that square they actually occupy.'
+Then the analogy if it helps: VRR is occupancy for software. A hotel with 100 rooms open 365 days sells a fraction of its room-nights. Nobody expects 100%, and a hotel running at 100% did not build enough rooms.
+ANSWER THESE BEFORE THEY ASK:
+· Is it utilization? No — utilization is one side of the square. VRR is the area.
+· Can it be 0? Yes. No features, or no consumption, collapses the area.
+· Can it be 100%? Yes — and that account is out of room. It is an upsell signal, not a win.
+· Do NOT say 'typical range is 20-50%' as though the metric imposes it. What you observe is that enterprise customers buy broad and deploy narrow. The observation IS the finding.</a:t>
             </a:r>
             <a:endParaRPr lang="en-US" dirty="0"/>
           </a:p>
@@ -2203,7 +2212,7 @@
                 <a:ea typeface="Calibri" pitchFamily="34" charset="-122"/>
                 <a:cs typeface="Calibri" pitchFamily="34" charset="-120"/>
               </a:rPr>
-              <a:t>Suraj Parameswara Iyer   ·   Principal Product Manager, Analytics &amp; AI</a:t>
+              <a:t>Suraj Iyer</a:t>
             </a:r>
             <a:endParaRPr lang="en-US" sz="1300" dirty="0"/>
           </a:p>
@@ -4619,7 +4628,7 @@
                 <a:ea typeface="Cambria" pitchFamily="34" charset="-122"/>
                 <a:cs typeface="Cambria" pitchFamily="34" charset="-120"/>
               </a:rPr>
-              <a:t>Row counts prove it ran. These prove it was right.</a:t>
+              <a:t>The tests check the answer, not the plumbing</a:t>
             </a:r>
             <a:endParaRPr lang="en-US" sz="3400" dirty="0"/>
           </a:p>
@@ -4627,13 +4636,52 @@
       </p:sp>
       <p:sp>
         <p:nvSpPr>
-          <p:cNvPr id="4" name="Shape 2"/>
-          <p:cNvSpPr/>
-          <p:nvPr/>
-        </p:nvSpPr>
-        <p:spPr>
-          <a:xfrm>
-            <a:off x="548640" y="1554480"/>
+          <p:cNvPr id="4" name="Text 2"/>
+          <p:cNvSpPr/>
+          <p:nvPr/>
+        </p:nvSpPr>
+        <p:spPr>
+          <a:xfrm>
+            <a:off x="548640" y="1298448"/>
+            <a:ext cx="11064240" cy="320040"/>
+          </a:xfrm>
+          <a:prstGeom prst="rect">
+            <a:avLst/>
+          </a:prstGeom>
+          <a:noFill/>
+          <a:ln/>
+        </p:spPr>
+        <p:txBody>
+          <a:bodyPr wrap="square" lIns="0" tIns="0" rIns="0" bIns="0" rtlCol="0" anchor="ctr"/>
+          <a:lstStyle/>
+          <a:p>
+            <a:pPr indent="0" marL="0">
+              <a:buNone/>
+            </a:pPr>
+            <a:r>
+              <a:rPr lang="en-US" sz="1400" dirty="0">
+                <a:solidFill>
+                  <a:srgbClr val="5A5F6B"/>
+                </a:solidFill>
+                <a:latin typeface="Calibri" pitchFamily="34" charset="0"/>
+                <a:ea typeface="Calibri" pitchFamily="34" charset="-122"/>
+                <a:cs typeface="Calibri" pitchFamily="34" charset="-120"/>
+              </a:rPr>
+              <a:t>I planted twelve problems in the data, then tested whether the metric found them — without ever letting the pipeline see the labels.</a:t>
+            </a:r>
+            <a:endParaRPr lang="en-US" sz="1400" dirty="0"/>
+          </a:p>
+        </p:txBody>
+      </p:sp>
+      <p:sp>
+        <p:nvSpPr>
+          <p:cNvPr id="5" name="Shape 3"/>
+          <p:cNvSpPr/>
+          <p:nvPr/>
+        </p:nvSpPr>
+        <p:spPr>
+          <a:xfrm>
+            <a:off x="548640" y="1719072"/>
             <a:ext cx="5394960" cy="896112"/>
           </a:xfrm>
           <a:prstGeom prst="roundRect">
@@ -4654,13 +4702,13 @@
       </p:sp>
       <p:sp>
         <p:nvSpPr>
-          <p:cNvPr id="5" name="Text 3"/>
-          <p:cNvSpPr/>
-          <p:nvPr/>
-        </p:nvSpPr>
-        <p:spPr>
-          <a:xfrm>
-            <a:off x="822960" y="1664208"/>
+          <p:cNvPr id="6" name="Text 4"/>
+          <p:cNvSpPr/>
+          <p:nvPr/>
+        </p:nvSpPr>
+        <p:spPr>
+          <a:xfrm>
+            <a:off x="822960" y="1828800"/>
             <a:ext cx="4846320" cy="274320"/>
           </a:xfrm>
           <a:prstGeom prst="rect">
@@ -4693,13 +4741,13 @@
       </p:sp>
       <p:sp>
         <p:nvSpPr>
-          <p:cNvPr id="6" name="Text 4"/>
-          <p:cNvSpPr/>
-          <p:nvPr/>
-        </p:nvSpPr>
-        <p:spPr>
-          <a:xfrm>
-            <a:off x="822960" y="1938528"/>
+          <p:cNvPr id="7" name="Text 5"/>
+          <p:cNvSpPr/>
+          <p:nvPr/>
+        </p:nvSpPr>
+        <p:spPr>
+          <a:xfrm>
+            <a:off x="822960" y="2103120"/>
             <a:ext cx="4846320" cy="457200"/>
           </a:xfrm>
           <a:prstGeom prst="rect">
@@ -4732,13 +4780,13 @@
       </p:sp>
       <p:sp>
         <p:nvSpPr>
-          <p:cNvPr id="7" name="Shape 5"/>
-          <p:cNvSpPr/>
-          <p:nvPr/>
-        </p:nvSpPr>
-        <p:spPr>
-          <a:xfrm>
-            <a:off x="548640" y="2578608"/>
+          <p:cNvPr id="8" name="Shape 6"/>
+          <p:cNvSpPr/>
+          <p:nvPr/>
+        </p:nvSpPr>
+        <p:spPr>
+          <a:xfrm>
+            <a:off x="548640" y="2743200"/>
             <a:ext cx="5394960" cy="896112"/>
           </a:xfrm>
           <a:prstGeom prst="roundRect">
@@ -4759,13 +4807,13 @@
       </p:sp>
       <p:sp>
         <p:nvSpPr>
-          <p:cNvPr id="8" name="Text 6"/>
-          <p:cNvSpPr/>
-          <p:nvPr/>
-        </p:nvSpPr>
-        <p:spPr>
-          <a:xfrm>
-            <a:off x="822960" y="2688336"/>
+          <p:cNvPr id="9" name="Text 7"/>
+          <p:cNvSpPr/>
+          <p:nvPr/>
+        </p:nvSpPr>
+        <p:spPr>
+          <a:xfrm>
+            <a:off x="822960" y="2852928"/>
             <a:ext cx="4846320" cy="274320"/>
           </a:xfrm>
           <a:prstGeom prst="rect">
@@ -4798,13 +4846,13 @@
       </p:sp>
       <p:sp>
         <p:nvSpPr>
-          <p:cNvPr id="9" name="Text 7"/>
-          <p:cNvSpPr/>
-          <p:nvPr/>
-        </p:nvSpPr>
-        <p:spPr>
-          <a:xfrm>
-            <a:off x="822960" y="2962656"/>
+          <p:cNvPr id="10" name="Text 8"/>
+          <p:cNvSpPr/>
+          <p:nvPr/>
+        </p:nvSpPr>
+        <p:spPr>
+          <a:xfrm>
+            <a:off x="822960" y="3127248"/>
             <a:ext cx="4846320" cy="457200"/>
           </a:xfrm>
           <a:prstGeom prst="rect">
@@ -4837,13 +4885,13 @@
       </p:sp>
       <p:sp>
         <p:nvSpPr>
-          <p:cNvPr id="10" name="Shape 8"/>
-          <p:cNvSpPr/>
-          <p:nvPr/>
-        </p:nvSpPr>
-        <p:spPr>
-          <a:xfrm>
-            <a:off x="548640" y="3602736"/>
+          <p:cNvPr id="11" name="Shape 9"/>
+          <p:cNvSpPr/>
+          <p:nvPr/>
+        </p:nvSpPr>
+        <p:spPr>
+          <a:xfrm>
+            <a:off x="548640" y="3767328"/>
             <a:ext cx="5394960" cy="896112"/>
           </a:xfrm>
           <a:prstGeom prst="roundRect">
@@ -4864,13 +4912,13 @@
       </p:sp>
       <p:sp>
         <p:nvSpPr>
-          <p:cNvPr id="11" name="Text 9"/>
-          <p:cNvSpPr/>
-          <p:nvPr/>
-        </p:nvSpPr>
-        <p:spPr>
-          <a:xfrm>
-            <a:off x="822960" y="3712464"/>
+          <p:cNvPr id="12" name="Text 10"/>
+          <p:cNvSpPr/>
+          <p:nvPr/>
+        </p:nvSpPr>
+        <p:spPr>
+          <a:xfrm>
+            <a:off x="822960" y="3877056"/>
             <a:ext cx="4846320" cy="274320"/>
           </a:xfrm>
           <a:prstGeom prst="rect">
@@ -4903,13 +4951,13 @@
       </p:sp>
       <p:sp>
         <p:nvSpPr>
-          <p:cNvPr id="12" name="Text 10"/>
-          <p:cNvSpPr/>
-          <p:nvPr/>
-        </p:nvSpPr>
-        <p:spPr>
-          <a:xfrm>
-            <a:off x="822960" y="3986784"/>
+          <p:cNvPr id="13" name="Text 11"/>
+          <p:cNvSpPr/>
+          <p:nvPr/>
+        </p:nvSpPr>
+        <p:spPr>
+          <a:xfrm>
+            <a:off x="822960" y="4151376"/>
             <a:ext cx="4846320" cy="457200"/>
           </a:xfrm>
           <a:prstGeom prst="rect">
@@ -4942,13 +4990,13 @@
       </p:sp>
       <p:sp>
         <p:nvSpPr>
-          <p:cNvPr id="13" name="Shape 11"/>
-          <p:cNvSpPr/>
-          <p:nvPr/>
-        </p:nvSpPr>
-        <p:spPr>
-          <a:xfrm>
-            <a:off x="6217920" y="1554480"/>
+          <p:cNvPr id="14" name="Shape 12"/>
+          <p:cNvSpPr/>
+          <p:nvPr/>
+        </p:nvSpPr>
+        <p:spPr>
+          <a:xfrm>
+            <a:off x="6217920" y="1719072"/>
             <a:ext cx="5394960" cy="3054096"/>
           </a:xfrm>
           <a:prstGeom prst="roundRect">
@@ -4969,13 +5017,13 @@
       </p:sp>
       <p:sp>
         <p:nvSpPr>
-          <p:cNvPr id="14" name="Text 12"/>
-          <p:cNvSpPr/>
-          <p:nvPr/>
-        </p:nvSpPr>
-        <p:spPr>
-          <a:xfrm>
-            <a:off x="6492240" y="1719072"/>
+          <p:cNvPr id="15" name="Text 13"/>
+          <p:cNvSpPr/>
+          <p:nvPr/>
+        </p:nvSpPr>
+        <p:spPr>
+          <a:xfrm>
+            <a:off x="6492240" y="1883664"/>
             <a:ext cx="4846320" cy="274320"/>
           </a:xfrm>
           <a:prstGeom prst="rect">
@@ -5008,13 +5056,13 @@
       </p:sp>
       <p:sp>
         <p:nvSpPr>
-          <p:cNvPr id="15" name="Text 13"/>
-          <p:cNvSpPr/>
-          <p:nvPr/>
-        </p:nvSpPr>
-        <p:spPr>
-          <a:xfrm>
-            <a:off x="6492240" y="2066544"/>
+          <p:cNvPr id="16" name="Text 14"/>
+          <p:cNvSpPr/>
+          <p:nvPr/>
+        </p:nvSpPr>
+        <p:spPr>
+          <a:xfrm>
+            <a:off x="6492240" y="2231136"/>
             <a:ext cx="658368" cy="274320"/>
           </a:xfrm>
           <a:prstGeom prst="rect">
@@ -5047,13 +5095,13 @@
       </p:sp>
       <p:sp>
         <p:nvSpPr>
-          <p:cNvPr id="16" name="Text 14"/>
-          <p:cNvSpPr/>
-          <p:nvPr/>
-        </p:nvSpPr>
-        <p:spPr>
-          <a:xfrm>
-            <a:off x="7269480" y="2093976"/>
+          <p:cNvPr id="17" name="Text 15"/>
+          <p:cNvSpPr/>
+          <p:nvPr/>
+        </p:nvSpPr>
+        <p:spPr>
+          <a:xfrm>
+            <a:off x="7269480" y="2258568"/>
             <a:ext cx="4114800" cy="365760"/>
           </a:xfrm>
           <a:prstGeom prst="rect">
@@ -5086,13 +5134,13 @@
       </p:sp>
       <p:sp>
         <p:nvSpPr>
-          <p:cNvPr id="17" name="Text 15"/>
-          <p:cNvSpPr/>
-          <p:nvPr/>
-        </p:nvSpPr>
-        <p:spPr>
-          <a:xfrm>
-            <a:off x="6492240" y="2450592"/>
+          <p:cNvPr id="18" name="Text 16"/>
+          <p:cNvSpPr/>
+          <p:nvPr/>
+        </p:nvSpPr>
+        <p:spPr>
+          <a:xfrm>
+            <a:off x="6492240" y="2615184"/>
             <a:ext cx="658368" cy="274320"/>
           </a:xfrm>
           <a:prstGeom prst="rect">
@@ -5125,13 +5173,13 @@
       </p:sp>
       <p:sp>
         <p:nvSpPr>
-          <p:cNvPr id="18" name="Text 16"/>
-          <p:cNvSpPr/>
-          <p:nvPr/>
-        </p:nvSpPr>
-        <p:spPr>
-          <a:xfrm>
-            <a:off x="7269480" y="2478024"/>
+          <p:cNvPr id="19" name="Text 17"/>
+          <p:cNvSpPr/>
+          <p:nvPr/>
+        </p:nvSpPr>
+        <p:spPr>
+          <a:xfrm>
+            <a:off x="7269480" y="2642616"/>
             <a:ext cx="4114800" cy="365760"/>
           </a:xfrm>
           <a:prstGeom prst="rect">
@@ -5164,13 +5212,13 @@
       </p:sp>
       <p:sp>
         <p:nvSpPr>
-          <p:cNvPr id="19" name="Text 17"/>
-          <p:cNvSpPr/>
-          <p:nvPr/>
-        </p:nvSpPr>
-        <p:spPr>
-          <a:xfrm>
-            <a:off x="6492240" y="2834640"/>
+          <p:cNvPr id="20" name="Text 18"/>
+          <p:cNvSpPr/>
+          <p:nvPr/>
+        </p:nvSpPr>
+        <p:spPr>
+          <a:xfrm>
+            <a:off x="6492240" y="2999232"/>
             <a:ext cx="658368" cy="274320"/>
           </a:xfrm>
           <a:prstGeom prst="rect">
@@ -5203,13 +5251,13 @@
       </p:sp>
       <p:sp>
         <p:nvSpPr>
-          <p:cNvPr id="20" name="Text 18"/>
-          <p:cNvSpPr/>
-          <p:nvPr/>
-        </p:nvSpPr>
-        <p:spPr>
-          <a:xfrm>
-            <a:off x="7269480" y="2862072"/>
+          <p:cNvPr id="21" name="Text 19"/>
+          <p:cNvSpPr/>
+          <p:nvPr/>
+        </p:nvSpPr>
+        <p:spPr>
+          <a:xfrm>
+            <a:off x="7269480" y="3026664"/>
             <a:ext cx="4114800" cy="365760"/>
           </a:xfrm>
           <a:prstGeom prst="rect">
@@ -5242,13 +5290,13 @@
       </p:sp>
       <p:sp>
         <p:nvSpPr>
-          <p:cNvPr id="21" name="Text 19"/>
-          <p:cNvSpPr/>
-          <p:nvPr/>
-        </p:nvSpPr>
-        <p:spPr>
-          <a:xfrm>
-            <a:off x="6492240" y="3218688"/>
+          <p:cNvPr id="22" name="Text 20"/>
+          <p:cNvSpPr/>
+          <p:nvPr/>
+        </p:nvSpPr>
+        <p:spPr>
+          <a:xfrm>
+            <a:off x="6492240" y="3383280"/>
             <a:ext cx="658368" cy="274320"/>
           </a:xfrm>
           <a:prstGeom prst="rect">
@@ -5281,13 +5329,13 @@
       </p:sp>
       <p:sp>
         <p:nvSpPr>
-          <p:cNvPr id="22" name="Text 20"/>
-          <p:cNvSpPr/>
-          <p:nvPr/>
-        </p:nvSpPr>
-        <p:spPr>
-          <a:xfrm>
-            <a:off x="7269480" y="3246120"/>
+          <p:cNvPr id="23" name="Text 21"/>
+          <p:cNvSpPr/>
+          <p:nvPr/>
+        </p:nvSpPr>
+        <p:spPr>
+          <a:xfrm>
+            <a:off x="7269480" y="3410712"/>
             <a:ext cx="4114800" cy="365760"/>
           </a:xfrm>
           <a:prstGeom prst="rect">
@@ -5320,13 +5368,13 @@
       </p:sp>
       <p:sp>
         <p:nvSpPr>
-          <p:cNvPr id="23" name="Text 21"/>
-          <p:cNvSpPr/>
-          <p:nvPr/>
-        </p:nvSpPr>
-        <p:spPr>
-          <a:xfrm>
-            <a:off x="6492240" y="3602736"/>
+          <p:cNvPr id="24" name="Text 22"/>
+          <p:cNvSpPr/>
+          <p:nvPr/>
+        </p:nvSpPr>
+        <p:spPr>
+          <a:xfrm>
+            <a:off x="6492240" y="3767328"/>
             <a:ext cx="658368" cy="274320"/>
           </a:xfrm>
           <a:prstGeom prst="rect">
@@ -5359,13 +5407,13 @@
       </p:sp>
       <p:sp>
         <p:nvSpPr>
-          <p:cNvPr id="24" name="Text 22"/>
-          <p:cNvSpPr/>
-          <p:nvPr/>
-        </p:nvSpPr>
-        <p:spPr>
-          <a:xfrm>
-            <a:off x="7269480" y="3630168"/>
+          <p:cNvPr id="25" name="Text 23"/>
+          <p:cNvSpPr/>
+          <p:nvPr/>
+        </p:nvSpPr>
+        <p:spPr>
+          <a:xfrm>
+            <a:off x="7269480" y="3794760"/>
             <a:ext cx="4114800" cy="365760"/>
           </a:xfrm>
           <a:prstGeom prst="rect">
@@ -5398,13 +5446,13 @@
       </p:sp>
       <p:sp>
         <p:nvSpPr>
-          <p:cNvPr id="25" name="Text 23"/>
-          <p:cNvSpPr/>
-          <p:nvPr/>
-        </p:nvSpPr>
-        <p:spPr>
-          <a:xfrm>
-            <a:off x="6492240" y="3986784"/>
+          <p:cNvPr id="26" name="Text 24"/>
+          <p:cNvSpPr/>
+          <p:nvPr/>
+        </p:nvSpPr>
+        <p:spPr>
+          <a:xfrm>
+            <a:off x="6492240" y="4151376"/>
             <a:ext cx="658368" cy="274320"/>
           </a:xfrm>
           <a:prstGeom prst="rect">
@@ -5437,13 +5485,13 @@
       </p:sp>
       <p:sp>
         <p:nvSpPr>
-          <p:cNvPr id="26" name="Text 24"/>
-          <p:cNvSpPr/>
-          <p:nvPr/>
-        </p:nvSpPr>
-        <p:spPr>
-          <a:xfrm>
-            <a:off x="7269480" y="4014216"/>
+          <p:cNvPr id="27" name="Text 25"/>
+          <p:cNvSpPr/>
+          <p:nvPr/>
+        </p:nvSpPr>
+        <p:spPr>
+          <a:xfrm>
+            <a:off x="7269480" y="4178808"/>
             <a:ext cx="4114800" cy="365760"/>
           </a:xfrm>
           <a:prstGeom prst="rect">
@@ -5476,13 +5524,13 @@
       </p:sp>
       <p:sp>
         <p:nvSpPr>
-          <p:cNvPr id="27" name="Text 25"/>
-          <p:cNvSpPr/>
-          <p:nvPr/>
-        </p:nvSpPr>
-        <p:spPr>
-          <a:xfrm>
-            <a:off x="6492240" y="4407408"/>
+          <p:cNvPr id="28" name="Text 26"/>
+          <p:cNvSpPr/>
+          <p:nvPr/>
+        </p:nvSpPr>
+        <p:spPr>
+          <a:xfrm>
+            <a:off x="6492240" y="4572000"/>
             <a:ext cx="4846320" cy="237744"/>
           </a:xfrm>
           <a:prstGeom prst="rect">
@@ -5515,13 +5563,13 @@
       </p:sp>
       <p:sp>
         <p:nvSpPr>
-          <p:cNvPr id="28" name="Shape 26"/>
-          <p:cNvSpPr/>
-          <p:nvPr/>
-        </p:nvSpPr>
-        <p:spPr>
-          <a:xfrm>
-            <a:off x="548640" y="4892040"/>
+          <p:cNvPr id="29" name="Shape 27"/>
+          <p:cNvSpPr/>
+          <p:nvPr/>
+        </p:nvSpPr>
+        <p:spPr>
+          <a:xfrm>
+            <a:off x="548640" y="5029200"/>
             <a:ext cx="11064240" cy="1143000"/>
           </a:xfrm>
           <a:prstGeom prst="roundRect">
@@ -5542,13 +5590,13 @@
       </p:sp>
       <p:sp>
         <p:nvSpPr>
-          <p:cNvPr id="29" name="Text 27"/>
-          <p:cNvSpPr/>
-          <p:nvPr/>
-        </p:nvSpPr>
-        <p:spPr>
-          <a:xfrm>
-            <a:off x="868680" y="5074920"/>
+          <p:cNvPr id="30" name="Text 28"/>
+          <p:cNvSpPr/>
+          <p:nvPr/>
+        </p:nvSpPr>
+        <p:spPr>
+          <a:xfrm>
+            <a:off x="868680" y="5212080"/>
             <a:ext cx="5486400" cy="320040"/>
           </a:xfrm>
           <a:prstGeom prst="rect">
@@ -5581,13 +5629,13 @@
       </p:sp>
       <p:sp>
         <p:nvSpPr>
-          <p:cNvPr id="30" name="Text 28"/>
-          <p:cNvSpPr/>
-          <p:nvPr/>
-        </p:nvSpPr>
-        <p:spPr>
-          <a:xfrm>
-            <a:off x="868680" y="5422392"/>
+          <p:cNvPr id="31" name="Text 29"/>
+          <p:cNvSpPr/>
+          <p:nvPr/>
+        </p:nvSpPr>
+        <p:spPr>
+          <a:xfrm>
+            <a:off x="868680" y="5559552"/>
             <a:ext cx="10424160" cy="502920"/>
           </a:xfrm>
           <a:prstGeom prst="rect">
@@ -6176,7 +6224,7 @@
                 <a:ea typeface="Cambria" pitchFamily="34" charset="-122"/>
                 <a:cs typeface="Cambria" pitchFamily="34" charset="-120"/>
               </a:rPr>
-              <a:t>I build the layer that tells a business what's actually happening</a:t>
+              <a:t>Three themes define my career</a:t>
             </a:r>
             <a:endParaRPr lang="en-US" sz="3400" dirty="0"/>
           </a:p>
@@ -6190,65 +6238,118 @@
         </p:nvSpPr>
         <p:spPr>
           <a:xfrm>
-            <a:off x="548640" y="1554480"/>
-            <a:ext cx="11064240" cy="640080"/>
-          </a:xfrm>
-          <a:prstGeom prst="rect">
-            <a:avLst/>
-          </a:prstGeom>
-          <a:noFill/>
-          <a:ln/>
-        </p:spPr>
-        <p:txBody>
-          <a:bodyPr wrap="square" lIns="0" tIns="0" rIns="0" bIns="0" rtlCol="0" anchor="ctr"/>
-          <a:lstStyle/>
-          <a:p>
-            <a:pPr indent="0" marL="0">
-              <a:buNone/>
-            </a:pPr>
-            <a:r>
-              <a:rPr lang="en-US" sz="1500" b="1" dirty="0">
-                <a:solidFill>
-                  <a:srgbClr val="5A5F6B"/>
-                </a:solidFill>
-                <a:latin typeface="Calibri" pitchFamily="34" charset="0"/>
-                <a:ea typeface="Calibri" pitchFamily="34" charset="-122"/>
-                <a:cs typeface="Calibri" pitchFamily="34" charset="-120"/>
-              </a:rPr>
-              <a:t>Data science </a:t>
-            </a:r>
-            <a:pPr indent="0" marL="0">
-              <a:buNone/>
-            </a:pPr>
-            <a:r>
-              <a:rPr lang="en-US" sz="1500" dirty="0">
-                <a:solidFill>
-                  <a:srgbClr val="5A5F6B"/>
-                </a:solidFill>
-                <a:latin typeface="Calibri" pitchFamily="34" charset="0"/>
-                <a:ea typeface="Calibri" pitchFamily="34" charset="-122"/>
-                <a:cs typeface="Calibri" pitchFamily="34" charset="-120"/>
-              </a:rPr>
-              <a:t>→ data platform → streaming infrastructure. Ten years shipping the measurement layer other teams run on — Mu Sigma, Bing Ads, Azure Event Hubs, Microsoft 365 Data Platform.</a:t>
-            </a:r>
-            <a:endParaRPr lang="en-US" sz="1500" dirty="0"/>
-          </a:p>
-        </p:txBody>
-      </p:sp>
-      <p:sp>
-        <p:nvSpPr>
-          <p:cNvPr id="5" name="Shape 3"/>
-          <p:cNvSpPr/>
-          <p:nvPr/>
-        </p:nvSpPr>
-        <p:spPr>
-          <a:xfrm>
-            <a:off x="548640" y="2377440"/>
-            <a:ext cx="11064240" cy="1143000"/>
+            <a:off x="548640" y="1572768"/>
+            <a:ext cx="11064240" cy="320040"/>
+          </a:xfrm>
+          <a:prstGeom prst="rect">
+            <a:avLst/>
+          </a:prstGeom>
+          <a:noFill/>
+          <a:ln/>
+        </p:spPr>
+        <p:txBody>
+          <a:bodyPr wrap="square" lIns="0" tIns="0" rIns="0" bIns="0" rtlCol="0" anchor="ctr"/>
+          <a:lstStyle/>
+          <a:p>
+            <a:pPr indent="0" marL="0">
+              <a:buNone/>
+            </a:pPr>
+            <a:r>
+              <a:rPr lang="en-US" sz="1600" b="1" dirty="0">
+                <a:solidFill>
+                  <a:srgbClr val="16181D"/>
+                </a:solidFill>
+                <a:latin typeface="Calibri" pitchFamily="34" charset="0"/>
+                <a:ea typeface="Calibri" pitchFamily="34" charset="-122"/>
+                <a:cs typeface="Calibri" pitchFamily="34" charset="-120"/>
+              </a:rPr>
+              <a:t>Senior Product Manager, Microsoft 365 Data Platform.</a:t>
+            </a:r>
+            <a:pPr indent="0" marL="0">
+              <a:buNone/>
+            </a:pPr>
+            <a:r>
+              <a:rPr lang="en-US" sz="1600" dirty="0">
+                <a:solidFill>
+                  <a:srgbClr val="16181D"/>
+                </a:solidFill>
+                <a:latin typeface="Calibri" pitchFamily="34" charset="0"/>
+                <a:ea typeface="Calibri" pitchFamily="34" charset="-122"/>
+                <a:cs typeface="Calibri" pitchFamily="34" charset="-120"/>
+              </a:rPr>
+              <a:t>  Ten years building data and ML platform products.</a:t>
+            </a:r>
+            <a:endParaRPr lang="en-US" sz="1600" dirty="0"/>
+          </a:p>
+        </p:txBody>
+      </p:sp>
+      <p:sp>
+        <p:nvSpPr>
+          <p:cNvPr id="5" name="Text 3"/>
+          <p:cNvSpPr/>
+          <p:nvPr/>
+        </p:nvSpPr>
+        <p:spPr>
+          <a:xfrm>
+            <a:off x="548640" y="2011680"/>
+            <a:ext cx="11064240" cy="320040"/>
+          </a:xfrm>
+          <a:prstGeom prst="rect">
+            <a:avLst/>
+          </a:prstGeom>
+          <a:noFill/>
+          <a:ln/>
+        </p:spPr>
+        <p:txBody>
+          <a:bodyPr wrap="square" lIns="0" tIns="0" rIns="0" bIns="0" rtlCol="0" anchor="ctr"/>
+          <a:lstStyle/>
+          <a:p>
+            <a:pPr indent="0" marL="0">
+              <a:buNone/>
+            </a:pPr>
+            <a:r>
+              <a:rPr lang="en-US" sz="1600" b="1" dirty="0">
+                <a:solidFill>
+                  <a:srgbClr val="16181D"/>
+                </a:solidFill>
+                <a:latin typeface="Calibri" pitchFamily="34" charset="0"/>
+                <a:ea typeface="Calibri" pitchFamily="34" charset="-122"/>
+                <a:cs typeface="Calibri" pitchFamily="34" charset="-120"/>
+              </a:rPr>
+              <a:t>Mu Sigma  →  Bing Ads  →  Azure Event Hubs  →  Microsoft 365.</a:t>
+            </a:r>
+            <a:pPr indent="0" marL="0">
+              <a:buNone/>
+            </a:pPr>
+            <a:r>
+              <a:rPr lang="en-US" sz="1600" dirty="0">
+                <a:solidFill>
+                  <a:srgbClr val="16181D"/>
+                </a:solidFill>
+                <a:latin typeface="Calibri" pitchFamily="34" charset="0"/>
+                <a:ea typeface="Calibri" pitchFamily="34" charset="-122"/>
+                <a:cs typeface="Calibri" pitchFamily="34" charset="-120"/>
+              </a:rPr>
+              <a:t>  The measurement layer other teams build on.</a:t>
+            </a:r>
+            <a:endParaRPr lang="en-US" sz="1600" dirty="0"/>
+          </a:p>
+        </p:txBody>
+      </p:sp>
+      <p:sp>
+        <p:nvSpPr>
+          <p:cNvPr id="6" name="Shape 4"/>
+          <p:cNvSpPr/>
+          <p:nvPr/>
+        </p:nvSpPr>
+        <p:spPr>
+          <a:xfrm>
+            <a:off x="548640" y="2788920"/>
+            <a:ext cx="3520440" cy="1691640"/>
           </a:xfrm>
           <a:prstGeom prst="roundRect">
             <a:avLst>
-              <a:gd name="adj" fmla="val 4800"/>
+              <a:gd name="adj" fmla="val 3243"/>
             </a:avLst>
           </a:prstGeom>
           <a:solidFill>
@@ -6264,155 +6365,80 @@
       </p:sp>
       <p:sp>
         <p:nvSpPr>
-          <p:cNvPr id="6" name="Shape 4"/>
-          <p:cNvSpPr/>
-          <p:nvPr/>
-        </p:nvSpPr>
-        <p:spPr>
-          <a:xfrm>
-            <a:off x="868680" y="2761488"/>
-            <a:ext cx="365760" cy="365760"/>
-          </a:xfrm>
-          <a:prstGeom prst="ellipse">
-            <a:avLst/>
-          </a:prstGeom>
-          <a:solidFill>
-            <a:srgbClr val="1BAF7A"/>
-          </a:solidFill>
-          <a:ln/>
-        </p:spPr>
-      </p:sp>
-      <p:sp>
-        <p:nvSpPr>
           <p:cNvPr id="7" name="Text 5"/>
           <p:cNvSpPr/>
           <p:nvPr/>
         </p:nvSpPr>
         <p:spPr>
           <a:xfrm>
-            <a:off x="868680" y="2761488"/>
-            <a:ext cx="365760" cy="365760"/>
-          </a:xfrm>
-          <a:prstGeom prst="rect">
-            <a:avLst/>
-          </a:prstGeom>
-          <a:noFill/>
-          <a:ln/>
-        </p:spPr>
-        <p:txBody>
-          <a:bodyPr wrap="square" lIns="0" tIns="0" rIns="0" bIns="0" rtlCol="0" anchor="ctr"/>
-          <a:lstStyle/>
-          <a:p>
-            <a:pPr algn="ctr" indent="0" marL="0">
-              <a:buNone/>
-            </a:pPr>
-            <a:r>
-              <a:rPr lang="en-US" sz="1400" b="1" dirty="0">
-                <a:solidFill>
-                  <a:srgbClr val="FFFFFF"/>
-                </a:solidFill>
-                <a:latin typeface="Calibri" pitchFamily="34" charset="0"/>
-                <a:ea typeface="Calibri" pitchFamily="34" charset="-122"/>
-                <a:cs typeface="Calibri" pitchFamily="34" charset="-120"/>
-              </a:rPr>
-              <a:t>1</a:t>
-            </a:r>
-            <a:endParaRPr lang="en-US" sz="1400" dirty="0"/>
-          </a:p>
-        </p:txBody>
-      </p:sp>
-      <p:sp>
-        <p:nvSpPr>
-          <p:cNvPr id="8" name="Text 6"/>
-          <p:cNvSpPr/>
-          <p:nvPr/>
-        </p:nvSpPr>
-        <p:spPr>
-          <a:xfrm>
-            <a:off x="1463040" y="2542032"/>
-            <a:ext cx="9875520" cy="365760"/>
-          </a:xfrm>
-          <a:prstGeom prst="rect">
-            <a:avLst/>
-          </a:prstGeom>
-          <a:noFill/>
-          <a:ln/>
-        </p:spPr>
-        <p:txBody>
-          <a:bodyPr wrap="square" lIns="0" tIns="0" rIns="0" bIns="0" rtlCol="0" anchor="ctr"/>
-          <a:lstStyle/>
-          <a:p>
-            <a:pPr indent="0" marL="0">
-              <a:buNone/>
-            </a:pPr>
-            <a:r>
-              <a:rPr lang="en-US" sz="1900" b="1" dirty="0">
-                <a:solidFill>
-                  <a:srgbClr val="16181D"/>
+            <a:off x="822960" y="3063240"/>
+            <a:ext cx="2971800" cy="1188720"/>
+          </a:xfrm>
+          <a:prstGeom prst="rect">
+            <a:avLst/>
+          </a:prstGeom>
+          <a:noFill/>
+          <a:ln/>
+        </p:spPr>
+        <p:txBody>
+          <a:bodyPr wrap="square" lIns="0" tIns="0" rIns="0" bIns="0" rtlCol="0" anchor="ctr"/>
+          <a:lstStyle/>
+          <a:p>
+            <a:pPr indent="0" marL="0">
+              <a:lnSpc>
+                <a:spcPts val="3200"/>
+              </a:lnSpc>
+              <a:buNone/>
+            </a:pPr>
+            <a:r>
+              <a:rPr lang="en-US" sz="2700" b="1" dirty="0">
+                <a:solidFill>
+                  <a:srgbClr val="1E2761"/>
                 </a:solidFill>
                 <a:latin typeface="Cambria" pitchFamily="34" charset="0"/>
                 <a:ea typeface="Cambria" pitchFamily="34" charset="-122"/>
                 <a:cs typeface="Cambria" pitchFamily="34" charset="-120"/>
               </a:rPr>
-              <a:t>You can't fix what you can't see</a:t>
-            </a:r>
-            <a:endParaRPr lang="en-US" sz="1900" dirty="0"/>
-          </a:p>
-        </p:txBody>
-      </p:sp>
-      <p:sp>
-        <p:nvSpPr>
-          <p:cNvPr id="9" name="Text 7"/>
-          <p:cNvSpPr/>
-          <p:nvPr/>
-        </p:nvSpPr>
-        <p:spPr>
-          <a:xfrm>
-            <a:off x="1463040" y="2944368"/>
-            <a:ext cx="9875520" cy="457200"/>
-          </a:xfrm>
-          <a:prstGeom prst="rect">
-            <a:avLst/>
-          </a:prstGeom>
-          <a:noFill/>
-          <a:ln/>
-        </p:spPr>
-        <p:txBody>
-          <a:bodyPr wrap="square" lIns="0" tIns="0" rIns="0" bIns="0" rtlCol="0" anchor="ctr"/>
-          <a:lstStyle/>
-          <a:p>
-            <a:pPr indent="0" marL="0">
-              <a:buNone/>
-            </a:pPr>
-            <a:r>
-              <a:rPr lang="en-US" sz="1300" dirty="0">
-                <a:solidFill>
-                  <a:srgbClr val="5A5F6B"/>
-                </a:solidFill>
-                <a:latin typeface="Calibri" pitchFamily="34" charset="0"/>
-                <a:ea typeface="Calibri" pitchFamily="34" charset="-122"/>
-                <a:cs typeface="Calibri" pitchFamily="34" charset="-120"/>
-              </a:rPr>
-              <a:t>Built unified telemetry across Azure Event Hubs and Service Bus — surfaced $200K/month in billing discrepancies nobody knew existed.</a:t>
-            </a:r>
-            <a:endParaRPr lang="en-US" sz="1300" dirty="0"/>
-          </a:p>
-        </p:txBody>
-      </p:sp>
-      <p:sp>
-        <p:nvSpPr>
-          <p:cNvPr id="10" name="Shape 8"/>
-          <p:cNvSpPr/>
-          <p:nvPr/>
-        </p:nvSpPr>
-        <p:spPr>
-          <a:xfrm>
-            <a:off x="548640" y="3703320"/>
-            <a:ext cx="11064240" cy="1143000"/>
+              <a:t>Customer</a:t>
+            </a:r>
+            <a:endParaRPr lang="en-US" sz="2700" dirty="0"/>
+          </a:p>
+          <a:p>
+            <a:pPr indent="0" marL="0">
+              <a:lnSpc>
+                <a:spcPts val="3200"/>
+              </a:lnSpc>
+              <a:buNone/>
+            </a:pPr>
+            <a:r>
+              <a:rPr lang="en-US" sz="2700" b="1" dirty="0">
+                <a:solidFill>
+                  <a:srgbClr val="1E2761"/>
+                </a:solidFill>
+                <a:latin typeface="Cambria" pitchFamily="34" charset="0"/>
+                <a:ea typeface="Cambria" pitchFamily="34" charset="-122"/>
+                <a:cs typeface="Cambria" pitchFamily="34" charset="-120"/>
+              </a:rPr>
+              <a:t>Centricity</a:t>
+            </a:r>
+            <a:endParaRPr lang="en-US" sz="2700" dirty="0"/>
+          </a:p>
+        </p:txBody>
+      </p:sp>
+      <p:sp>
+        <p:nvSpPr>
+          <p:cNvPr id="8" name="Shape 6"/>
+          <p:cNvSpPr/>
+          <p:nvPr/>
+        </p:nvSpPr>
+        <p:spPr>
+          <a:xfrm>
+            <a:off x="4270248" y="2788920"/>
+            <a:ext cx="3520440" cy="1691640"/>
           </a:xfrm>
           <a:prstGeom prst="roundRect">
             <a:avLst>
-              <a:gd name="adj" fmla="val 4800"/>
+              <a:gd name="adj" fmla="val 3243"/>
             </a:avLst>
           </a:prstGeom>
           <a:solidFill>
@@ -6428,159 +6454,84 @@
       </p:sp>
       <p:sp>
         <p:nvSpPr>
-          <p:cNvPr id="11" name="Shape 9"/>
-          <p:cNvSpPr/>
-          <p:nvPr/>
-        </p:nvSpPr>
-        <p:spPr>
-          <a:xfrm>
-            <a:off x="868680" y="4087368"/>
-            <a:ext cx="365760" cy="365760"/>
-          </a:xfrm>
-          <a:prstGeom prst="ellipse">
-            <a:avLst/>
-          </a:prstGeom>
-          <a:solidFill>
-            <a:srgbClr val="EB6834"/>
-          </a:solidFill>
-          <a:ln/>
-        </p:spPr>
-      </p:sp>
-      <p:sp>
-        <p:nvSpPr>
-          <p:cNvPr id="12" name="Text 10"/>
-          <p:cNvSpPr/>
-          <p:nvPr/>
-        </p:nvSpPr>
-        <p:spPr>
-          <a:xfrm>
-            <a:off x="868680" y="4087368"/>
-            <a:ext cx="365760" cy="365760"/>
-          </a:xfrm>
-          <a:prstGeom prst="rect">
-            <a:avLst/>
-          </a:prstGeom>
-          <a:noFill/>
-          <a:ln/>
-        </p:spPr>
-        <p:txBody>
-          <a:bodyPr wrap="square" lIns="0" tIns="0" rIns="0" bIns="0" rtlCol="0" anchor="ctr"/>
-          <a:lstStyle/>
-          <a:p>
-            <a:pPr algn="ctr" indent="0" marL="0">
-              <a:buNone/>
-            </a:pPr>
-            <a:r>
-              <a:rPr lang="en-US" sz="1400" b="1" dirty="0">
-                <a:solidFill>
-                  <a:srgbClr val="FFFFFF"/>
-                </a:solidFill>
-                <a:latin typeface="Calibri" pitchFamily="34" charset="0"/>
-                <a:ea typeface="Calibri" pitchFamily="34" charset="-122"/>
-                <a:cs typeface="Calibri" pitchFamily="34" charset="-120"/>
-              </a:rPr>
-              <a:t>2</a:t>
-            </a:r>
-            <a:endParaRPr lang="en-US" sz="1400" dirty="0"/>
-          </a:p>
-        </p:txBody>
-      </p:sp>
-      <p:sp>
-        <p:nvSpPr>
-          <p:cNvPr id="13" name="Text 11"/>
-          <p:cNvSpPr/>
-          <p:nvPr/>
-        </p:nvSpPr>
-        <p:spPr>
-          <a:xfrm>
-            <a:off x="1463040" y="3867912"/>
-            <a:ext cx="9875520" cy="365760"/>
-          </a:xfrm>
-          <a:prstGeom prst="rect">
-            <a:avLst/>
-          </a:prstGeom>
-          <a:noFill/>
-          <a:ln/>
-        </p:spPr>
-        <p:txBody>
-          <a:bodyPr wrap="square" lIns="0" tIns="0" rIns="0" bIns="0" rtlCol="0" anchor="ctr"/>
-          <a:lstStyle/>
-          <a:p>
-            <a:pPr indent="0" marL="0">
-              <a:buNone/>
-            </a:pPr>
-            <a:r>
-              <a:rPr lang="en-US" sz="1900" b="1" dirty="0">
-                <a:solidFill>
-                  <a:srgbClr val="16181D"/>
+          <p:cNvPr id="9" name="Text 7"/>
+          <p:cNvSpPr/>
+          <p:nvPr/>
+        </p:nvSpPr>
+        <p:spPr>
+          <a:xfrm>
+            <a:off x="4544568" y="3063240"/>
+            <a:ext cx="2971800" cy="1188720"/>
+          </a:xfrm>
+          <a:prstGeom prst="rect">
+            <a:avLst/>
+          </a:prstGeom>
+          <a:noFill/>
+          <a:ln/>
+        </p:spPr>
+        <p:txBody>
+          <a:bodyPr wrap="square" lIns="0" tIns="0" rIns="0" bIns="0" rtlCol="0" anchor="ctr"/>
+          <a:lstStyle/>
+          <a:p>
+            <a:pPr indent="0" marL="0">
+              <a:lnSpc>
+                <a:spcPts val="3200"/>
+              </a:lnSpc>
+              <a:buNone/>
+            </a:pPr>
+            <a:r>
+              <a:rPr lang="en-US" sz="2700" b="1" dirty="0">
+                <a:solidFill>
+                  <a:srgbClr val="1E2761"/>
                 </a:solidFill>
                 <a:latin typeface="Cambria" pitchFamily="34" charset="0"/>
                 <a:ea typeface="Cambria" pitchFamily="34" charset="-122"/>
                 <a:cs typeface="Cambria" pitchFamily="34" charset="-120"/>
               </a:rPr>
-              <a:t>Choosing the metric is a product decision</a:t>
-            </a:r>
-            <a:endParaRPr lang="en-US" sz="1900" dirty="0"/>
-          </a:p>
-        </p:txBody>
-      </p:sp>
-      <p:sp>
-        <p:nvSpPr>
-          <p:cNvPr id="14" name="Text 12"/>
-          <p:cNvSpPr/>
-          <p:nvPr/>
-        </p:nvSpPr>
-        <p:spPr>
-          <a:xfrm>
-            <a:off x="1463040" y="4270248"/>
-            <a:ext cx="9875520" cy="457200"/>
-          </a:xfrm>
-          <a:prstGeom prst="rect">
-            <a:avLst/>
-          </a:prstGeom>
-          <a:noFill/>
-          <a:ln/>
-        </p:spPr>
-        <p:txBody>
-          <a:bodyPr wrap="square" lIns="0" tIns="0" rIns="0" bIns="0" rtlCol="0" anchor="ctr"/>
-          <a:lstStyle/>
-          <a:p>
-            <a:pPr indent="0" marL="0">
-              <a:buNone/>
-            </a:pPr>
-            <a:r>
-              <a:rPr lang="en-US" sz="1300" dirty="0">
-                <a:solidFill>
-                  <a:srgbClr val="5A5F6B"/>
-                </a:solidFill>
-                <a:latin typeface="Calibri" pitchFamily="34" charset="0"/>
-                <a:ea typeface="Calibri" pitchFamily="34" charset="-122"/>
-                <a:cs typeface="Calibri" pitchFamily="34" charset="-120"/>
-              </a:rPr>
-              <a:t>Teams Queues App: prioritized the metrics supervisors needed over the ones that were easy to instrument. 25× adoption in six months.</a:t>
-            </a:r>
-            <a:endParaRPr lang="en-US" sz="1300" dirty="0"/>
-          </a:p>
-        </p:txBody>
-      </p:sp>
-      <p:sp>
-        <p:nvSpPr>
-          <p:cNvPr id="15" name="Shape 13"/>
-          <p:cNvSpPr/>
-          <p:nvPr/>
-        </p:nvSpPr>
-        <p:spPr>
-          <a:xfrm>
-            <a:off x="548640" y="5029200"/>
-            <a:ext cx="11064240" cy="1143000"/>
+              <a:t>Platform</a:t>
+            </a:r>
+            <a:endParaRPr lang="en-US" sz="2700" dirty="0"/>
+          </a:p>
+          <a:p>
+            <a:pPr indent="0" marL="0">
+              <a:lnSpc>
+                <a:spcPts val="3200"/>
+              </a:lnSpc>
+              <a:buNone/>
+            </a:pPr>
+            <a:r>
+              <a:rPr lang="en-US" sz="2700" b="1" dirty="0">
+                <a:solidFill>
+                  <a:srgbClr val="1E2761"/>
+                </a:solidFill>
+                <a:latin typeface="Cambria" pitchFamily="34" charset="0"/>
+                <a:ea typeface="Cambria" pitchFamily="34" charset="-122"/>
+                <a:cs typeface="Cambria" pitchFamily="34" charset="-120"/>
+              </a:rPr>
+              <a:t>Thinking</a:t>
+            </a:r>
+            <a:endParaRPr lang="en-US" sz="2700" dirty="0"/>
+          </a:p>
+        </p:txBody>
+      </p:sp>
+      <p:sp>
+        <p:nvSpPr>
+          <p:cNvPr id="10" name="Shape 8"/>
+          <p:cNvSpPr/>
+          <p:nvPr/>
+        </p:nvSpPr>
+        <p:spPr>
+          <a:xfrm>
+            <a:off x="7991856" y="2788920"/>
+            <a:ext cx="3520440" cy="1691640"/>
           </a:xfrm>
           <a:prstGeom prst="roundRect">
             <a:avLst>
-              <a:gd name="adj" fmla="val 4800"/>
+              <a:gd name="adj" fmla="val 3243"/>
             </a:avLst>
           </a:prstGeom>
           <a:solidFill>
-            <a:srgbClr val="F4F6FA"/>
+            <a:srgbClr val="FDF1EC"/>
           </a:solidFill>
           <a:ln w="6350">
             <a:solidFill>
@@ -6592,138 +6543,109 @@
       </p:sp>
       <p:sp>
         <p:nvSpPr>
-          <p:cNvPr id="16" name="Shape 14"/>
-          <p:cNvSpPr/>
-          <p:nvPr/>
-        </p:nvSpPr>
-        <p:spPr>
-          <a:xfrm>
-            <a:off x="868680" y="5413248"/>
-            <a:ext cx="365760" cy="365760"/>
-          </a:xfrm>
-          <a:prstGeom prst="ellipse">
-            <a:avLst/>
+          <p:cNvPr id="11" name="Text 9"/>
+          <p:cNvSpPr/>
+          <p:nvPr/>
+        </p:nvSpPr>
+        <p:spPr>
+          <a:xfrm>
+            <a:off x="8266176" y="3063240"/>
+            <a:ext cx="2971800" cy="1188720"/>
+          </a:xfrm>
+          <a:prstGeom prst="rect">
+            <a:avLst/>
+          </a:prstGeom>
+          <a:noFill/>
+          <a:ln/>
+        </p:spPr>
+        <p:txBody>
+          <a:bodyPr wrap="square" lIns="0" tIns="0" rIns="0" bIns="0" rtlCol="0" anchor="ctr"/>
+          <a:lstStyle/>
+          <a:p>
+            <a:pPr indent="0" marL="0">
+              <a:lnSpc>
+                <a:spcPts val="3200"/>
+              </a:lnSpc>
+              <a:buNone/>
+            </a:pPr>
+            <a:r>
+              <a:rPr lang="en-US" sz="2700" b="1" dirty="0">
+                <a:solidFill>
+                  <a:srgbClr val="EB6834"/>
+                </a:solidFill>
+                <a:latin typeface="Cambria" pitchFamily="34" charset="0"/>
+                <a:ea typeface="Cambria" pitchFamily="34" charset="-122"/>
+                <a:cs typeface="Cambria" pitchFamily="34" charset="-120"/>
+              </a:rPr>
+              <a:t>Learning</a:t>
+            </a:r>
+            <a:endParaRPr lang="en-US" sz="2700" dirty="0"/>
+          </a:p>
+        </p:txBody>
+      </p:sp>
+      <p:sp>
+        <p:nvSpPr>
+          <p:cNvPr id="12" name="Shape 10"/>
+          <p:cNvSpPr/>
+          <p:nvPr/>
+        </p:nvSpPr>
+        <p:spPr>
+          <a:xfrm>
+            <a:off x="548640" y="4892040"/>
+            <a:ext cx="11064240" cy="1234440"/>
+          </a:xfrm>
+          <a:prstGeom prst="roundRect">
+            <a:avLst>
+              <a:gd name="adj" fmla="val 4444"/>
+            </a:avLst>
           </a:prstGeom>
           <a:solidFill>
             <a:srgbClr val="1E2761"/>
           </a:solidFill>
-          <a:ln/>
-        </p:spPr>
-      </p:sp>
-      <p:sp>
-        <p:nvSpPr>
-          <p:cNvPr id="17" name="Text 15"/>
-          <p:cNvSpPr/>
-          <p:nvPr/>
-        </p:nvSpPr>
-        <p:spPr>
-          <a:xfrm>
-            <a:off x="868680" y="5413248"/>
-            <a:ext cx="365760" cy="365760"/>
-          </a:xfrm>
-          <a:prstGeom prst="rect">
-            <a:avLst/>
-          </a:prstGeom>
-          <a:noFill/>
-          <a:ln/>
-        </p:spPr>
-        <p:txBody>
-          <a:bodyPr wrap="square" lIns="0" tIns="0" rIns="0" bIns="0" rtlCol="0" anchor="ctr"/>
-          <a:lstStyle/>
-          <a:p>
-            <a:pPr algn="ctr" indent="0" marL="0">
-              <a:buNone/>
-            </a:pPr>
-            <a:r>
-              <a:rPr lang="en-US" sz="1400" b="1" dirty="0">
+          <a:ln w="6350">
+            <a:solidFill>
+              <a:srgbClr val="DEE1E8"/>
+            </a:solidFill>
+            <a:prstDash val="solid"/>
+          </a:ln>
+        </p:spPr>
+      </p:sp>
+      <p:sp>
+        <p:nvSpPr>
+          <p:cNvPr id="13" name="Text 11"/>
+          <p:cNvSpPr/>
+          <p:nvPr/>
+        </p:nvSpPr>
+        <p:spPr>
+          <a:xfrm>
+            <a:off x="914400" y="5138928"/>
+            <a:ext cx="10332720" cy="777240"/>
+          </a:xfrm>
+          <a:prstGeom prst="rect">
+            <a:avLst/>
+          </a:prstGeom>
+          <a:noFill/>
+          <a:ln/>
+        </p:spPr>
+        <p:txBody>
+          <a:bodyPr wrap="square" lIns="0" tIns="0" rIns="0" bIns="0" rtlCol="0" anchor="ctr"/>
+          <a:lstStyle/>
+          <a:p>
+            <a:pPr indent="0" marL="0">
+              <a:buNone/>
+            </a:pPr>
+            <a:r>
+              <a:rPr lang="en-US" sz="1900" i="1" dirty="0">
                 <a:solidFill>
                   <a:srgbClr val="FFFFFF"/>
-                </a:solidFill>
-                <a:latin typeface="Calibri" pitchFamily="34" charset="0"/>
-                <a:ea typeface="Calibri" pitchFamily="34" charset="-122"/>
-                <a:cs typeface="Calibri" pitchFamily="34" charset="-120"/>
-              </a:rPr>
-              <a:t>3</a:t>
-            </a:r>
-            <a:endParaRPr lang="en-US" sz="1400" dirty="0"/>
-          </a:p>
-        </p:txBody>
-      </p:sp>
-      <p:sp>
-        <p:nvSpPr>
-          <p:cNvPr id="18" name="Text 16"/>
-          <p:cNvSpPr/>
-          <p:nvPr/>
-        </p:nvSpPr>
-        <p:spPr>
-          <a:xfrm>
-            <a:off x="1463040" y="5193792"/>
-            <a:ext cx="9875520" cy="365760"/>
-          </a:xfrm>
-          <a:prstGeom prst="rect">
-            <a:avLst/>
-          </a:prstGeom>
-          <a:noFill/>
-          <a:ln/>
-        </p:spPr>
-        <p:txBody>
-          <a:bodyPr wrap="square" lIns="0" tIns="0" rIns="0" bIns="0" rtlCol="0" anchor="ctr"/>
-          <a:lstStyle/>
-          <a:p>
-            <a:pPr indent="0" marL="0">
-              <a:buNone/>
-            </a:pPr>
-            <a:r>
-              <a:rPr lang="en-US" sz="1900" b="1" dirty="0">
-                <a:solidFill>
-                  <a:srgbClr val="16181D"/>
                 </a:solidFill>
                 <a:latin typeface="Cambria" pitchFamily="34" charset="0"/>
                 <a:ea typeface="Cambria" pitchFamily="34" charset="-122"/>
                 <a:cs typeface="Cambria" pitchFamily="34" charset="-120"/>
               </a:rPr>
-              <a:t>Trust is a feature</a:t>
+              <a:t>“Building large platforms and data products that solve customers' problems, while I keep learning, is what I love — and that's what brings me here today.”</a:t>
             </a:r>
             <a:endParaRPr lang="en-US" sz="1900" dirty="0"/>
-          </a:p>
-        </p:txBody>
-      </p:sp>
-      <p:sp>
-        <p:nvSpPr>
-          <p:cNvPr id="19" name="Text 17"/>
-          <p:cNvSpPr/>
-          <p:nvPr/>
-        </p:nvSpPr>
-        <p:spPr>
-          <a:xfrm>
-            <a:off x="1463040" y="5596128"/>
-            <a:ext cx="9875520" cy="457200"/>
-          </a:xfrm>
-          <a:prstGeom prst="rect">
-            <a:avLst/>
-          </a:prstGeom>
-          <a:noFill/>
-          <a:ln/>
-        </p:spPr>
-        <p:txBody>
-          <a:bodyPr wrap="square" lIns="0" tIns="0" rIns="0" bIns="0" rtlCol="0" anchor="ctr"/>
-          <a:lstStyle/>
-          <a:p>
-            <a:pPr indent="0" marL="0">
-              <a:buNone/>
-            </a:pPr>
-            <a:r>
-              <a:rPr lang="en-US" sz="1300" dirty="0">
-                <a:solidFill>
-                  <a:srgbClr val="5A5F6B"/>
-                </a:solidFill>
-                <a:latin typeface="Calibri" pitchFamily="34" charset="0"/>
-                <a:ea typeface="Calibri" pitchFamily="34" charset="-122"/>
-                <a:cs typeface="Calibri" pitchFamily="34" charset="-120"/>
-              </a:rPr>
-              <a:t>Self-service governance across 200+ service owners — 100% EDPS compliance, 40 weeks of manual effort removed each year.</a:t>
-            </a:r>
-            <a:endParaRPr lang="en-US" sz="1300" dirty="0"/>
           </a:p>
         </p:txBody>
       </p:sp>
@@ -7717,7 +7639,7 @@
                 <a:ea typeface="Cambria" pitchFamily="34" charset="-122"/>
                 <a:cs typeface="Cambria" pitchFamily="34" charset="-120"/>
               </a:rPr>
-              <a:t>One score, and it's two things multiplied</a:t>
+              <a:t>VRR is occupancy</a:t>
             </a:r>
             <a:endParaRPr lang="en-US" sz="3400" dirty="0"/>
           </a:p>
@@ -7731,12 +7653,12 @@
         </p:nvSpPr>
         <p:spPr>
           <a:xfrm>
-            <a:off x="548640" y="1554480"/>
-            <a:ext cx="11064240" cy="914400"/>
+            <a:off x="548640" y="1298448"/>
+            <a:ext cx="11064240" cy="731520"/>
           </a:xfrm>
           <a:prstGeom prst="roundRect">
             <a:avLst>
-              <a:gd name="adj" fmla="val 6000"/>
+              <a:gd name="adj" fmla="val 7500"/>
             </a:avLst>
           </a:prstGeom>
           <a:solidFill>
@@ -7758,8 +7680,8 @@
         </p:nvSpPr>
         <p:spPr>
           <a:xfrm>
-            <a:off x="822960" y="1783080"/>
-            <a:ext cx="10515600" cy="457200"/>
+            <a:off x="822960" y="1481328"/>
+            <a:ext cx="10515600" cy="365760"/>
           </a:xfrm>
           <a:prstGeom prst="rect">
             <a:avLst/>
@@ -7775,7 +7697,7 @@
               <a:buNone/>
             </a:pPr>
             <a:r>
-              <a:rPr lang="en-US" sz="2400" b="1" dirty="0">
+              <a:rPr lang="en-US" sz="2100" b="1" dirty="0">
                 <a:solidFill>
                   <a:srgbClr val="FFFFFF"/>
                 </a:solidFill>
@@ -7789,7 +7711,7 @@
               <a:buNone/>
             </a:pPr>
             <a:r>
-              <a:rPr lang="en-US" sz="2000" dirty="0">
+              <a:rPr lang="en-US" sz="1800" dirty="0">
                 <a:solidFill>
                   <a:srgbClr val="CADCFC"/>
                 </a:solidFill>
@@ -7803,7 +7725,7 @@
               <a:buNone/>
             </a:pPr>
             <a:r>
-              <a:rPr lang="en-US" sz="2000" dirty="0">
+              <a:rPr lang="en-US" sz="1800" dirty="0">
                 <a:solidFill>
                   <a:srgbClr val="FFFFFF"/>
                 </a:solidFill>
@@ -7817,7 +7739,7 @@
               <a:buNone/>
             </a:pPr>
             <a:r>
-              <a:rPr lang="en-US" sz="2000" dirty="0">
+              <a:rPr lang="en-US" sz="1800" dirty="0">
                 <a:solidFill>
                   <a:srgbClr val="CADCFC"/>
                 </a:solidFill>
@@ -7831,7 +7753,7 @@
               <a:buNone/>
             </a:pPr>
             <a:r>
-              <a:rPr lang="en-US" sz="2000" dirty="0">
+              <a:rPr lang="en-US" sz="1800" dirty="0">
                 <a:solidFill>
                   <a:srgbClr val="FFFFFF"/>
                 </a:solidFill>
@@ -7841,7 +7763,7 @@
               </a:rPr>
               <a:t>% of their capacity they use</a:t>
             </a:r>
-            <a:endParaRPr lang="en-US" sz="2400" dirty="0"/>
+            <a:endParaRPr lang="en-US" sz="2100" dirty="0"/>
           </a:p>
         </p:txBody>
       </p:sp>
@@ -7853,8 +7775,136 @@
         </p:nvSpPr>
         <p:spPr>
           <a:xfrm>
-            <a:off x="548640" y="2697480"/>
-            <a:ext cx="11064240" cy="274320"/>
+            <a:off x="548640" y="2194560"/>
+            <a:ext cx="5852160" cy="274320"/>
+          </a:xfrm>
+          <a:prstGeom prst="rect">
+            <a:avLst/>
+          </a:prstGeom>
+          <a:noFill/>
+          <a:ln/>
+        </p:spPr>
+        <p:txBody>
+          <a:bodyPr wrap="square" lIns="0" tIns="0" rIns="0" bIns="0" rtlCol="0" anchor="ctr"/>
+          <a:lstStyle/>
+          <a:p>
+            <a:pPr indent="0" marL="0">
+              <a:buNone/>
+            </a:pPr>
+            <a:r>
+              <a:rPr lang="en-US" sz="1300" b="1" dirty="0">
+                <a:solidFill>
+                  <a:srgbClr val="16181D"/>
+                </a:solidFill>
+                <a:latin typeface="Calibri" pitchFamily="34" charset="0"/>
+                <a:ea typeface="Calibri" pitchFamily="34" charset="-122"/>
+                <a:cs typeface="Calibri" pitchFamily="34" charset="-120"/>
+              </a:rPr>
+              <a:t>Everything Acme could get from this SKU is a square. They occupy 26% of it.</a:t>
+            </a:r>
+            <a:endParaRPr lang="en-US" sz="1300" dirty="0"/>
+          </a:p>
+        </p:txBody>
+      </p:sp>
+      <p:sp>
+        <p:nvSpPr>
+          <p:cNvPr id="7" name="Shape 5"/>
+          <p:cNvSpPr/>
+          <p:nvPr/>
+        </p:nvSpPr>
+        <p:spPr>
+          <a:xfrm>
+            <a:off x="1051560" y="2578608"/>
+            <a:ext cx="4206240" cy="2286000"/>
+          </a:xfrm>
+          <a:prstGeom prst="rect">
+            <a:avLst/>
+          </a:prstGeom>
+          <a:solidFill>
+            <a:srgbClr val="F4F6FA"/>
+          </a:solidFill>
+          <a:ln w="12700">
+            <a:solidFill>
+              <a:srgbClr val="DEE1E8"/>
+            </a:solidFill>
+            <a:prstDash val="solid"/>
+          </a:ln>
+        </p:spPr>
+      </p:sp>
+      <p:sp>
+        <p:nvSpPr>
+          <p:cNvPr id="8" name="Shape 6"/>
+          <p:cNvSpPr/>
+          <p:nvPr/>
+        </p:nvSpPr>
+        <p:spPr>
+          <a:xfrm>
+            <a:off x="1051560" y="4114800"/>
+            <a:ext cx="3364992" cy="749808"/>
+          </a:xfrm>
+          <a:prstGeom prst="rect">
+            <a:avLst/>
+          </a:prstGeom>
+          <a:solidFill>
+            <a:srgbClr val="EB6834"/>
+          </a:solidFill>
+          <a:ln w="12700">
+            <a:solidFill>
+              <a:srgbClr val="FFFFFF"/>
+            </a:solidFill>
+            <a:prstDash val="solid"/>
+          </a:ln>
+        </p:spPr>
+      </p:sp>
+      <p:sp>
+        <p:nvSpPr>
+          <p:cNvPr id="9" name="Text 7"/>
+          <p:cNvSpPr/>
+          <p:nvPr/>
+        </p:nvSpPr>
+        <p:spPr>
+          <a:xfrm>
+            <a:off x="1051560" y="4251960"/>
+            <a:ext cx="3364992" cy="457200"/>
+          </a:xfrm>
+          <a:prstGeom prst="rect">
+            <a:avLst/>
+          </a:prstGeom>
+          <a:noFill/>
+          <a:ln/>
+        </p:spPr>
+        <p:txBody>
+          <a:bodyPr wrap="square" lIns="0" tIns="0" rIns="0" bIns="0" rtlCol="0" anchor="ctr"/>
+          <a:lstStyle/>
+          <a:p>
+            <a:pPr algn="ctr" indent="0" marL="0">
+              <a:buNone/>
+            </a:pPr>
+            <a:r>
+              <a:rPr lang="en-US" sz="2200" b="1" dirty="0">
+                <a:solidFill>
+                  <a:srgbClr val="FFFFFF"/>
+                </a:solidFill>
+                <a:latin typeface="Cambria" pitchFamily="34" charset="0"/>
+                <a:ea typeface="Cambria" pitchFamily="34" charset="-122"/>
+                <a:cs typeface="Cambria" pitchFamily="34" charset="-120"/>
+              </a:rPr>
+              <a:t>26%</a:t>
+            </a:r>
+            <a:endParaRPr lang="en-US" sz="2200" dirty="0"/>
+          </a:p>
+        </p:txBody>
+      </p:sp>
+      <p:sp>
+        <p:nvSpPr>
+          <p:cNvPr id="10" name="Text 8"/>
+          <p:cNvSpPr/>
+          <p:nvPr/>
+        </p:nvSpPr>
+        <p:spPr>
+          <a:xfrm>
+            <a:off x="1325880" y="2926080"/>
+            <a:ext cx="3657600" cy="640080"/>
           </a:xfrm>
           <a:prstGeom prst="rect">
             <a:avLst/>
@@ -7878,7 +7928,7 @@
                 <a:ea typeface="Calibri" pitchFamily="34" charset="-122"/>
                 <a:cs typeface="Calibri" pitchFamily="34" charset="-120"/>
               </a:rPr>
-              <a:t>Acme Financial  ·  $100k/year  ·  4 features  ·  10M credits  ·  measured monthly</a:t>
+              <a:t>unused headroom  ·  $74k a year on this one account</a:t>
             </a:r>
             <a:endParaRPr lang="en-US" sz="1300" dirty="0"/>
           </a:p>
@@ -7886,18 +7936,135 @@
       </p:sp>
       <p:sp>
         <p:nvSpPr>
-          <p:cNvPr id="7" name="Shape 5"/>
-          <p:cNvSpPr/>
-          <p:nvPr/>
-        </p:nvSpPr>
-        <p:spPr>
-          <a:xfrm>
-            <a:off x="548640" y="3108960"/>
-            <a:ext cx="7223760" cy="603504"/>
+          <p:cNvPr id="11" name="Text 9"/>
+          <p:cNvSpPr/>
+          <p:nvPr/>
+        </p:nvSpPr>
+        <p:spPr>
+          <a:xfrm rot="16200000">
+            <a:off x="228600" y="2578608"/>
+            <a:ext cx="685800" cy="2286000"/>
+          </a:xfrm>
+          <a:prstGeom prst="rect">
+            <a:avLst/>
+          </a:prstGeom>
+          <a:noFill/>
+          <a:ln/>
+        </p:spPr>
+        <p:txBody>
+          <a:bodyPr wrap="square" lIns="0" tIns="0" rIns="0" bIns="0" rtlCol="0" anchor="ctr"/>
+          <a:lstStyle/>
+          <a:p>
+            <a:pPr algn="ctr" indent="0" marL="0">
+              <a:buNone/>
+            </a:pPr>
+            <a:r>
+              <a:rPr lang="en-US" sz="1000" dirty="0">
+                <a:solidFill>
+                  <a:srgbClr val="5A5F6B"/>
+                </a:solidFill>
+                <a:latin typeface="Calibri" pitchFamily="34" charset="0"/>
+                <a:ea typeface="Calibri" pitchFamily="34" charset="-122"/>
+                <a:cs typeface="Calibri" pitchFamily="34" charset="-120"/>
+              </a:rPr>
+              <a:t>all features →</a:t>
+            </a:r>
+            <a:endParaRPr lang="en-US" sz="1000" dirty="0"/>
+          </a:p>
+        </p:txBody>
+      </p:sp>
+      <p:sp>
+        <p:nvSpPr>
+          <p:cNvPr id="12" name="Text 10"/>
+          <p:cNvSpPr/>
+          <p:nvPr/>
+        </p:nvSpPr>
+        <p:spPr>
+          <a:xfrm>
+            <a:off x="1051560" y="4919472"/>
+            <a:ext cx="4206240" cy="256032"/>
+          </a:xfrm>
+          <a:prstGeom prst="rect">
+            <a:avLst/>
+          </a:prstGeom>
+          <a:noFill/>
+          <a:ln/>
+        </p:spPr>
+        <p:txBody>
+          <a:bodyPr wrap="square" lIns="0" tIns="0" rIns="0" bIns="0" rtlCol="0" anchor="ctr"/>
+          <a:lstStyle/>
+          <a:p>
+            <a:pPr indent="0" marL="0">
+              <a:buNone/>
+            </a:pPr>
+            <a:r>
+              <a:rPr lang="en-US" sz="1000" dirty="0">
+                <a:solidFill>
+                  <a:srgbClr val="5A5F6B"/>
+                </a:solidFill>
+                <a:latin typeface="Calibri" pitchFamily="34" charset="0"/>
+                <a:ea typeface="Calibri" pitchFamily="34" charset="-122"/>
+                <a:cs typeface="Calibri" pitchFamily="34" charset="-120"/>
+              </a:rPr>
+              <a:t>all capacity →</a:t>
+            </a:r>
+            <a:endParaRPr lang="en-US" sz="1000" dirty="0"/>
+          </a:p>
+        </p:txBody>
+      </p:sp>
+      <p:sp>
+        <p:nvSpPr>
+          <p:cNvPr id="13" name="Text 11"/>
+          <p:cNvSpPr/>
+          <p:nvPr/>
+        </p:nvSpPr>
+        <p:spPr>
+          <a:xfrm>
+            <a:off x="5760720" y="2194560"/>
+            <a:ext cx="5852160" cy="274320"/>
+          </a:xfrm>
+          <a:prstGeom prst="rect">
+            <a:avLst/>
+          </a:prstGeom>
+          <a:noFill/>
+          <a:ln/>
+        </p:spPr>
+        <p:txBody>
+          <a:bodyPr wrap="square" lIns="0" tIns="0" rIns="0" bIns="0" rtlCol="0" anchor="ctr"/>
+          <a:lstStyle/>
+          <a:p>
+            <a:pPr indent="0" marL="0">
+              <a:buNone/>
+            </a:pPr>
+            <a:r>
+              <a:rPr lang="en-US" sz="1200" dirty="0">
+                <a:solidFill>
+                  <a:srgbClr val="5A5F6B"/>
+                </a:solidFill>
+                <a:latin typeface="Calibri" pitchFamily="34" charset="0"/>
+                <a:ea typeface="Calibri" pitchFamily="34" charset="-122"/>
+                <a:cs typeface="Calibri" pitchFamily="34" charset="-120"/>
+              </a:rPr>
+              <a:t>Acme Financial  ·  $100k/year  ·  4 features  ·  10M credits  ·  monthly</a:t>
+            </a:r>
+            <a:endParaRPr lang="en-US" sz="1200" dirty="0"/>
+          </a:p>
+        </p:txBody>
+      </p:sp>
+      <p:sp>
+        <p:nvSpPr>
+          <p:cNvPr id="14" name="Shape 12"/>
+          <p:cNvSpPr/>
+          <p:nvPr/>
+        </p:nvSpPr>
+        <p:spPr>
+          <a:xfrm>
+            <a:off x="5760720" y="2578608"/>
+            <a:ext cx="5852160" cy="566928"/>
           </a:xfrm>
           <a:prstGeom prst="roundRect">
             <a:avLst>
-              <a:gd name="adj" fmla="val 9091"/>
+              <a:gd name="adj" fmla="val 9677"/>
             </a:avLst>
           </a:prstGeom>
           <a:solidFill>
@@ -7913,30 +8080,30 @@
       </p:sp>
       <p:sp>
         <p:nvSpPr>
-          <p:cNvPr id="8" name="Text 6"/>
-          <p:cNvSpPr/>
-          <p:nvPr/>
-        </p:nvSpPr>
-        <p:spPr>
-          <a:xfrm>
-            <a:off x="868680" y="3236976"/>
-            <a:ext cx="3017520" cy="320040"/>
-          </a:xfrm>
-          <a:prstGeom prst="rect">
-            <a:avLst/>
-          </a:prstGeom>
-          <a:noFill/>
-          <a:ln/>
-        </p:spPr>
-        <p:txBody>
-          <a:bodyPr wrap="square" lIns="0" tIns="0" rIns="0" bIns="0" rtlCol="0" anchor="ctr"/>
-          <a:lstStyle/>
-          <a:p>
-            <a:pPr indent="0" marL="0">
-              <a:buNone/>
-            </a:pPr>
-            <a:r>
-              <a:rPr lang="en-US" sz="1600" dirty="0">
+          <p:cNvPr id="15" name="Text 13"/>
+          <p:cNvSpPr/>
+          <p:nvPr/>
+        </p:nvSpPr>
+        <p:spPr>
+          <a:xfrm>
+            <a:off x="6035040" y="2679192"/>
+            <a:ext cx="2468880" cy="292608"/>
+          </a:xfrm>
+          <a:prstGeom prst="rect">
+            <a:avLst/>
+          </a:prstGeom>
+          <a:noFill/>
+          <a:ln/>
+        </p:spPr>
+        <p:txBody>
+          <a:bodyPr wrap="square" lIns="0" tIns="0" rIns="0" bIns="0" rtlCol="0" anchor="ctr"/>
+          <a:lstStyle/>
+          <a:p>
+            <a:pPr indent="0" marL="0">
+              <a:buNone/>
+            </a:pPr>
+            <a:r>
+              <a:rPr lang="en-US" sz="1500" dirty="0">
                 <a:solidFill>
                   <a:srgbClr val="16181D"/>
                 </a:solidFill>
@@ -7944,38 +8111,38 @@
                 <a:ea typeface="Cambria" pitchFamily="34" charset="-122"/>
                 <a:cs typeface="Cambria" pitchFamily="34" charset="-120"/>
               </a:rPr>
-              <a:t>Features used</a:t>
-            </a:r>
-            <a:endParaRPr lang="en-US" sz="1600" dirty="0"/>
-          </a:p>
-        </p:txBody>
-      </p:sp>
-      <p:sp>
-        <p:nvSpPr>
-          <p:cNvPr id="9" name="Text 7"/>
-          <p:cNvSpPr/>
-          <p:nvPr/>
-        </p:nvSpPr>
-        <p:spPr>
-          <a:xfrm>
-            <a:off x="3931920" y="3273552"/>
-            <a:ext cx="2743200" cy="274320"/>
-          </a:xfrm>
-          <a:prstGeom prst="rect">
-            <a:avLst/>
-          </a:prstGeom>
-          <a:noFill/>
-          <a:ln/>
-        </p:spPr>
-        <p:txBody>
-          <a:bodyPr wrap="square" lIns="0" tIns="0" rIns="0" bIns="0" rtlCol="0" anchor="ctr"/>
-          <a:lstStyle/>
-          <a:p>
-            <a:pPr indent="0" marL="0">
-              <a:buNone/>
-            </a:pPr>
-            <a:r>
-              <a:rPr lang="en-US" sz="1200" dirty="0">
+              <a:t>Features they use</a:t>
+            </a:r>
+            <a:endParaRPr lang="en-US" sz="1500" dirty="0"/>
+          </a:p>
+        </p:txBody>
+      </p:sp>
+      <p:sp>
+        <p:nvSpPr>
+          <p:cNvPr id="16" name="Text 14"/>
+          <p:cNvSpPr/>
+          <p:nvPr/>
+        </p:nvSpPr>
+        <p:spPr>
+          <a:xfrm>
+            <a:off x="8549640" y="2715768"/>
+            <a:ext cx="2011680" cy="256032"/>
+          </a:xfrm>
+          <a:prstGeom prst="rect">
+            <a:avLst/>
+          </a:prstGeom>
+          <a:noFill/>
+          <a:ln/>
+        </p:spPr>
+        <p:txBody>
+          <a:bodyPr wrap="square" lIns="0" tIns="0" rIns="0" bIns="0" rtlCol="0" anchor="ctr"/>
+          <a:lstStyle/>
+          <a:p>
+            <a:pPr indent="0" marL="0">
+              <a:buNone/>
+            </a:pPr>
+            <a:r>
+              <a:rPr lang="en-US" sz="1100" dirty="0">
                 <a:solidFill>
                   <a:srgbClr val="5A5F6B"/>
                 </a:solidFill>
@@ -7985,20 +8152,20 @@
               </a:rPr>
               <a:t>1 of 4, value-weighted</a:t>
             </a:r>
-            <a:endParaRPr lang="en-US" sz="1200" dirty="0"/>
-          </a:p>
-        </p:txBody>
-      </p:sp>
-      <p:sp>
-        <p:nvSpPr>
-          <p:cNvPr id="10" name="Text 8"/>
-          <p:cNvSpPr/>
-          <p:nvPr/>
-        </p:nvSpPr>
-        <p:spPr>
-          <a:xfrm>
-            <a:off x="6583680" y="3182112"/>
-            <a:ext cx="1005840" cy="411480"/>
+            <a:endParaRPr lang="en-US" sz="1100" dirty="0"/>
+          </a:p>
+        </p:txBody>
+      </p:sp>
+      <p:sp>
+        <p:nvSpPr>
+          <p:cNvPr id="17" name="Text 15"/>
+          <p:cNvSpPr/>
+          <p:nvPr/>
+        </p:nvSpPr>
+        <p:spPr>
+          <a:xfrm>
+            <a:off x="10515600" y="2633472"/>
+            <a:ext cx="914400" cy="384048"/>
           </a:xfrm>
           <a:prstGeom prst="rect">
             <a:avLst/>
@@ -8014,7 +8181,7 @@
               <a:buNone/>
             </a:pPr>
             <a:r>
-              <a:rPr lang="en-US" sz="2200" b="1" dirty="0">
+              <a:rPr lang="en-US" sz="2000" b="1" dirty="0">
                 <a:solidFill>
                   <a:srgbClr val="16181D"/>
                 </a:solidFill>
@@ -8024,24 +8191,24 @@
               </a:rPr>
               <a:t>33%</a:t>
             </a:r>
-            <a:endParaRPr lang="en-US" sz="2200" dirty="0"/>
-          </a:p>
-        </p:txBody>
-      </p:sp>
-      <p:sp>
-        <p:nvSpPr>
-          <p:cNvPr id="11" name="Shape 9"/>
-          <p:cNvSpPr/>
-          <p:nvPr/>
-        </p:nvSpPr>
-        <p:spPr>
-          <a:xfrm>
-            <a:off x="548640" y="3822192"/>
-            <a:ext cx="7223760" cy="603504"/>
+            <a:endParaRPr lang="en-US" sz="2000" dirty="0"/>
+          </a:p>
+        </p:txBody>
+      </p:sp>
+      <p:sp>
+        <p:nvSpPr>
+          <p:cNvPr id="18" name="Shape 16"/>
+          <p:cNvSpPr/>
+          <p:nvPr/>
+        </p:nvSpPr>
+        <p:spPr>
+          <a:xfrm>
+            <a:off x="5760720" y="3236976"/>
+            <a:ext cx="5852160" cy="566928"/>
           </a:xfrm>
           <a:prstGeom prst="roundRect">
             <a:avLst>
-              <a:gd name="adj" fmla="val 9091"/>
+              <a:gd name="adj" fmla="val 9677"/>
             </a:avLst>
           </a:prstGeom>
           <a:solidFill>
@@ -8057,30 +8224,30 @@
       </p:sp>
       <p:sp>
         <p:nvSpPr>
-          <p:cNvPr id="12" name="Text 10"/>
-          <p:cNvSpPr/>
-          <p:nvPr/>
-        </p:nvSpPr>
-        <p:spPr>
-          <a:xfrm>
-            <a:off x="868680" y="3950208"/>
-            <a:ext cx="3017520" cy="320040"/>
-          </a:xfrm>
-          <a:prstGeom prst="rect">
-            <a:avLst/>
-          </a:prstGeom>
-          <a:noFill/>
-          <a:ln/>
-        </p:spPr>
-        <p:txBody>
-          <a:bodyPr wrap="square" lIns="0" tIns="0" rIns="0" bIns="0" rtlCol="0" anchor="ctr"/>
-          <a:lstStyle/>
-          <a:p>
-            <a:pPr indent="0" marL="0">
-              <a:buNone/>
-            </a:pPr>
-            <a:r>
-              <a:rPr lang="en-US" sz="1600" dirty="0">
+          <p:cNvPr id="19" name="Text 17"/>
+          <p:cNvSpPr/>
+          <p:nvPr/>
+        </p:nvSpPr>
+        <p:spPr>
+          <a:xfrm>
+            <a:off x="6035040" y="3337560"/>
+            <a:ext cx="2468880" cy="292608"/>
+          </a:xfrm>
+          <a:prstGeom prst="rect">
+            <a:avLst/>
+          </a:prstGeom>
+          <a:noFill/>
+          <a:ln/>
+        </p:spPr>
+        <p:txBody>
+          <a:bodyPr wrap="square" lIns="0" tIns="0" rIns="0" bIns="0" rtlCol="0" anchor="ctr"/>
+          <a:lstStyle/>
+          <a:p>
+            <a:pPr indent="0" marL="0">
+              <a:buNone/>
+            </a:pPr>
+            <a:r>
+              <a:rPr lang="en-US" sz="1500" dirty="0">
                 <a:solidFill>
                   <a:srgbClr val="16181D"/>
                 </a:solidFill>
@@ -8088,38 +8255,38 @@
                 <a:ea typeface="Cambria" pitchFamily="34" charset="-122"/>
                 <a:cs typeface="Cambria" pitchFamily="34" charset="-120"/>
               </a:rPr>
-              <a:t>Capacity used</a:t>
-            </a:r>
-            <a:endParaRPr lang="en-US" sz="1600" dirty="0"/>
-          </a:p>
-        </p:txBody>
-      </p:sp>
-      <p:sp>
-        <p:nvSpPr>
-          <p:cNvPr id="13" name="Text 11"/>
-          <p:cNvSpPr/>
-          <p:nvPr/>
-        </p:nvSpPr>
-        <p:spPr>
-          <a:xfrm>
-            <a:off x="3931920" y="3986784"/>
-            <a:ext cx="2743200" cy="274320"/>
-          </a:xfrm>
-          <a:prstGeom prst="rect">
-            <a:avLst/>
-          </a:prstGeom>
-          <a:noFill/>
-          <a:ln/>
-        </p:spPr>
-        <p:txBody>
-          <a:bodyPr wrap="square" lIns="0" tIns="0" rIns="0" bIns="0" rtlCol="0" anchor="ctr"/>
-          <a:lstStyle/>
-          <a:p>
-            <a:pPr indent="0" marL="0">
-              <a:buNone/>
-            </a:pPr>
-            <a:r>
-              <a:rPr lang="en-US" sz="1200" dirty="0">
+              <a:t>Capacity they use</a:t>
+            </a:r>
+            <a:endParaRPr lang="en-US" sz="1500" dirty="0"/>
+          </a:p>
+        </p:txBody>
+      </p:sp>
+      <p:sp>
+        <p:nvSpPr>
+          <p:cNvPr id="20" name="Text 18"/>
+          <p:cNvSpPr/>
+          <p:nvPr/>
+        </p:nvSpPr>
+        <p:spPr>
+          <a:xfrm>
+            <a:off x="8549640" y="3374136"/>
+            <a:ext cx="2011680" cy="256032"/>
+          </a:xfrm>
+          <a:prstGeom prst="rect">
+            <a:avLst/>
+          </a:prstGeom>
+          <a:noFill/>
+          <a:ln/>
+        </p:spPr>
+        <p:txBody>
+          <a:bodyPr wrap="square" lIns="0" tIns="0" rIns="0" bIns="0" rtlCol="0" anchor="ctr"/>
+          <a:lstStyle/>
+          <a:p>
+            <a:pPr indent="0" marL="0">
+              <a:buNone/>
+            </a:pPr>
+            <a:r>
+              <a:rPr lang="en-US" sz="1100" dirty="0">
                 <a:solidFill>
                   <a:srgbClr val="5A5F6B"/>
                 </a:solidFill>
@@ -8127,22 +8294,22 @@
                 <a:ea typeface="Calibri" pitchFamily="34" charset="-122"/>
                 <a:cs typeface="Calibri" pitchFamily="34" charset="-120"/>
               </a:rPr>
-              <a:t>667k of 833k credits this month</a:t>
-            </a:r>
-            <a:endParaRPr lang="en-US" sz="1200" dirty="0"/>
-          </a:p>
-        </p:txBody>
-      </p:sp>
-      <p:sp>
-        <p:nvSpPr>
-          <p:cNvPr id="14" name="Text 12"/>
-          <p:cNvSpPr/>
-          <p:nvPr/>
-        </p:nvSpPr>
-        <p:spPr>
-          <a:xfrm>
-            <a:off x="6583680" y="3895344"/>
-            <a:ext cx="1005840" cy="411480"/>
+              <a:t>667k of 833k credits</a:t>
+            </a:r>
+            <a:endParaRPr lang="en-US" sz="1100" dirty="0"/>
+          </a:p>
+        </p:txBody>
+      </p:sp>
+      <p:sp>
+        <p:nvSpPr>
+          <p:cNvPr id="21" name="Text 19"/>
+          <p:cNvSpPr/>
+          <p:nvPr/>
+        </p:nvSpPr>
+        <p:spPr>
+          <a:xfrm>
+            <a:off x="10515600" y="3291840"/>
+            <a:ext cx="914400" cy="384048"/>
           </a:xfrm>
           <a:prstGeom prst="rect">
             <a:avLst/>
@@ -8158,7 +8325,7 @@
               <a:buNone/>
             </a:pPr>
             <a:r>
-              <a:rPr lang="en-US" sz="2200" b="1" dirty="0">
+              <a:rPr lang="en-US" sz="2000" b="1" dirty="0">
                 <a:solidFill>
                   <a:srgbClr val="16181D"/>
                 </a:solidFill>
@@ -8168,24 +8335,24 @@
               </a:rPr>
               <a:t>80%</a:t>
             </a:r>
-            <a:endParaRPr lang="en-US" sz="2200" dirty="0"/>
-          </a:p>
-        </p:txBody>
-      </p:sp>
-      <p:sp>
-        <p:nvSpPr>
-          <p:cNvPr id="15" name="Shape 13"/>
-          <p:cNvSpPr/>
-          <p:nvPr/>
-        </p:nvSpPr>
-        <p:spPr>
-          <a:xfrm>
-            <a:off x="548640" y="4535424"/>
-            <a:ext cx="7223760" cy="603504"/>
+            <a:endParaRPr lang="en-US" sz="2000" dirty="0"/>
+          </a:p>
+        </p:txBody>
+      </p:sp>
+      <p:sp>
+        <p:nvSpPr>
+          <p:cNvPr id="22" name="Shape 20"/>
+          <p:cNvSpPr/>
+          <p:nvPr/>
+        </p:nvSpPr>
+        <p:spPr>
+          <a:xfrm>
+            <a:off x="5760720" y="3895344"/>
+            <a:ext cx="5852160" cy="566928"/>
           </a:xfrm>
           <a:prstGeom prst="roundRect">
             <a:avLst>
-              <a:gd name="adj" fmla="val 9091"/>
+              <a:gd name="adj" fmla="val 9677"/>
             </a:avLst>
           </a:prstGeom>
           <a:solidFill>
@@ -8201,30 +8368,30 @@
       </p:sp>
       <p:sp>
         <p:nvSpPr>
-          <p:cNvPr id="16" name="Text 14"/>
-          <p:cNvSpPr/>
-          <p:nvPr/>
-        </p:nvSpPr>
-        <p:spPr>
-          <a:xfrm>
-            <a:off x="868680" y="4663440"/>
-            <a:ext cx="3017520" cy="320040"/>
-          </a:xfrm>
-          <a:prstGeom prst="rect">
-            <a:avLst/>
-          </a:prstGeom>
-          <a:noFill/>
-          <a:ln/>
-        </p:spPr>
-        <p:txBody>
-          <a:bodyPr wrap="square" lIns="0" tIns="0" rIns="0" bIns="0" rtlCol="0" anchor="ctr"/>
-          <a:lstStyle/>
-          <a:p>
-            <a:pPr indent="0" marL="0">
-              <a:buNone/>
-            </a:pPr>
-            <a:r>
-              <a:rPr lang="en-US" sz="1600" b="1" dirty="0">
+          <p:cNvPr id="23" name="Text 21"/>
+          <p:cNvSpPr/>
+          <p:nvPr/>
+        </p:nvSpPr>
+        <p:spPr>
+          <a:xfrm>
+            <a:off x="6035040" y="3995928"/>
+            <a:ext cx="2468880" cy="292608"/>
+          </a:xfrm>
+          <a:prstGeom prst="rect">
+            <a:avLst/>
+          </a:prstGeom>
+          <a:noFill/>
+          <a:ln/>
+        </p:spPr>
+        <p:txBody>
+          <a:bodyPr wrap="square" lIns="0" tIns="0" rIns="0" bIns="0" rtlCol="0" anchor="ctr"/>
+          <a:lstStyle/>
+          <a:p>
+            <a:pPr indent="0" marL="0">
+              <a:buNone/>
+            </a:pPr>
+            <a:r>
+              <a:rPr lang="en-US" sz="1500" b="1" dirty="0">
                 <a:solidFill>
                   <a:srgbClr val="16181D"/>
                 </a:solidFill>
@@ -8232,38 +8399,38 @@
                 <a:ea typeface="Cambria" pitchFamily="34" charset="-122"/>
                 <a:cs typeface="Cambria" pitchFamily="34" charset="-120"/>
               </a:rPr>
-              <a:t>Value Realization Rate</a:t>
-            </a:r>
-            <a:endParaRPr lang="en-US" sz="1600" dirty="0"/>
-          </a:p>
-        </p:txBody>
-      </p:sp>
-      <p:sp>
-        <p:nvSpPr>
-          <p:cNvPr id="17" name="Text 15"/>
-          <p:cNvSpPr/>
-          <p:nvPr/>
-        </p:nvSpPr>
-        <p:spPr>
-          <a:xfrm>
-            <a:off x="3931920" y="4700016"/>
-            <a:ext cx="2743200" cy="274320"/>
-          </a:xfrm>
-          <a:prstGeom prst="rect">
-            <a:avLst/>
-          </a:prstGeom>
-          <a:noFill/>
-          <a:ln/>
-        </p:spPr>
-        <p:txBody>
-          <a:bodyPr wrap="square" lIns="0" tIns="0" rIns="0" bIns="0" rtlCol="0" anchor="ctr"/>
-          <a:lstStyle/>
-          <a:p>
-            <a:pPr indent="0" marL="0">
-              <a:buNone/>
-            </a:pPr>
-            <a:r>
-              <a:rPr lang="en-US" sz="1200" dirty="0">
+              <a:t>Share of the square</a:t>
+            </a:r>
+            <a:endParaRPr lang="en-US" sz="1500" dirty="0"/>
+          </a:p>
+        </p:txBody>
+      </p:sp>
+      <p:sp>
+        <p:nvSpPr>
+          <p:cNvPr id="24" name="Text 22"/>
+          <p:cNvSpPr/>
+          <p:nvPr/>
+        </p:nvSpPr>
+        <p:spPr>
+          <a:xfrm>
+            <a:off x="8549640" y="4032504"/>
+            <a:ext cx="2011680" cy="256032"/>
+          </a:xfrm>
+          <a:prstGeom prst="rect">
+            <a:avLst/>
+          </a:prstGeom>
+          <a:noFill/>
+          <a:ln/>
+        </p:spPr>
+        <p:txBody>
+          <a:bodyPr wrap="square" lIns="0" tIns="0" rIns="0" bIns="0" rtlCol="0" anchor="ctr"/>
+          <a:lstStyle/>
+          <a:p>
+            <a:pPr indent="0" marL="0">
+              <a:buNone/>
+            </a:pPr>
+            <a:r>
+              <a:rPr lang="en-US" sz="1100" dirty="0">
                 <a:solidFill>
                   <a:srgbClr val="5A5F6B"/>
                 </a:solidFill>
@@ -8273,20 +8440,20 @@
               </a:rPr>
               <a:t>33% × 80%</a:t>
             </a:r>
-            <a:endParaRPr lang="en-US" sz="1200" dirty="0"/>
-          </a:p>
-        </p:txBody>
-      </p:sp>
-      <p:sp>
-        <p:nvSpPr>
-          <p:cNvPr id="18" name="Text 16"/>
-          <p:cNvSpPr/>
-          <p:nvPr/>
-        </p:nvSpPr>
-        <p:spPr>
-          <a:xfrm>
-            <a:off x="6583680" y="4608576"/>
-            <a:ext cx="1005840" cy="411480"/>
+            <a:endParaRPr lang="en-US" sz="1100" dirty="0"/>
+          </a:p>
+        </p:txBody>
+      </p:sp>
+      <p:sp>
+        <p:nvSpPr>
+          <p:cNvPr id="25" name="Text 23"/>
+          <p:cNvSpPr/>
+          <p:nvPr/>
+        </p:nvSpPr>
+        <p:spPr>
+          <a:xfrm>
+            <a:off x="10515600" y="3950208"/>
+            <a:ext cx="914400" cy="384048"/>
           </a:xfrm>
           <a:prstGeom prst="rect">
             <a:avLst/>
@@ -8302,7 +8469,7 @@
               <a:buNone/>
             </a:pPr>
             <a:r>
-              <a:rPr lang="en-US" sz="2200" b="1" dirty="0">
+              <a:rPr lang="en-US" sz="2000" b="1" dirty="0">
                 <a:solidFill>
                   <a:srgbClr val="EB6834"/>
                 </a:solidFill>
@@ -8312,24 +8479,24 @@
               </a:rPr>
               <a:t>26%</a:t>
             </a:r>
-            <a:endParaRPr lang="en-US" sz="2200" dirty="0"/>
-          </a:p>
-        </p:txBody>
-      </p:sp>
-      <p:sp>
-        <p:nvSpPr>
-          <p:cNvPr id="19" name="Shape 17"/>
-          <p:cNvSpPr/>
-          <p:nvPr/>
-        </p:nvSpPr>
-        <p:spPr>
-          <a:xfrm>
-            <a:off x="8138160" y="3108960"/>
-            <a:ext cx="3474720" cy="1865376"/>
+            <a:endParaRPr lang="en-US" sz="2000" dirty="0"/>
+          </a:p>
+        </p:txBody>
+      </p:sp>
+      <p:sp>
+        <p:nvSpPr>
+          <p:cNvPr id="26" name="Shape 24"/>
+          <p:cNvSpPr/>
+          <p:nvPr/>
+        </p:nvSpPr>
+        <p:spPr>
+          <a:xfrm>
+            <a:off x="5760720" y="4590288"/>
+            <a:ext cx="5852160" cy="685800"/>
           </a:xfrm>
           <a:prstGeom prst="roundRect">
             <a:avLst>
-              <a:gd name="adj" fmla="val 2941"/>
+              <a:gd name="adj" fmla="val 8000"/>
             </a:avLst>
           </a:prstGeom>
           <a:solidFill>
@@ -8345,69 +8512,135 @@
       </p:sp>
       <p:sp>
         <p:nvSpPr>
-          <p:cNvPr id="20" name="Text 18"/>
-          <p:cNvSpPr/>
-          <p:nvPr/>
-        </p:nvSpPr>
-        <p:spPr>
-          <a:xfrm>
-            <a:off x="8412480" y="3291840"/>
-            <a:ext cx="2926080" cy="640080"/>
-          </a:xfrm>
-          <a:prstGeom prst="rect">
-            <a:avLst/>
-          </a:prstGeom>
-          <a:noFill/>
-          <a:ln/>
-        </p:spPr>
-        <p:txBody>
-          <a:bodyPr wrap="square" lIns="0" tIns="0" rIns="0" bIns="0" rtlCol="0" anchor="ctr"/>
-          <a:lstStyle/>
-          <a:p>
-            <a:pPr indent="0" marL="0">
-              <a:buNone/>
-            </a:pPr>
-            <a:r>
-              <a:rPr lang="en-US" sz="1700" b="1" dirty="0">
+          <p:cNvPr id="27" name="Text 25"/>
+          <p:cNvSpPr/>
+          <p:nvPr/>
+        </p:nvSpPr>
+        <p:spPr>
+          <a:xfrm>
+            <a:off x="6035040" y="4736592"/>
+            <a:ext cx="5394960" cy="457200"/>
+          </a:xfrm>
+          <a:prstGeom prst="rect">
+            <a:avLst/>
+          </a:prstGeom>
+          <a:noFill/>
+          <a:ln/>
+        </p:spPr>
+        <p:txBody>
+          <a:bodyPr wrap="square" lIns="0" tIns="0" rIns="0" bIns="0" rtlCol="0" anchor="ctr"/>
+          <a:lstStyle/>
+          <a:p>
+            <a:pPr indent="0" marL="0">
+              <a:buNone/>
+            </a:pPr>
+            <a:r>
+              <a:rPr lang="en-US" sz="1250" dirty="0">
                 <a:solidFill>
                   <a:srgbClr val="16181D"/>
                 </a:solidFill>
-                <a:latin typeface="Cambria" pitchFamily="34" charset="0"/>
-                <a:ea typeface="Cambria" pitchFamily="34" charset="-122"/>
-                <a:cs typeface="Cambria" pitchFamily="34" charset="-120"/>
-              </a:rPr>
-              <a:t>They bought a platform and deployed a point tool.</a:t>
-            </a:r>
-            <a:endParaRPr lang="en-US" sz="1700" dirty="0"/>
-          </a:p>
-        </p:txBody>
-      </p:sp>
-      <p:sp>
-        <p:nvSpPr>
-          <p:cNvPr id="21" name="Text 19"/>
-          <p:cNvSpPr/>
-          <p:nvPr/>
-        </p:nvSpPr>
-        <p:spPr>
-          <a:xfrm>
-            <a:off x="8412480" y="3977640"/>
-            <a:ext cx="2926080" cy="868680"/>
-          </a:xfrm>
-          <a:prstGeom prst="rect">
-            <a:avLst/>
-          </a:prstGeom>
-          <a:noFill/>
-          <a:ln/>
-        </p:spPr>
-        <p:txBody>
-          <a:bodyPr wrap="square" lIns="0" tIns="0" rIns="0" bIns="0" rtlCol="0" anchor="ctr"/>
-          <a:lstStyle/>
-          <a:p>
-            <a:pPr indent="0" marL="0">
-              <a:buNone/>
-            </a:pPr>
-            <a:r>
-              <a:rPr lang="en-US" sz="1200" dirty="0">
+                <a:latin typeface="Calibri" pitchFamily="34" charset="0"/>
+                <a:ea typeface="Calibri" pitchFamily="34" charset="-122"/>
+                <a:cs typeface="Calibri" pitchFamily="34" charset="-120"/>
+              </a:rPr>
+              <a:t>They bought a platform and deployed a point tool. Neither number catches that alone.</a:t>
+            </a:r>
+            <a:endParaRPr lang="en-US" sz="1250" dirty="0"/>
+          </a:p>
+        </p:txBody>
+      </p:sp>
+      <p:sp>
+        <p:nvSpPr>
+          <p:cNvPr id="28" name="Shape 26"/>
+          <p:cNvSpPr/>
+          <p:nvPr/>
+        </p:nvSpPr>
+        <p:spPr>
+          <a:xfrm>
+            <a:off x="548640" y="5440680"/>
+            <a:ext cx="5440680" cy="822960"/>
+          </a:xfrm>
+          <a:prstGeom prst="roundRect">
+            <a:avLst>
+              <a:gd name="adj" fmla="val 6667"/>
+            </a:avLst>
+          </a:prstGeom>
+          <a:solidFill>
+            <a:srgbClr val="EEF2FA"/>
+          </a:solidFill>
+          <a:ln w="6350">
+            <a:solidFill>
+              <a:srgbClr val="DEE1E8"/>
+            </a:solidFill>
+            <a:prstDash val="solid"/>
+          </a:ln>
+        </p:spPr>
+      </p:sp>
+      <p:sp>
+        <p:nvSpPr>
+          <p:cNvPr id="29" name="Text 27"/>
+          <p:cNvSpPr/>
+          <p:nvPr/>
+        </p:nvSpPr>
+        <p:spPr>
+          <a:xfrm>
+            <a:off x="822960" y="5559552"/>
+            <a:ext cx="4937760" cy="237744"/>
+          </a:xfrm>
+          <a:prstGeom prst="rect">
+            <a:avLst/>
+          </a:prstGeom>
+          <a:noFill/>
+          <a:ln/>
+        </p:spPr>
+        <p:txBody>
+          <a:bodyPr wrap="square" lIns="0" tIns="0" rIns="0" bIns="0" rtlCol="0" anchor="ctr"/>
+          <a:lstStyle/>
+          <a:p>
+            <a:pPr indent="0" marL="0">
+              <a:buNone/>
+            </a:pPr>
+            <a:r>
+              <a:rPr lang="en-US" sz="1250" b="1" dirty="0">
+                <a:solidFill>
+                  <a:srgbClr val="1E2761"/>
+                </a:solidFill>
+                <a:latin typeface="Calibri" pitchFamily="34" charset="0"/>
+                <a:ea typeface="Calibri" pitchFamily="34" charset="-122"/>
+                <a:cs typeface="Calibri" pitchFamily="34" charset="-120"/>
+              </a:rPr>
+              <a:t>100% is not the target.</a:t>
+            </a:r>
+            <a:endParaRPr lang="en-US" sz="1250" dirty="0"/>
+          </a:p>
+        </p:txBody>
+      </p:sp>
+      <p:sp>
+        <p:nvSpPr>
+          <p:cNvPr id="30" name="Text 28"/>
+          <p:cNvSpPr/>
+          <p:nvPr/>
+        </p:nvSpPr>
+        <p:spPr>
+          <a:xfrm>
+            <a:off x="822960" y="5797296"/>
+            <a:ext cx="4937760" cy="411480"/>
+          </a:xfrm>
+          <a:prstGeom prst="rect">
+            <a:avLst/>
+          </a:prstGeom>
+          <a:noFill/>
+          <a:ln/>
+        </p:spPr>
+        <p:txBody>
+          <a:bodyPr wrap="square" lIns="0" tIns="0" rIns="0" bIns="0" rtlCol="0" anchor="ctr"/>
+          <a:lstStyle/>
+          <a:p>
+            <a:pPr indent="0" marL="0">
+              <a:buNone/>
+            </a:pPr>
+            <a:r>
+              <a:rPr lang="en-US" sz="1100" dirty="0">
                 <a:solidFill>
                   <a:srgbClr val="5A5F6B"/>
                 </a:solidFill>
@@ -8415,38 +8648,104 @@
                 <a:ea typeface="Calibri" pitchFamily="34" charset="-122"/>
                 <a:cs typeface="Calibri" pitchFamily="34" charset="-120"/>
               </a:rPr>
-              <a:t>Neither number catches this alone. Consumption looks healthy. A feature checklist looks half-done.</a:t>
-            </a:r>
-            <a:endParaRPr lang="en-US" sz="1200" dirty="0"/>
-          </a:p>
-        </p:txBody>
-      </p:sp>
-      <p:sp>
-        <p:nvSpPr>
-          <p:cNvPr id="22" name="Text 20"/>
-          <p:cNvSpPr/>
-          <p:nvPr/>
-        </p:nvSpPr>
-        <p:spPr>
-          <a:xfrm>
-            <a:off x="548640" y="5257800"/>
-            <a:ext cx="11064240" cy="274320"/>
-          </a:xfrm>
-          <a:prstGeom prst="rect">
-            <a:avLst/>
-          </a:prstGeom>
-          <a:noFill/>
-          <a:ln/>
-        </p:spPr>
-        <p:txBody>
-          <a:bodyPr wrap="square" lIns="0" tIns="0" rIns="0" bIns="0" rtlCol="0" anchor="ctr"/>
-          <a:lstStyle/>
-          <a:p>
-            <a:pPr indent="0" marL="0">
-              <a:buNone/>
-            </a:pPr>
-            <a:r>
-              <a:rPr lang="en-US" sz="1200" dirty="0">
+              <a:t>An account at 100% has no headroom left — they are under-provisioned, not healthy. It is an upsell signal.</a:t>
+            </a:r>
+            <a:endParaRPr lang="en-US" sz="1100" dirty="0"/>
+          </a:p>
+        </p:txBody>
+      </p:sp>
+      <p:sp>
+        <p:nvSpPr>
+          <p:cNvPr id="31" name="Shape 29"/>
+          <p:cNvSpPr/>
+          <p:nvPr/>
+        </p:nvSpPr>
+        <p:spPr>
+          <a:xfrm>
+            <a:off x="6172200" y="5440680"/>
+            <a:ext cx="5440680" cy="822960"/>
+          </a:xfrm>
+          <a:prstGeom prst="roundRect">
+            <a:avLst>
+              <a:gd name="adj" fmla="val 6667"/>
+            </a:avLst>
+          </a:prstGeom>
+          <a:solidFill>
+            <a:srgbClr val="EEF2FA"/>
+          </a:solidFill>
+          <a:ln w="6350">
+            <a:solidFill>
+              <a:srgbClr val="DEE1E8"/>
+            </a:solidFill>
+            <a:prstDash val="solid"/>
+          </a:ln>
+        </p:spPr>
+      </p:sp>
+      <p:sp>
+        <p:nvSpPr>
+          <p:cNvPr id="32" name="Text 30"/>
+          <p:cNvSpPr/>
+          <p:nvPr/>
+        </p:nvSpPr>
+        <p:spPr>
+          <a:xfrm>
+            <a:off x="6446520" y="5559552"/>
+            <a:ext cx="4937760" cy="237744"/>
+          </a:xfrm>
+          <a:prstGeom prst="rect">
+            <a:avLst/>
+          </a:prstGeom>
+          <a:noFill/>
+          <a:ln/>
+        </p:spPr>
+        <p:txBody>
+          <a:bodyPr wrap="square" lIns="0" tIns="0" rIns="0" bIns="0" rtlCol="0" anchor="ctr"/>
+          <a:lstStyle/>
+          <a:p>
+            <a:pPr indent="0" marL="0">
+              <a:buNone/>
+            </a:pPr>
+            <a:r>
+              <a:rPr lang="en-US" sz="1250" b="1" dirty="0">
+                <a:solidFill>
+                  <a:srgbClr val="1E2761"/>
+                </a:solidFill>
+                <a:latin typeface="Calibri" pitchFamily="34" charset="0"/>
+                <a:ea typeface="Calibri" pitchFamily="34" charset="-122"/>
+                <a:cs typeface="Calibri" pitchFamily="34" charset="-120"/>
+              </a:rPr>
+              <a:t>It is not a grade.</a:t>
+            </a:r>
+            <a:endParaRPr lang="en-US" sz="1250" dirty="0"/>
+          </a:p>
+        </p:txBody>
+      </p:sp>
+      <p:sp>
+        <p:nvSpPr>
+          <p:cNvPr id="33" name="Text 31"/>
+          <p:cNvSpPr/>
+          <p:nvPr/>
+        </p:nvSpPr>
+        <p:spPr>
+          <a:xfrm>
+            <a:off x="6446520" y="5797296"/>
+            <a:ext cx="4937760" cy="411480"/>
+          </a:xfrm>
+          <a:prstGeom prst="rect">
+            <a:avLst/>
+          </a:prstGeom>
+          <a:noFill/>
+          <a:ln/>
+        </p:spPr>
+        <p:txBody>
+          <a:bodyPr wrap="square" lIns="0" tIns="0" rIns="0" bIns="0" rtlCol="0" anchor="ctr"/>
+          <a:lstStyle/>
+          <a:p>
+            <a:pPr indent="0" marL="0">
+              <a:buNone/>
+            </a:pPr>
+            <a:r>
+              <a:rPr lang="en-US" sz="1100" dirty="0">
                 <a:solidFill>
                   <a:srgbClr val="5A5F6B"/>
                 </a:solidFill>
@@ -8454,48 +8753,9 @@
                 <a:ea typeface="Calibri" pitchFamily="34" charset="-122"/>
                 <a:cs typeface="Calibri" pitchFamily="34" charset="-120"/>
               </a:rPr>
-              <a:t>Capped at 100% — over-consumption is an expansion signal, not a health signal.   ·   Features are value-weighted: Core 3×, Differentiator 2×, Adjacent 1×.</a:t>
-            </a:r>
-            <a:endParaRPr lang="en-US" sz="1200" dirty="0"/>
-          </a:p>
-        </p:txBody>
-      </p:sp>
-      <p:sp>
-        <p:nvSpPr>
-          <p:cNvPr id="23" name="Text 21"/>
-          <p:cNvSpPr/>
-          <p:nvPr/>
-        </p:nvSpPr>
-        <p:spPr>
-          <a:xfrm>
-            <a:off x="548640" y="5623560"/>
-            <a:ext cx="11064240" cy="365760"/>
-          </a:xfrm>
-          <a:prstGeom prst="rect">
-            <a:avLst/>
-          </a:prstGeom>
-          <a:noFill/>
-          <a:ln/>
-        </p:spPr>
-        <p:txBody>
-          <a:bodyPr wrap="square" lIns="0" tIns="0" rIns="0" bIns="0" rtlCol="0" anchor="ctr"/>
-          <a:lstStyle/>
-          <a:p>
-            <a:pPr indent="0" marL="0">
-              <a:buNone/>
-            </a:pPr>
-            <a:r>
-              <a:rPr lang="en-US" sz="1200" i="1" dirty="0">
-                <a:solidFill>
-                  <a:srgbClr val="5A5F6B"/>
-                </a:solidFill>
-                <a:latin typeface="Calibri" pitchFamily="34" charset="0"/>
-                <a:ea typeface="Calibri" pitchFamily="34" charset="-122"/>
-                <a:cs typeface="Calibri" pitchFamily="34" charset="-120"/>
-              </a:rPr>
-              <a:t>An earlier version used a geometric mean of three factors. More precise, unexplainable in a room — so explainability became a design requirement, not a preference.</a:t>
-            </a:r>
-            <a:endParaRPr lang="en-US" sz="1200" dirty="0"/>
+              <a:t>A low score is unclaimed value you have already sold. The empty part of the square is the opportunity.</a:t>
+            </a:r>
+            <a:endParaRPr lang="en-US" sz="1100" dirty="0"/>
           </a:p>
         </p:txBody>
       </p:sp>

</xml_diff>

<commit_message>
Expanded VRR on the first use in the deck, making it more readable
</commit_message>
<xml_diff>
--- a/docs/executive_deck.pptx
+++ b/docs/executive_deck.pptx
@@ -6746,7 +6746,7 @@
                 <a:ea typeface="Cambria" pitchFamily="34" charset="-122"/>
                 <a:cs typeface="Cambria" pitchFamily="34" charset="-120"/>
               </a:rPr>
-              <a:t>Three questions every software business answers precisely. And one it can't.</a:t>
+              <a:t>Three questions a software business answers precisely. The fourth is the hard one.</a:t>
             </a:r>
             <a:endParaRPr lang="en-US" sz="3400" dirty="0"/>
           </a:p>
@@ -7444,7 +7444,7 @@
                 <a:ea typeface="Calibri" pitchFamily="34" charset="-122"/>
                 <a:cs typeface="Calibri" pitchFamily="34" charset="-120"/>
               </a:rPr>
-              <a:t>Nothing tells you whether it mattered.</a:t>
+              <a:t>It doesn't tell you whether it mattered.</a:t>
             </a:r>
             <a:endParaRPr lang="en-US" sz="1200" dirty="0"/>
           </a:p>
@@ -7639,7 +7639,7 @@
                 <a:ea typeface="Cambria" pitchFamily="34" charset="-122"/>
                 <a:cs typeface="Cambria" pitchFamily="34" charset="-120"/>
               </a:rPr>
-              <a:t>VRR is occupancy</a:t>
+              <a:t>Value Realization Rate (VRR) is occupancy</a:t>
             </a:r>
             <a:endParaRPr lang="en-US" sz="3400" dirty="0"/>
           </a:p>

</xml_diff>

<commit_message>
Removing some characters and making some revisions on the deck
</commit_message>
<xml_diff>
--- a/docs/executive_deck.pptx
+++ b/docs/executive_deck.pptx
@@ -6185,7 +6185,7 @@
                 <a:ea typeface="Calibri" pitchFamily="34" charset="-122"/>
                 <a:cs typeface="Calibri" pitchFamily="34" charset="-120"/>
               </a:rPr>
-              <a:t>INTRODUCTION · 5 MIN</a:t>
+              <a:t>INTRODUCTION</a:t>
             </a:r>
             <a:endParaRPr lang="en-US" sz="1100" dirty="0"/>
           </a:p>
@@ -6707,7 +6707,7 @@
                 <a:ea typeface="Calibri" pitchFamily="34" charset="-122"/>
                 <a:cs typeface="Calibri" pitchFamily="34" charset="-120"/>
               </a:rPr>
-              <a:t>CONTEXT &amp; PROBLEM · 5 MIN</a:t>
+              <a:t>CONTEXT &amp; PROBLEM</a:t>
             </a:r>
             <a:endParaRPr lang="en-US" sz="1100" dirty="0"/>
           </a:p>
@@ -7600,7 +7600,7 @@
                 <a:ea typeface="Calibri" pitchFamily="34" charset="-122"/>
                 <a:cs typeface="Calibri" pitchFamily="34" charset="-120"/>
               </a:rPr>
-              <a:t>THE FRAMEWORK · 5 OF 15 MIN</a:t>
+              <a:t>THE FRAMEWORK</a:t>
             </a:r>
             <a:endParaRPr lang="en-US" sz="1100" dirty="0"/>
           </a:p>
@@ -8817,7 +8817,7 @@
                 <a:ea typeface="Calibri" pitchFamily="34" charset="-122"/>
                 <a:cs typeface="Calibri" pitchFamily="34" charset="-120"/>
               </a:rPr>
-              <a:t>THE FRAMEWORK · 10 OF 15 MIN</a:t>
+              <a:t>THE FRAMEWORK</a:t>
             </a:r>
             <a:endParaRPr lang="en-US" sz="1100" dirty="0"/>
           </a:p>
@@ -9744,7 +9744,7 @@
                 <a:ea typeface="Calibri" pitchFamily="34" charset="-122"/>
                 <a:cs typeface="Calibri" pitchFamily="34" charset="-120"/>
               </a:rPr>
-              <a:t>EVALUATION &amp; RESULTS · 4 OF 10 MIN</a:t>
+              <a:t>EVALUATION &amp; RESULTS</a:t>
             </a:r>
             <a:endParaRPr lang="en-US" sz="1100" dirty="0"/>
           </a:p>
@@ -10338,7 +10338,7 @@
                 <a:ea typeface="Cambria" pitchFamily="34" charset="-122"/>
                 <a:cs typeface="Cambria" pitchFamily="34" charset="-120"/>
               </a:rPr>
-              <a:t>Six minutes in the dashboard</a:t>
+              <a:t>Four moves in the dashboard</a:t>
             </a:r>
             <a:endParaRPr lang="en-US" sz="3400" dirty="0"/>
           </a:p>
@@ -11028,7 +11028,7 @@
                 <a:ea typeface="Calibri" pitchFamily="34" charset="-122"/>
                 <a:cs typeface="Calibri" pitchFamily="34" charset="-120"/>
               </a:rPr>
-              <a:t>EVALUATION &amp; RESULTS · CLOSING</a:t>
+              <a:t>EVALUATION &amp; RESULTS</a:t>
             </a:r>
             <a:endParaRPr lang="en-US" sz="1100" dirty="0"/>
           </a:p>

</xml_diff>

<commit_message>
Deck: Azure Messaging, relabel feature-depth tile, trim slide 11 header, simple slide mods for presentation
</commit_message>
<xml_diff>
--- a/docs/executive_deck.pptx
+++ b/docs/executive_deck.pptx
@@ -4,6 +4,9 @@
   <p:sldMasterIdLst>
     <p:sldMasterId id="2147483648" r:id="rId1"/>
   </p:sldMasterIdLst>
+  <p:notesMasterIdLst>
+    <p:notesMasterId r:id="rId16"/>
+  </p:notesMasterIdLst>
   <p:sldIdLst>
     <p:sldId id="256" r:id="rId2"/>
     <p:sldId id="257" r:id="rId3"/>
@@ -20,9 +23,6 @@
     <p:sldId id="268" r:id="rId14"/>
     <p:sldId id="269" r:id="rId15"/>
   </p:sldIdLst>
-  <p:notesMasterIdLst>
-    <p:notesMasterId r:id="rId16"/>
-  </p:notesMasterIdLst>
   <p:sldSz cx="12192000" cy="6858000"/>
   <p:notesSz cx="6858000" cy="12192000"/>
   <p:defaultTextStyle>
@@ -117,6 +117,11 @@
       </a:defRPr>
     </a:lvl9pPr>
   </p:defaultTextStyle>
+  <p:extLst>
+    <p:ext uri="{EFAFB233-063F-42B5-8137-9DF3F51BA10A}">
+      <p15:sldGuideLst xmlns:p15="http://schemas.microsoft.com/office/powerpoint/2012/main"/>
+    </p:ext>
+  </p:extLst>
 </p:presentation>
 </file>
 
@@ -142,234 +147,10 @@
           <a:chExt cx="0" cy="0"/>
         </a:xfrm>
       </p:grpSpPr>
-      <p:sp>
-        <p:nvSpPr>
-          <p:cNvPr id="2" name="Header Placeholder 1"/>
-          <p:cNvSpPr>
-            <a:spLocks noGrp="1"/>
-          </p:cNvSpPr>
-          <p:nvPr>
-            <p:ph type="hdr" sz="quarter"/>
-          </p:nvPr>
-        </p:nvSpPr>
-        <p:spPr>
-          <a:xfrm>
-            <a:off x="0" y="0"/>
-            <a:ext cx="2971800" cy="458788"/>
-          </a:xfrm>
-          <a:prstGeom prst="rect">
-            <a:avLst/>
-          </a:prstGeom>
-        </p:spPr>
-        <p:txBody>
-          <a:bodyPr vert="horz" lIns="91440" tIns="45720" rIns="91440" bIns="45720" rtlCol="0"/>
-          <a:lstStyle>
-            <a:lvl1pPr algn="l">
-              <a:defRPr sz="1200"/>
-            </a:lvl1pPr>
-          </a:lstStyle>
-          <a:p>
-            <a:endParaRPr lang="en-US"/>
-          </a:p>
-        </p:txBody>
-      </p:sp>
-      <p:sp>
-        <p:nvSpPr>
-          <p:cNvPr id="3" name="Date Placeholder 2"/>
-          <p:cNvSpPr>
-            <a:spLocks noGrp="1"/>
-          </p:cNvSpPr>
-          <p:nvPr>
-            <p:ph type="dt" idx="1"/>
-          </p:nvPr>
-        </p:nvSpPr>
-        <p:spPr>
-          <a:xfrm>
-            <a:off x="3884613" y="0"/>
-            <a:ext cx="2971800" cy="458788"/>
-          </a:xfrm>
-          <a:prstGeom prst="rect">
-            <a:avLst/>
-          </a:prstGeom>
-        </p:spPr>
-        <p:txBody>
-          <a:bodyPr vert="horz" lIns="91440" tIns="45720" rIns="91440" bIns="45720" rtlCol="0"/>
-          <a:lstStyle>
-            <a:lvl1pPr algn="r">
-              <a:defRPr sz="1200"/>
-            </a:lvl1pPr>
-          </a:lstStyle>
-          <a:p>
-            <a:fld id="{5282F153-3F37-0F45-9E97-73ACFA13230C}" type="datetimeFigureOut">
-              <a:rPr lang="en-US"/>
-              <a:t>7/23/19</a:t>
-            </a:fld>
-            <a:endParaRPr lang="en-US"/>
-          </a:p>
-        </p:txBody>
-      </p:sp>
-      <p:sp>
-        <p:nvSpPr>
-          <p:cNvPr id="4" name="Slide Image Placeholder 3"/>
-          <p:cNvSpPr>
-            <a:spLocks noGrp="1" noRot="1" noChangeAspect="1"/>
-          </p:cNvSpPr>
-          <p:nvPr>
-            <p:ph type="sldImg" idx="2"/>
-          </p:nvPr>
-        </p:nvSpPr>
-        <p:spPr>
-          <a:xfrm>
-            <a:off x="685800" y="1143000"/>
-            <a:ext cx="5486400" cy="3086100"/>
-          </a:xfrm>
-          <a:prstGeom prst="rect">
-            <a:avLst/>
-          </a:prstGeom>
-          <a:noFill/>
-          <a:ln w="12700">
-            <a:solidFill>
-              <a:prstClr val="black"/>
-            </a:solidFill>
-          </a:ln>
-        </p:spPr>
-        <p:txBody>
-          <a:bodyPr vert="horz" lIns="91440" tIns="45720" rIns="91440" bIns="45720" rtlCol="0" anchor="ctr"/>
-          <a:lstStyle/>
-          <a:p>
-            <a:endParaRPr lang="en-US"/>
-          </a:p>
-        </p:txBody>
-      </p:sp>
-      <p:sp>
-        <p:nvSpPr>
-          <p:cNvPr id="5" name="Notes Placeholder 4"/>
-          <p:cNvSpPr>
-            <a:spLocks noGrp="1"/>
-          </p:cNvSpPr>
-          <p:nvPr>
-            <p:ph type="body" sz="quarter" idx="3"/>
-          </p:nvPr>
-        </p:nvSpPr>
-        <p:spPr>
-          <a:xfrm>
-            <a:off x="685800" y="4400550"/>
-            <a:ext cx="5486400" cy="3600450"/>
-          </a:xfrm>
-          <a:prstGeom prst="rect">
-            <a:avLst/>
-          </a:prstGeom>
-        </p:spPr>
-        <p:txBody>
-          <a:bodyPr vert="horz" lIns="91440" tIns="45720" rIns="91440" bIns="45720" rtlCol="0"/>
-          <a:lstStyle/>
-          <a:p>
-            <a:pPr lvl="0"/>
-            <a:r>
-              <a:rPr lang="en-US"/>
-              <a:t>Click to edit Master text styles</a:t>
-            </a:r>
-          </a:p>
-          <a:p>
-            <a:pPr lvl="1"/>
-            <a:r>
-              <a:rPr lang="en-US"/>
-              <a:t>Second level</a:t>
-            </a:r>
-          </a:p>
-          <a:p>
-            <a:pPr lvl="2"/>
-            <a:r>
-              <a:rPr lang="en-US"/>
-              <a:t>Third level</a:t>
-            </a:r>
-          </a:p>
-          <a:p>
-            <a:pPr lvl="3"/>
-            <a:r>
-              <a:rPr lang="en-US"/>
-              <a:t>Fourth level</a:t>
-            </a:r>
-          </a:p>
-          <a:p>
-            <a:pPr lvl="4"/>
-            <a:r>
-              <a:rPr lang="en-US"/>
-              <a:t>Fifth level</a:t>
-            </a:r>
-          </a:p>
-        </p:txBody>
-      </p:sp>
-      <p:sp>
-        <p:nvSpPr>
-          <p:cNvPr id="6" name="Footer Placeholder 5"/>
-          <p:cNvSpPr>
-            <a:spLocks noGrp="1"/>
-          </p:cNvSpPr>
-          <p:nvPr>
-            <p:ph type="ftr" sz="quarter" idx="4"/>
-          </p:nvPr>
-        </p:nvSpPr>
-        <p:spPr>
-          <a:xfrm>
-            <a:off x="0" y="8685213"/>
-            <a:ext cx="2971800" cy="458787"/>
-          </a:xfrm>
-          <a:prstGeom prst="rect">
-            <a:avLst/>
-          </a:prstGeom>
-        </p:spPr>
-        <p:txBody>
-          <a:bodyPr vert="horz" lIns="91440" tIns="45720" rIns="91440" bIns="45720" rtlCol="0" anchor="b"/>
-          <a:lstStyle>
-            <a:lvl1pPr algn="l">
-              <a:defRPr sz="1200"/>
-            </a:lvl1pPr>
-          </a:lstStyle>
-          <a:p>
-            <a:endParaRPr lang="en-US"/>
-          </a:p>
-        </p:txBody>
-      </p:sp>
-      <p:sp>
-        <p:nvSpPr>
-          <p:cNvPr id="7" name="Slide Number Placeholder 6"/>
-          <p:cNvSpPr>
-            <a:spLocks noGrp="1"/>
-          </p:cNvSpPr>
-          <p:nvPr>
-            <p:ph type="sldNum" sz="quarter" idx="5"/>
-          </p:nvPr>
-        </p:nvSpPr>
-        <p:spPr>
-          <a:xfrm>
-            <a:off x="3884613" y="8685213"/>
-            <a:ext cx="2971800" cy="458787"/>
-          </a:xfrm>
-          <a:prstGeom prst="rect">
-            <a:avLst/>
-          </a:prstGeom>
-        </p:spPr>
-        <p:txBody>
-          <a:bodyPr vert="horz" lIns="91440" tIns="45720" rIns="91440" bIns="45720" rtlCol="0" anchor="b"/>
-          <a:lstStyle>
-            <a:lvl1pPr algn="r">
-              <a:defRPr sz="1200"/>
-            </a:lvl1pPr>
-          </a:lstStyle>
-          <a:p>
-            <a:fld id="{CE5E9CC1-C706-0F49-92D6-E571CC5EEA8F}" type="slidenum">
-              <a:rPr lang="en-US"/>
-              <a:t>‹#›</a:t>
-            </a:fld>
-            <a:endParaRPr lang="en-US"/>
-          </a:p>
-        </p:txBody>
-      </p:sp>
     </p:spTree>
     <p:extLst>
       <p:ext uri="{BB962C8B-B14F-4D97-AF65-F5344CB8AC3E}">
-        <p14:creationId xmlns:p14="http://schemas.microsoft.com/office/powerpoint/2010/main" val="1024086991"/>
+        <p14:creationId xmlns:p14="http://schemas.microsoft.com/office/powerpoint/2010/main" val="557436722"/>
       </p:ext>
     </p:extLst>
   </p:cSld>
@@ -512,14 +293,7 @@
         <p:txBody>
           <a:bodyPr/>
           <a:lstStyle/>
-          <a:p>
-            <a:r>
-              <a:rPr lang="en-US" dirty="0"/>
-              <a:t>60 minutes total. 5 intro, 5 context, 15 deep dive, 10 results, 25 Q&amp;A.
-Open by naming the question, not the framework: 'a customer pays you $100k a year — are they using it?'</a:t>
-            </a:r>
-            <a:endParaRPr lang="en-US" dirty="0"/>
-          </a:p>
+          <a:p/>
         </p:txBody>
       </p:sp>
       <p:sp>
@@ -601,15 +375,7 @@
         <p:txBody>
           <a:bodyPr/>
           <a:lstStyle/>
-          <a:p>
-            <a:r>
-              <a:rPr lang="en-US" dirty="0"/>
-              <a:t>The presentation ends on the ask. Stop here and hand over.
-If they want to keep going, offer the choice: 'I have four slides on how it was built and what went wrong — happy to walk them, or take questions and pull them up as needed.'
-Most panels will choose questions. Let them.</a:t>
-            </a:r>
-            <a:endParaRPr lang="en-US" dirty="0"/>
-          </a:p>
+          <a:p/>
         </p:txBody>
       </p:sp>
       <p:sp>
@@ -691,13 +457,7 @@
         <p:txBody>
           <a:bodyPr/>
           <a:lstStyle/>
-          <a:p>
-            <a:r>
-              <a:rPr lang="en-US" dirty="0"/>
-              <a:t>4 min. The DML story is the one to tell: I assumed nothing and tested the environment. That test is checked into the repo.</a:t>
-            </a:r>
-            <a:endParaRPr lang="en-US" dirty="0"/>
-          </a:p>
+          <a:p/>
         </p:txBody>
       </p:sp>
       <p:sp>
@@ -779,13 +539,7 @@
         <p:txBody>
           <a:bodyPr/>
           <a:lstStyle/>
-          <a:p>
-            <a:r>
-              <a:rPr lang="en-US" dirty="0"/>
-              <a:t>4 min. Their brief says edge-case handling is weighted heavily — this is the differentiation slide. Spend the time on the three that changed the framework, not the list.</a:t>
-            </a:r>
-            <a:endParaRPr lang="en-US" dirty="0"/>
-          </a:p>
+          <a:p/>
         </p:txBody>
       </p:sp>
       <p:sp>
@@ -867,13 +621,7 @@
         <p:txBody>
           <a:bodyPr/>
           <a:lstStyle/>
-          <a:p>
-            <a:r>
-              <a:rPr lang="en-US" dirty="0"/>
-              <a:t>4 min. Demo the Data Quality tab here — it is the least expected thing you will show and the most credible.</a:t>
-            </a:r>
-            <a:endParaRPr lang="en-US" dirty="0"/>
-          </a:p>
+          <a:p/>
         </p:txBody>
       </p:sp>
       <p:sp>
@@ -955,14 +703,7 @@
         <p:txBody>
           <a:bodyPr/>
           <a:lstStyle/>
-          <a:p>
-            <a:r>
-              <a:rPr lang="en-US" dirty="0"/>
-              <a:t>6 min, and do not rush it. Naming your own $1.9B error before anyone asks is worth more than any slide in this deck.
-Close on the third one — it hands you the ask.</a:t>
-            </a:r>
-            <a:endParaRPr lang="en-US" dirty="0"/>
-          </a:p>
+          <a:p/>
         </p:txBody>
       </p:sp>
       <p:sp>
@@ -1044,17 +785,7 @@
         <p:txBody>
           <a:bodyPr/>
           <a:lstStyle/>
-          <a:p>
-            <a:r>
-              <a:rPr lang="en-US" dirty="0"/>
-              <a:t>5 min — this is you talking, not the slide. Keep the slide bare and carry the proof in the script.
-CUSTOMER CENTRICITY — Teams Queues App. I prioritized the metrics call-centre supervisors actually needed over the ones that were easy to instrument. Wait times down 50%, 25x adoption in six months.
-PLATFORM THINKING — M365's first compliant streaming platform. 1M events per second, phishing response from two hours to under five minutes, model recall 60% to 90%. And a unified telemetry product across Event Hubs and Service Bus that surfaced $200K a month in billing discrepancies nobody knew existed. You cannot fix what you cannot see.
-LEARNING — this case study. BigQuery, dbt-style SQL and Streamlit, none of which I had used before last week. Say this one out loud: it makes Learning a demonstration rather than a claim, and it pre-empts 'you have never worked in BigQuery.'
-Close on the quote, then go straight into the four questions.</a:t>
-            </a:r>
-            <a:endParaRPr lang="en-US" dirty="0"/>
-          </a:p>
+          <a:p/>
         </p:txBody>
       </p:sp>
       <p:sp>
@@ -1136,15 +867,7 @@
         <p:txBody>
           <a:bodyPr/>
           <a:lstStyle/>
-          <a:p>
-            <a:r>
-              <a:rPr lang="en-US" dirty="0"/>
-              <a:t>5 min. Three easy yeses, then the miss. Pause after the fourth row.
-Do NOT give the precise dollar figure here — it means nothing before the metric is defined, and asserting it invites 'converted according to what?'. Open the loop instead and close it on the results slide.
-Then the honest line: 'I don't have your data, so I built a business that looks like yours — 100 customers, 500 SKUs, 2,000 features, 15 months — and tested the framework against it.'</a:t>
-            </a:r>
-            <a:endParaRPr lang="en-US" dirty="0"/>
-          </a:p>
+          <a:p/>
         </p:txBody>
       </p:sp>
       <p:sp>
@@ -1226,20 +949,7 @@
         <p:txBody>
           <a:bodyPr/>
           <a:lstStyle/>
-          <a:p>
-            <a:r>
-              <a:rPr lang="en-US" dirty="0"/>
-              <a:t>5 min — the most important slide in the deck. Do not rush it.
-Lead with the square, not the formula: 'Everything a customer could get from a SKU is a square — all their features on one side, all their capacity on the other. VRR is how much of that square they actually occupy.'
-Then the analogy if it helps: VRR is occupancy for software. A hotel with 100 rooms open 365 days sells a fraction of its room-nights. Nobody expects 100%, and a hotel running at 100% did not build enough rooms.
-ANSWER THESE BEFORE THEY ASK:
-· Is it utilization? No — utilization is one side of the square. VRR is the area.
-· Can it be 0? Yes. No features, or no consumption, collapses the area.
-· Can it be 100%? Yes — and that account is out of room. It is an upsell signal, not a win.
-· Do NOT say 'typical range is 20-50%' as though the metric imposes it. What you observe is that enterprise customers buy broad and deploy narrow. The observation IS the finding.</a:t>
-            </a:r>
-            <a:endParaRPr lang="en-US" dirty="0"/>
-          </a:p>
+          <a:p/>
         </p:txBody>
       </p:sp>
       <p:sp>
@@ -1321,18 +1031,7 @@
         <p:txBody>
           <a:bodyPr/>
           <a:lstStyle/>
-          <a:p>
-            <a:r>
-              <a:rPr lang="en-US" dirty="0"/>
-              <a:t>5 min. THE centerpiece. Walk the four boxes, naming the owner each time:
-· Bottom-left, not started — rescue, CS leadership
-· Bottom-right, running hot on one thing — they'll hit the cap and renegotiate on price. Sales + Product
-· Top-left, set up never scaled — enablement, CSM
-· Top-right, realizing value — expansion, Sales
-If asked why a box is thin: this book is bimodal — accounts are either broadly working or completely dead. Move the slider live to show it.</a:t>
-            </a:r>
-            <a:endParaRPr lang="en-US" dirty="0"/>
-          </a:p>
+          <a:p/>
         </p:txBody>
       </p:sp>
       <p:sp>
@@ -1414,15 +1113,7 @@
         <p:txBody>
           <a:bodyPr/>
           <a:lstStyle/>
-          <a:p>
-            <a:r>
-              <a:rPr lang="en-US" dirty="0"/>
-              <a:t>5 min. Lead with 4%. Let it land before explaining. THEN close the loop you opened on slide 3 with the $13.2M — by now it is earned rather than asserted.
-The reframe: a spike at one feature is not a hundred customer problems — it is one packaging or onboarding problem, fixable once across every account on that SKU. That makes it a Product decision, not a CSM one.
-Precision: these are customer–SKU relationships, not customers. Say it that way.</a:t>
-            </a:r>
-            <a:endParaRPr lang="en-US" dirty="0"/>
-          </a:p>
+          <a:p/>
         </p:txBody>
       </p:sp>
       <p:sp>
@@ -1504,16 +1195,7 @@
         <p:txBody>
           <a:bodyPr/>
           <a:lstStyle/>
-          <a:p>
-            <a:r>
-              <a:rPr lang="en-US" dirty="0"/>
-              <a:t>6 min. Open the browser tab BEFORE the session starts — never launch it live.
-Share the browser window only, not the desktop.
-If anything fails: stay on this slide, talk through the four moves, and point at the screenshots already in this deck — slides 5 and 6 are both live captures. Do not debug in front of the panel.
-Pick your drill-down account in advance and know its numbers cold.</a:t>
-            </a:r>
-            <a:endParaRPr lang="en-US" dirty="0"/>
-          </a:p>
+          <a:p/>
         </p:txBody>
       </p:sp>
       <p:sp>
@@ -1595,14 +1277,7 @@
         <p:txBody>
           <a:bodyPr/>
           <a:lstStyle/>
-          <a:p>
-            <a:r>
-              <a:rPr lang="en-US" dirty="0"/>
-              <a:t>5 min. The altitude idea: the questions never change, only the resolution.
-On the owner view — name it, don't sell it. 'Eventually this supports a compensation conversation. That is not today's ask, and I would want a year of history before attaching it to pay.'</a:t>
-            </a:r>
-            <a:endParaRPr lang="en-US" dirty="0"/>
-          </a:p>
+          <a:p/>
         </p:txBody>
       </p:sp>
       <p:sp>
@@ -1684,14 +1359,7 @@
         <p:txBody>
           <a:bodyPr/>
           <a:lstStyle/>
-          <a:p>
-            <a:r>
-              <a:rPr lang="en-US" dirty="0"/>
-              <a:t>2 min. This is the END of the presentation — state the ask, stop talking, let them respond.
-If pushed on comp: 'I'd want a year of history before attaching this to anyone's pay. Today I'm asking for agreement on the measurement.'</a:t>
-            </a:r>
-            <a:endParaRPr lang="en-US" dirty="0"/>
-          </a:p>
+          <a:p/>
         </p:txBody>
       </p:sp>
       <p:sp>
@@ -1763,6 +1431,11 @@
 <file path=ppt/slideMasters/slideMaster1.xml><?xml version="1.0" encoding="utf-8"?>
 <p:sldMaster xmlns:a="http://schemas.openxmlformats.org/drawingml/2006/main" xmlns:r="http://schemas.openxmlformats.org/officeDocument/2006/relationships" xmlns:p="http://schemas.openxmlformats.org/presentationml/2006/main">
   <p:cSld>
+    <p:bg>
+      <p:bgRef idx="1001">
+        <a:schemeClr val="bg1"/>
+      </p:bgRef>
+    </p:bg>
     <p:spTree>
       <p:nvGrpSpPr>
         <p:cNvPr id="1" name=""/>
@@ -2045,6 +1718,7 @@
         <a:solidFill>
           <a:srgbClr val="1E2761"/>
         </a:solidFill>
+        <a:effectLst/>
       </p:bgPr>
     </p:bg>
     <p:spTree>
@@ -2082,7 +1756,7 @@
           <a:bodyPr wrap="square" lIns="0" tIns="0" rIns="0" bIns="0" rtlCol="0" anchor="ctr"/>
           <a:lstStyle/>
           <a:p>
-            <a:pPr indent="0" marL="0">
+            <a:pPr marL="0" indent="0">
               <a:lnSpc>
                 <a:spcPts val="5200"/>
               </a:lnSpc>
@@ -2102,7 +1776,7 @@
             <a:endParaRPr lang="en-US" sz="4600" dirty="0"/>
           </a:p>
           <a:p>
-            <a:pPr indent="0" marL="0">
+            <a:pPr marL="0" indent="0">
               <a:lnSpc>
                 <a:spcPts val="5200"/>
               </a:lnSpc>
@@ -2144,7 +1818,7 @@
           <a:bodyPr wrap="square" lIns="0" tIns="0" rIns="0" bIns="0" rtlCol="0" anchor="ctr"/>
           <a:lstStyle/>
           <a:p>
-            <a:pPr indent="0" marL="0">
+            <a:pPr marL="0" indent="0">
               <a:buNone/>
             </a:pPr>
             <a:r>
@@ -2161,7 +1835,7 @@
             <a:endParaRPr lang="en-US" sz="1800" dirty="0"/>
           </a:p>
           <a:p>
-            <a:pPr indent="0" marL="0">
+            <a:pPr marL="0" indent="0">
               <a:buNone/>
             </a:pPr>
             <a:r>
@@ -2200,7 +1874,7 @@
           <a:bodyPr wrap="square" lIns="0" tIns="0" rIns="0" bIns="0" rtlCol="0" anchor="ctr"/>
           <a:lstStyle/>
           <a:p>
-            <a:pPr indent="0" marL="0">
+            <a:pPr marL="0" indent="0">
               <a:buNone/>
             </a:pPr>
             <a:r>
@@ -2234,6 +1908,7 @@
         <a:solidFill>
           <a:srgbClr val="16181D"/>
         </a:solidFill>
+        <a:effectLst/>
       </p:bgPr>
     </p:bg>
     <p:spTree>
@@ -2271,11 +1946,11 @@
           <a:bodyPr wrap="square" lIns="0" tIns="0" rIns="0" bIns="0" rtlCol="0" anchor="ctr"/>
           <a:lstStyle/>
           <a:p>
-            <a:pPr indent="0" marL="0">
-              <a:buNone/>
-            </a:pPr>
-            <a:r>
-              <a:rPr lang="en-US" sz="1200" b="1" spc="300" kern="0" dirty="0">
+            <a:pPr marL="0" indent="0">
+              <a:buNone/>
+            </a:pPr>
+            <a:r>
+              <a:rPr lang="en-US" sz="1200" b="1" kern="0" spc="300" dirty="0">
                 <a:solidFill>
                   <a:srgbClr val="EB6834"/>
                 </a:solidFill>
@@ -2310,7 +1985,7 @@
           <a:bodyPr wrap="square" lIns="0" tIns="0" rIns="0" bIns="0" rtlCol="0" anchor="ctr"/>
           <a:lstStyle/>
           <a:p>
-            <a:pPr indent="0" marL="0">
+            <a:pPr marL="0" indent="0">
               <a:buNone/>
             </a:pPr>
             <a:r>
@@ -2349,7 +2024,7 @@
           <a:bodyPr wrap="square" lIns="0" tIns="0" rIns="0" bIns="0" rtlCol="0" anchor="ctr"/>
           <a:lstStyle/>
           <a:p>
-            <a:pPr indent="0" marL="0">
+            <a:pPr marL="0" indent="0">
               <a:buNone/>
             </a:pPr>
             <a:r>
@@ -2388,7 +2063,7 @@
           <a:bodyPr wrap="square" lIns="0" tIns="0" rIns="0" bIns="0" rtlCol="0" anchor="ctr"/>
           <a:lstStyle/>
           <a:p>
-            <a:pPr indent="0" marL="0">
+            <a:pPr marL="0" indent="0">
               <a:buNone/>
             </a:pPr>
             <a:r>
@@ -2452,11 +2127,11 @@
           <a:bodyPr wrap="square" lIns="0" tIns="0" rIns="0" bIns="0" rtlCol="0" anchor="ctr"/>
           <a:lstStyle/>
           <a:p>
-            <a:pPr indent="0" marL="0">
-              <a:buNone/>
-            </a:pPr>
-            <a:r>
-              <a:rPr lang="en-US" sz="1100" b="1" spc="200" kern="0" dirty="0">
+            <a:pPr marL="0" indent="0">
+              <a:buNone/>
+            </a:pPr>
+            <a:r>
+              <a:rPr lang="en-US" sz="1100" b="1" kern="0" spc="200" dirty="0">
                 <a:solidFill>
                   <a:srgbClr val="5A5F6B"/>
                 </a:solidFill>
@@ -2491,7 +2166,7 @@
           <a:bodyPr wrap="square" lIns="0" tIns="0" rIns="0" bIns="0" rtlCol="0" anchor="ctr"/>
           <a:lstStyle/>
           <a:p>
-            <a:pPr indent="0" marL="0">
+            <a:pPr marL="0" indent="0">
               <a:buNone/>
             </a:pPr>
             <a:r>
@@ -2535,6 +2210,13 @@
             <a:prstDash val="solid"/>
           </a:ln>
         </p:spPr>
+        <p:txBody>
+          <a:bodyPr/>
+          <a:lstStyle/>
+          <a:p>
+            <a:endParaRPr lang="en-US"/>
+          </a:p>
+        </p:txBody>
       </p:sp>
       <p:sp>
         <p:nvSpPr>
@@ -2557,7 +2239,7 @@
           <a:bodyPr wrap="square" lIns="0" tIns="0" rIns="0" bIns="0" rtlCol="0" anchor="ctr"/>
           <a:lstStyle/>
           <a:p>
-            <a:pPr indent="0" marL="0">
+            <a:pPr marL="0" indent="0">
               <a:buNone/>
             </a:pPr>
             <a:r>
@@ -2596,7 +2278,7 @@
           <a:bodyPr wrap="square" lIns="0" tIns="0" rIns="0" bIns="0" rtlCol="0" anchor="ctr"/>
           <a:lstStyle/>
           <a:p>
-            <a:pPr indent="0" marL="0">
+            <a:pPr marL="0" indent="0">
               <a:buNone/>
             </a:pPr>
             <a:r>
@@ -2635,7 +2317,7 @@
           <a:bodyPr wrap="square" lIns="0" tIns="0" rIns="0" bIns="0" rtlCol="0" anchor="ctr"/>
           <a:lstStyle/>
           <a:p>
-            <a:pPr indent="0" marL="0">
+            <a:pPr marL="0" indent="0">
               <a:buNone/>
             </a:pPr>
             <a:r>
@@ -2652,7 +2334,7 @@
             <a:endParaRPr lang="en-US" sz="1000" dirty="0"/>
           </a:p>
           <a:p>
-            <a:pPr indent="0" marL="0">
+            <a:pPr marL="0" indent="0">
               <a:buNone/>
             </a:pPr>
             <a:r>
@@ -2669,7 +2351,7 @@
             <a:endParaRPr lang="en-US" sz="1000" dirty="0"/>
           </a:p>
           <a:p>
-            <a:pPr indent="0" marL="0">
+            <a:pPr marL="0" indent="0">
               <a:buNone/>
             </a:pPr>
             <a:r>
@@ -2708,7 +2390,7 @@
           <a:bodyPr wrap="square" lIns="0" tIns="0" rIns="0" bIns="0" rtlCol="0" anchor="ctr"/>
           <a:lstStyle/>
           <a:p>
-            <a:pPr indent="0" marL="0">
+            <a:pPr marL="0" indent="0">
               <a:buNone/>
             </a:pPr>
             <a:r>
@@ -2752,6 +2434,13 @@
             <a:prstDash val="solid"/>
           </a:ln>
         </p:spPr>
+        <p:txBody>
+          <a:bodyPr/>
+          <a:lstStyle/>
+          <a:p>
+            <a:endParaRPr lang="en-US"/>
+          </a:p>
+        </p:txBody>
       </p:sp>
       <p:sp>
         <p:nvSpPr>
@@ -2774,7 +2463,7 @@
           <a:bodyPr wrap="square" lIns="0" tIns="0" rIns="0" bIns="0" rtlCol="0" anchor="ctr"/>
           <a:lstStyle/>
           <a:p>
-            <a:pPr indent="0" marL="0">
+            <a:pPr marL="0" indent="0">
               <a:buNone/>
             </a:pPr>
             <a:r>
@@ -2813,7 +2502,7 @@
           <a:bodyPr wrap="square" lIns="0" tIns="0" rIns="0" bIns="0" rtlCol="0" anchor="ctr"/>
           <a:lstStyle/>
           <a:p>
-            <a:pPr indent="0" marL="0">
+            <a:pPr marL="0" indent="0">
               <a:buNone/>
             </a:pPr>
             <a:r>
@@ -2852,7 +2541,7 @@
           <a:bodyPr wrap="square" lIns="0" tIns="0" rIns="0" bIns="0" rtlCol="0" anchor="ctr"/>
           <a:lstStyle/>
           <a:p>
-            <a:pPr indent="0" marL="0">
+            <a:pPr marL="0" indent="0">
               <a:buNone/>
             </a:pPr>
             <a:r>
@@ -2869,7 +2558,7 @@
             <a:endParaRPr lang="en-US" sz="1000" dirty="0"/>
           </a:p>
           <a:p>
-            <a:pPr indent="0" marL="0">
+            <a:pPr marL="0" indent="0">
               <a:buNone/>
             </a:pPr>
             <a:r>
@@ -2886,7 +2575,7 @@
             <a:endParaRPr lang="en-US" sz="1000" dirty="0"/>
           </a:p>
           <a:p>
-            <a:pPr indent="0" marL="0">
+            <a:pPr marL="0" indent="0">
               <a:buNone/>
             </a:pPr>
             <a:r>
@@ -2925,7 +2614,7 @@
           <a:bodyPr wrap="square" lIns="0" tIns="0" rIns="0" bIns="0" rtlCol="0" anchor="ctr"/>
           <a:lstStyle/>
           <a:p>
-            <a:pPr indent="0" marL="0">
+            <a:pPr marL="0" indent="0">
               <a:buNone/>
             </a:pPr>
             <a:r>
@@ -2969,6 +2658,13 @@
             <a:prstDash val="solid"/>
           </a:ln>
         </p:spPr>
+        <p:txBody>
+          <a:bodyPr/>
+          <a:lstStyle/>
+          <a:p>
+            <a:endParaRPr lang="en-US"/>
+          </a:p>
+        </p:txBody>
       </p:sp>
       <p:sp>
         <p:nvSpPr>
@@ -2991,7 +2687,7 @@
           <a:bodyPr wrap="square" lIns="0" tIns="0" rIns="0" bIns="0" rtlCol="0" anchor="ctr"/>
           <a:lstStyle/>
           <a:p>
-            <a:pPr indent="0" marL="0">
+            <a:pPr marL="0" indent="0">
               <a:buNone/>
             </a:pPr>
             <a:r>
@@ -3030,7 +2726,7 @@
           <a:bodyPr wrap="square" lIns="0" tIns="0" rIns="0" bIns="0" rtlCol="0" anchor="ctr"/>
           <a:lstStyle/>
           <a:p>
-            <a:pPr indent="0" marL="0">
+            <a:pPr marL="0" indent="0">
               <a:buNone/>
             </a:pPr>
             <a:r>
@@ -3069,7 +2765,7 @@
           <a:bodyPr wrap="square" lIns="0" tIns="0" rIns="0" bIns="0" rtlCol="0" anchor="ctr"/>
           <a:lstStyle/>
           <a:p>
-            <a:pPr indent="0" marL="0">
+            <a:pPr marL="0" indent="0">
               <a:buNone/>
             </a:pPr>
             <a:r>
@@ -3086,7 +2782,7 @@
             <a:endParaRPr lang="en-US" sz="1000" dirty="0"/>
           </a:p>
           <a:p>
-            <a:pPr indent="0" marL="0">
+            <a:pPr marL="0" indent="0">
               <a:buNone/>
             </a:pPr>
             <a:r>
@@ -3103,7 +2799,7 @@
             <a:endParaRPr lang="en-US" sz="1000" dirty="0"/>
           </a:p>
           <a:p>
-            <a:pPr indent="0" marL="0">
+            <a:pPr marL="0" indent="0">
               <a:buNone/>
             </a:pPr>
             <a:r>
@@ -3142,7 +2838,7 @@
           <a:bodyPr wrap="square" lIns="0" tIns="0" rIns="0" bIns="0" rtlCol="0" anchor="ctr"/>
           <a:lstStyle/>
           <a:p>
-            <a:pPr indent="0" marL="0">
+            <a:pPr marL="0" indent="0">
               <a:buNone/>
             </a:pPr>
             <a:r>
@@ -3186,6 +2882,13 @@
             <a:prstDash val="solid"/>
           </a:ln>
         </p:spPr>
+        <p:txBody>
+          <a:bodyPr/>
+          <a:lstStyle/>
+          <a:p>
+            <a:endParaRPr lang="en-US"/>
+          </a:p>
+        </p:txBody>
       </p:sp>
       <p:sp>
         <p:nvSpPr>
@@ -3208,7 +2911,7 @@
           <a:bodyPr wrap="square" lIns="0" tIns="0" rIns="0" bIns="0" rtlCol="0" anchor="ctr"/>
           <a:lstStyle/>
           <a:p>
-            <a:pPr indent="0" marL="0">
+            <a:pPr marL="0" indent="0">
               <a:buNone/>
             </a:pPr>
             <a:r>
@@ -3247,7 +2950,7 @@
           <a:bodyPr wrap="square" lIns="0" tIns="0" rIns="0" bIns="0" rtlCol="0" anchor="ctr"/>
           <a:lstStyle/>
           <a:p>
-            <a:pPr indent="0" marL="0">
+            <a:pPr marL="0" indent="0">
               <a:buNone/>
             </a:pPr>
             <a:r>
@@ -3286,7 +2989,7 @@
           <a:bodyPr wrap="square" lIns="0" tIns="0" rIns="0" bIns="0" rtlCol="0" anchor="ctr"/>
           <a:lstStyle/>
           <a:p>
-            <a:pPr indent="0" marL="0">
+            <a:pPr marL="0" indent="0">
               <a:buNone/>
             </a:pPr>
             <a:r>
@@ -3303,7 +3006,7 @@
             <a:endParaRPr lang="en-US" sz="1000" dirty="0"/>
           </a:p>
           <a:p>
-            <a:pPr indent="0" marL="0">
+            <a:pPr marL="0" indent="0">
               <a:buNone/>
             </a:pPr>
             <a:r>
@@ -3320,7 +3023,7 @@
             <a:endParaRPr lang="en-US" sz="1000" dirty="0"/>
           </a:p>
           <a:p>
-            <a:pPr indent="0" marL="0">
+            <a:pPr marL="0" indent="0">
               <a:buNone/>
             </a:pPr>
             <a:r>
@@ -3359,7 +3062,7 @@
           <a:bodyPr wrap="square" lIns="0" tIns="0" rIns="0" bIns="0" rtlCol="0" anchor="ctr"/>
           <a:lstStyle/>
           <a:p>
-            <a:pPr indent="0" marL="0">
+            <a:pPr marL="0" indent="0">
               <a:buNone/>
             </a:pPr>
             <a:r>
@@ -3403,6 +3106,13 @@
             <a:prstDash val="solid"/>
           </a:ln>
         </p:spPr>
+        <p:txBody>
+          <a:bodyPr/>
+          <a:lstStyle/>
+          <a:p>
+            <a:endParaRPr lang="en-US"/>
+          </a:p>
+        </p:txBody>
       </p:sp>
       <p:sp>
         <p:nvSpPr>
@@ -3425,7 +3135,7 @@
           <a:bodyPr wrap="square" lIns="0" tIns="0" rIns="0" bIns="0" rtlCol="0" anchor="ctr"/>
           <a:lstStyle/>
           <a:p>
-            <a:pPr indent="0" marL="0">
+            <a:pPr marL="0" indent="0">
               <a:buNone/>
             </a:pPr>
             <a:r>
@@ -3464,7 +3174,7 @@
           <a:bodyPr wrap="square" lIns="0" tIns="0" rIns="0" bIns="0" rtlCol="0" anchor="ctr"/>
           <a:lstStyle/>
           <a:p>
-            <a:pPr indent="0" marL="0">
+            <a:pPr marL="0" indent="0">
               <a:buNone/>
             </a:pPr>
             <a:r>
@@ -3503,7 +3213,7 @@
           <a:bodyPr wrap="square" lIns="0" tIns="0" rIns="0" bIns="0" rtlCol="0" anchor="ctr"/>
           <a:lstStyle/>
           <a:p>
-            <a:pPr indent="0" marL="0">
+            <a:pPr marL="0" indent="0">
               <a:buNone/>
             </a:pPr>
             <a:r>
@@ -3520,7 +3230,7 @@
             <a:endParaRPr lang="en-US" sz="1000" dirty="0"/>
           </a:p>
           <a:p>
-            <a:pPr indent="0" marL="0">
+            <a:pPr marL="0" indent="0">
               <a:buNone/>
             </a:pPr>
             <a:r>
@@ -3537,7 +3247,7 @@
             <a:endParaRPr lang="en-US" sz="1000" dirty="0"/>
           </a:p>
           <a:p>
-            <a:pPr indent="0" marL="0">
+            <a:pPr marL="0" indent="0">
               <a:buNone/>
             </a:pPr>
             <a:r>
@@ -3576,7 +3286,7 @@
           <a:bodyPr wrap="square" lIns="0" tIns="0" rIns="0" bIns="0" rtlCol="0" anchor="ctr"/>
           <a:lstStyle/>
           <a:p>
-            <a:pPr indent="0" marL="0">
+            <a:pPr marL="0" indent="0">
               <a:buNone/>
             </a:pPr>
             <a:r>
@@ -3588,7 +3298,7 @@
                 <a:ea typeface="Cambria" pitchFamily="34" charset="-122"/>
                 <a:cs typeface="Cambria" pitchFamily="34" charset="-120"/>
               </a:rPr>
-              <a:t>Four decisions worth defending</a:t>
+              <a:t>Four decisions</a:t>
             </a:r>
             <a:endParaRPr lang="en-US" sz="1900" dirty="0"/>
           </a:p>
@@ -3615,7 +3325,7 @@
           <a:bodyPr wrap="square" lIns="0" tIns="0" rIns="0" bIns="0" rtlCol="0" anchor="ctr"/>
           <a:lstStyle/>
           <a:p>
-            <a:pPr indent="0" marL="0">
+            <a:pPr marL="0" indent="0">
               <a:buNone/>
             </a:pPr>
             <a:r>
@@ -3641,7 +3351,7 @@
         </p:nvSpPr>
         <p:spPr>
           <a:xfrm>
-            <a:off x="4343400" y="3931920"/>
+            <a:off x="4343400" y="3881680"/>
             <a:ext cx="7269480" cy="502920"/>
           </a:xfrm>
           <a:prstGeom prst="rect">
@@ -3654,7 +3364,7 @@
           <a:bodyPr wrap="square" lIns="0" tIns="0" rIns="0" bIns="0" rtlCol="0" anchor="ctr"/>
           <a:lstStyle/>
           <a:p>
-            <a:pPr indent="0" marL="0">
+            <a:pPr marL="0" indent="0">
               <a:buNone/>
             </a:pPr>
             <a:r>
@@ -3693,7 +3403,7 @@
           <a:bodyPr wrap="square" lIns="0" tIns="0" rIns="0" bIns="0" rtlCol="0" anchor="ctr"/>
           <a:lstStyle/>
           <a:p>
-            <a:pPr indent="0" marL="0">
+            <a:pPr marL="0" indent="0">
               <a:buNone/>
             </a:pPr>
             <a:r>
@@ -3719,7 +3429,7 @@
         </p:nvSpPr>
         <p:spPr>
           <a:xfrm>
-            <a:off x="4343400" y="4553712"/>
+            <a:off x="4343400" y="4503472"/>
             <a:ext cx="7269480" cy="502920"/>
           </a:xfrm>
           <a:prstGeom prst="rect">
@@ -3732,7 +3442,7 @@
           <a:bodyPr wrap="square" lIns="0" tIns="0" rIns="0" bIns="0" rtlCol="0" anchor="ctr"/>
           <a:lstStyle/>
           <a:p>
-            <a:pPr indent="0" marL="0">
+            <a:pPr marL="0" indent="0">
               <a:buNone/>
             </a:pPr>
             <a:r>
@@ -3771,7 +3481,7 @@
           <a:bodyPr wrap="square" lIns="0" tIns="0" rIns="0" bIns="0" rtlCol="0" anchor="ctr"/>
           <a:lstStyle/>
           <a:p>
-            <a:pPr indent="0" marL="0">
+            <a:pPr marL="0" indent="0">
               <a:buNone/>
             </a:pPr>
             <a:r>
@@ -3797,7 +3507,7 @@
         </p:nvSpPr>
         <p:spPr>
           <a:xfrm>
-            <a:off x="4343400" y="5175504"/>
+            <a:off x="4343400" y="5125264"/>
             <a:ext cx="7269480" cy="502920"/>
           </a:xfrm>
           <a:prstGeom prst="rect">
@@ -3810,7 +3520,7 @@
           <a:bodyPr wrap="square" lIns="0" tIns="0" rIns="0" bIns="0" rtlCol="0" anchor="ctr"/>
           <a:lstStyle/>
           <a:p>
-            <a:pPr indent="0" marL="0">
+            <a:pPr marL="0" indent="0">
               <a:buNone/>
             </a:pPr>
             <a:r>
@@ -3849,7 +3559,7 @@
           <a:bodyPr wrap="square" lIns="0" tIns="0" rIns="0" bIns="0" rtlCol="0" anchor="ctr"/>
           <a:lstStyle/>
           <a:p>
-            <a:pPr indent="0" marL="0">
+            <a:pPr marL="0" indent="0">
               <a:buNone/>
             </a:pPr>
             <a:r>
@@ -3875,7 +3585,7 @@
         </p:nvSpPr>
         <p:spPr>
           <a:xfrm>
-            <a:off x="4343400" y="5797296"/>
+            <a:off x="4343400" y="5747056"/>
             <a:ext cx="7269480" cy="502920"/>
           </a:xfrm>
           <a:prstGeom prst="rect">
@@ -3888,7 +3598,7 @@
           <a:bodyPr wrap="square" lIns="0" tIns="0" rIns="0" bIns="0" rtlCol="0" anchor="ctr"/>
           <a:lstStyle/>
           <a:p>
-            <a:pPr indent="0" marL="0">
+            <a:pPr marL="0" indent="0">
               <a:buNone/>
             </a:pPr>
             <a:r>
@@ -3952,11 +3662,11 @@
           <a:bodyPr wrap="square" lIns="0" tIns="0" rIns="0" bIns="0" rtlCol="0" anchor="ctr"/>
           <a:lstStyle/>
           <a:p>
-            <a:pPr indent="0" marL="0">
-              <a:buNone/>
-            </a:pPr>
-            <a:r>
-              <a:rPr lang="en-US" sz="1100" b="1" spc="200" kern="0" dirty="0">
+            <a:pPr marL="0" indent="0">
+              <a:buNone/>
+            </a:pPr>
+            <a:r>
+              <a:rPr lang="en-US" sz="1100" b="1" kern="0" spc="200" dirty="0">
                 <a:solidFill>
                   <a:srgbClr val="5A5F6B"/>
                 </a:solidFill>
@@ -3991,7 +3701,7 @@
           <a:bodyPr wrap="square" lIns="0" tIns="0" rIns="0" bIns="0" rtlCol="0" anchor="ctr"/>
           <a:lstStyle/>
           <a:p>
-            <a:pPr indent="0" marL="0">
+            <a:pPr marL="0" indent="0">
               <a:buNone/>
             </a:pPr>
             <a:r>
@@ -4030,7 +3740,7 @@
           <a:bodyPr wrap="square" lIns="0" tIns="0" rIns="0" bIns="0" rtlCol="0" anchor="ctr"/>
           <a:lstStyle/>
           <a:p>
-            <a:pPr indent="0" marL="0">
+            <a:pPr marL="0" indent="0">
               <a:buNone/>
             </a:pPr>
             <a:r>
@@ -4074,6 +3784,13 @@
             <a:prstDash val="solid"/>
           </a:ln>
         </p:spPr>
+        <p:txBody>
+          <a:bodyPr/>
+          <a:lstStyle/>
+          <a:p>
+            <a:endParaRPr lang="en-US"/>
+          </a:p>
+        </p:txBody>
       </p:sp>
       <p:sp>
         <p:nvSpPr>
@@ -4096,11 +3813,11 @@
           <a:bodyPr wrap="square" lIns="0" tIns="0" rIns="0" bIns="0" rtlCol="0" anchor="ctr"/>
           <a:lstStyle/>
           <a:p>
-            <a:pPr indent="0" marL="0">
-              <a:buNone/>
-            </a:pPr>
-            <a:r>
-              <a:rPr lang="en-US" sz="1000" b="1" spc="100" kern="0" dirty="0">
+            <a:pPr marL="0" indent="0">
+              <a:buNone/>
+            </a:pPr>
+            <a:r>
+              <a:rPr lang="en-US" sz="1000" b="1" kern="0" spc="100" dirty="0">
                 <a:solidFill>
                   <a:srgbClr val="5A5F6B"/>
                 </a:solidFill>
@@ -4135,7 +3852,7 @@
           <a:bodyPr wrap="square" lIns="0" tIns="0" rIns="0" bIns="0" rtlCol="0" anchor="ctr"/>
           <a:lstStyle/>
           <a:p>
-            <a:pPr indent="0" marL="0">
+            <a:pPr marL="0" indent="0">
               <a:buNone/>
             </a:pPr>
             <a:r>
@@ -4179,6 +3896,13 @@
             <a:prstDash val="solid"/>
           </a:ln>
         </p:spPr>
+        <p:txBody>
+          <a:bodyPr/>
+          <a:lstStyle/>
+          <a:p>
+            <a:endParaRPr lang="en-US"/>
+          </a:p>
+        </p:txBody>
       </p:sp>
       <p:sp>
         <p:nvSpPr>
@@ -4201,11 +3925,11 @@
           <a:bodyPr wrap="square" lIns="0" tIns="0" rIns="0" bIns="0" rtlCol="0" anchor="ctr"/>
           <a:lstStyle/>
           <a:p>
-            <a:pPr indent="0" marL="0">
-              <a:buNone/>
-            </a:pPr>
-            <a:r>
-              <a:rPr lang="en-US" sz="1000" b="1" spc="100" kern="0" dirty="0">
+            <a:pPr marL="0" indent="0">
+              <a:buNone/>
+            </a:pPr>
+            <a:r>
+              <a:rPr lang="en-US" sz="1000" b="1" kern="0" spc="100" dirty="0">
                 <a:solidFill>
                   <a:srgbClr val="EB6834"/>
                 </a:solidFill>
@@ -4240,7 +3964,7 @@
           <a:bodyPr wrap="square" lIns="0" tIns="0" rIns="0" bIns="0" rtlCol="0" anchor="ctr"/>
           <a:lstStyle/>
           <a:p>
-            <a:pPr indent="0" marL="0">
+            <a:pPr marL="0" indent="0">
               <a:buNone/>
             </a:pPr>
             <a:r>
@@ -4279,7 +4003,7 @@
           <a:bodyPr wrap="square" lIns="0" tIns="0" rIns="0" bIns="0" rtlCol="0" anchor="ctr"/>
           <a:lstStyle/>
           <a:p>
-            <a:pPr indent="0" marL="0">
+            <a:pPr marL="0" indent="0">
               <a:buNone/>
             </a:pPr>
             <a:r>
@@ -4318,7 +4042,7 @@
           <a:bodyPr wrap="square" lIns="0" tIns="0" rIns="0" bIns="0" rtlCol="0" anchor="ctr"/>
           <a:lstStyle/>
           <a:p>
-            <a:pPr indent="0" marL="0">
+            <a:pPr marL="0" indent="0">
               <a:buNone/>
             </a:pPr>
             <a:r>
@@ -4357,7 +4081,7 @@
           <a:bodyPr wrap="square" lIns="0" tIns="0" rIns="0" bIns="0" rtlCol="0" anchor="ctr"/>
           <a:lstStyle/>
           <a:p>
-            <a:pPr indent="0" marL="0">
+            <a:pPr marL="0" indent="0">
               <a:buNone/>
             </a:pPr>
             <a:r>
@@ -4396,7 +4120,7 @@
           <a:bodyPr wrap="square" lIns="0" tIns="0" rIns="0" bIns="0" rtlCol="0" anchor="ctr"/>
           <a:lstStyle/>
           <a:p>
-            <a:pPr indent="0" marL="0">
+            <a:pPr marL="0" indent="0">
               <a:buNone/>
             </a:pPr>
             <a:r>
@@ -4435,7 +4159,7 @@
           <a:bodyPr wrap="square" lIns="0" tIns="0" rIns="0" bIns="0" rtlCol="0" anchor="ctr"/>
           <a:lstStyle/>
           <a:p>
-            <a:pPr indent="0" marL="0">
+            <a:pPr marL="0" indent="0">
               <a:buNone/>
             </a:pPr>
             <a:r>
@@ -4474,7 +4198,7 @@
           <a:bodyPr wrap="square" lIns="0" tIns="0" rIns="0" bIns="0" rtlCol="0" anchor="ctr"/>
           <a:lstStyle/>
           <a:p>
-            <a:pPr indent="0" marL="0">
+            <a:pPr marL="0" indent="0">
               <a:buNone/>
             </a:pPr>
             <a:r>
@@ -4513,7 +4237,7 @@
           <a:bodyPr wrap="square" lIns="0" tIns="0" rIns="0" bIns="0" rtlCol="0" anchor="ctr"/>
           <a:lstStyle/>
           <a:p>
-            <a:pPr indent="0" marL="0">
+            <a:pPr marL="0" indent="0">
               <a:buNone/>
             </a:pPr>
             <a:r>
@@ -4577,11 +4301,11 @@
           <a:bodyPr wrap="square" lIns="0" tIns="0" rIns="0" bIns="0" rtlCol="0" anchor="ctr"/>
           <a:lstStyle/>
           <a:p>
-            <a:pPr indent="0" marL="0">
-              <a:buNone/>
-            </a:pPr>
-            <a:r>
-              <a:rPr lang="en-US" sz="1100" b="1" spc="200" kern="0" dirty="0">
+            <a:pPr marL="0" indent="0">
+              <a:buNone/>
+            </a:pPr>
+            <a:r>
+              <a:rPr lang="en-US" sz="1100" b="1" kern="0" spc="200" dirty="0">
                 <a:solidFill>
                   <a:srgbClr val="5A5F6B"/>
                 </a:solidFill>
@@ -4616,7 +4340,7 @@
           <a:bodyPr wrap="square" lIns="0" tIns="0" rIns="0" bIns="0" rtlCol="0" anchor="ctr"/>
           <a:lstStyle/>
           <a:p>
-            <a:pPr indent="0" marL="0">
+            <a:pPr marL="0" indent="0">
               <a:buNone/>
             </a:pPr>
             <a:r>
@@ -4655,7 +4379,7 @@
           <a:bodyPr wrap="square" lIns="0" tIns="0" rIns="0" bIns="0" rtlCol="0" anchor="ctr"/>
           <a:lstStyle/>
           <a:p>
-            <a:pPr indent="0" marL="0">
+            <a:pPr marL="0" indent="0">
               <a:buNone/>
             </a:pPr>
             <a:r>
@@ -4699,6 +4423,13 @@
             <a:prstDash val="solid"/>
           </a:ln>
         </p:spPr>
+        <p:txBody>
+          <a:bodyPr/>
+          <a:lstStyle/>
+          <a:p>
+            <a:endParaRPr lang="en-US"/>
+          </a:p>
+        </p:txBody>
       </p:sp>
       <p:sp>
         <p:nvSpPr>
@@ -4721,7 +4452,7 @@
           <a:bodyPr wrap="square" lIns="0" tIns="0" rIns="0" bIns="0" rtlCol="0" anchor="ctr"/>
           <a:lstStyle/>
           <a:p>
-            <a:pPr indent="0" marL="0">
+            <a:pPr marL="0" indent="0">
               <a:buNone/>
             </a:pPr>
             <a:r>
@@ -4760,7 +4491,7 @@
           <a:bodyPr wrap="square" lIns="0" tIns="0" rIns="0" bIns="0" rtlCol="0" anchor="ctr"/>
           <a:lstStyle/>
           <a:p>
-            <a:pPr indent="0" marL="0">
+            <a:pPr marL="0" indent="0">
               <a:buNone/>
             </a:pPr>
             <a:r>
@@ -4804,6 +4535,13 @@
             <a:prstDash val="solid"/>
           </a:ln>
         </p:spPr>
+        <p:txBody>
+          <a:bodyPr/>
+          <a:lstStyle/>
+          <a:p>
+            <a:endParaRPr lang="en-US"/>
+          </a:p>
+        </p:txBody>
       </p:sp>
       <p:sp>
         <p:nvSpPr>
@@ -4826,7 +4564,7 @@
           <a:bodyPr wrap="square" lIns="0" tIns="0" rIns="0" bIns="0" rtlCol="0" anchor="ctr"/>
           <a:lstStyle/>
           <a:p>
-            <a:pPr indent="0" marL="0">
+            <a:pPr marL="0" indent="0">
               <a:buNone/>
             </a:pPr>
             <a:r>
@@ -4865,7 +4603,7 @@
           <a:bodyPr wrap="square" lIns="0" tIns="0" rIns="0" bIns="0" rtlCol="0" anchor="ctr"/>
           <a:lstStyle/>
           <a:p>
-            <a:pPr indent="0" marL="0">
+            <a:pPr marL="0" indent="0">
               <a:buNone/>
             </a:pPr>
             <a:r>
@@ -4909,6 +4647,13 @@
             <a:prstDash val="solid"/>
           </a:ln>
         </p:spPr>
+        <p:txBody>
+          <a:bodyPr/>
+          <a:lstStyle/>
+          <a:p>
+            <a:endParaRPr lang="en-US"/>
+          </a:p>
+        </p:txBody>
       </p:sp>
       <p:sp>
         <p:nvSpPr>
@@ -4931,7 +4676,7 @@
           <a:bodyPr wrap="square" lIns="0" tIns="0" rIns="0" bIns="0" rtlCol="0" anchor="ctr"/>
           <a:lstStyle/>
           <a:p>
-            <a:pPr indent="0" marL="0">
+            <a:pPr marL="0" indent="0">
               <a:buNone/>
             </a:pPr>
             <a:r>
@@ -4970,7 +4715,7 @@
           <a:bodyPr wrap="square" lIns="0" tIns="0" rIns="0" bIns="0" rtlCol="0" anchor="ctr"/>
           <a:lstStyle/>
           <a:p>
-            <a:pPr indent="0" marL="0">
+            <a:pPr marL="0" indent="0">
               <a:buNone/>
             </a:pPr>
             <a:r>
@@ -5014,6 +4759,13 @@
             <a:prstDash val="solid"/>
           </a:ln>
         </p:spPr>
+        <p:txBody>
+          <a:bodyPr/>
+          <a:lstStyle/>
+          <a:p>
+            <a:endParaRPr lang="en-US"/>
+          </a:p>
+        </p:txBody>
       </p:sp>
       <p:sp>
         <p:nvSpPr>
@@ -5036,7 +4788,7 @@
           <a:bodyPr wrap="square" lIns="0" tIns="0" rIns="0" bIns="0" rtlCol="0" anchor="ctr"/>
           <a:lstStyle/>
           <a:p>
-            <a:pPr indent="0" marL="0">
+            <a:pPr marL="0" indent="0">
               <a:buNone/>
             </a:pPr>
             <a:r>
@@ -5075,7 +4827,7 @@
           <a:bodyPr wrap="square" lIns="0" tIns="0" rIns="0" bIns="0" rtlCol="0" anchor="ctr"/>
           <a:lstStyle/>
           <a:p>
-            <a:pPr algn="r" indent="0" marL="0">
+            <a:pPr marL="0" indent="0" algn="r">
               <a:buNone/>
             </a:pPr>
             <a:r>
@@ -5101,7 +4853,7 @@
         </p:nvSpPr>
         <p:spPr>
           <a:xfrm>
-            <a:off x="7269480" y="2258568"/>
+            <a:off x="7269480" y="2178182"/>
             <a:ext cx="4114800" cy="365760"/>
           </a:xfrm>
           <a:prstGeom prst="rect">
@@ -5114,7 +4866,7 @@
           <a:bodyPr wrap="square" lIns="0" tIns="0" rIns="0" bIns="0" rtlCol="0" anchor="ctr"/>
           <a:lstStyle/>
           <a:p>
-            <a:pPr indent="0" marL="0">
+            <a:pPr marL="0" indent="0">
               <a:buNone/>
             </a:pPr>
             <a:r>
@@ -5153,7 +4905,7 @@
           <a:bodyPr wrap="square" lIns="0" tIns="0" rIns="0" bIns="0" rtlCol="0" anchor="ctr"/>
           <a:lstStyle/>
           <a:p>
-            <a:pPr algn="r" indent="0" marL="0">
+            <a:pPr marL="0" indent="0" algn="r">
               <a:buNone/>
             </a:pPr>
             <a:r>
@@ -5179,7 +4931,7 @@
         </p:nvSpPr>
         <p:spPr>
           <a:xfrm>
-            <a:off x="7269480" y="2642616"/>
+            <a:off x="7269480" y="2562230"/>
             <a:ext cx="4114800" cy="365760"/>
           </a:xfrm>
           <a:prstGeom prst="rect">
@@ -5192,7 +4944,7 @@
           <a:bodyPr wrap="square" lIns="0" tIns="0" rIns="0" bIns="0" rtlCol="0" anchor="ctr"/>
           <a:lstStyle/>
           <a:p>
-            <a:pPr indent="0" marL="0">
+            <a:pPr marL="0" indent="0">
               <a:buNone/>
             </a:pPr>
             <a:r>
@@ -5231,7 +4983,7 @@
           <a:bodyPr wrap="square" lIns="0" tIns="0" rIns="0" bIns="0" rtlCol="0" anchor="ctr"/>
           <a:lstStyle/>
           <a:p>
-            <a:pPr algn="r" indent="0" marL="0">
+            <a:pPr marL="0" indent="0" algn="r">
               <a:buNone/>
             </a:pPr>
             <a:r>
@@ -5257,7 +5009,7 @@
         </p:nvSpPr>
         <p:spPr>
           <a:xfrm>
-            <a:off x="7269480" y="3026664"/>
+            <a:off x="7269480" y="2946278"/>
             <a:ext cx="4114800" cy="365760"/>
           </a:xfrm>
           <a:prstGeom prst="rect">
@@ -5270,7 +5022,7 @@
           <a:bodyPr wrap="square" lIns="0" tIns="0" rIns="0" bIns="0" rtlCol="0" anchor="ctr"/>
           <a:lstStyle/>
           <a:p>
-            <a:pPr indent="0" marL="0">
+            <a:pPr marL="0" indent="0">
               <a:buNone/>
             </a:pPr>
             <a:r>
@@ -5309,7 +5061,7 @@
           <a:bodyPr wrap="square" lIns="0" tIns="0" rIns="0" bIns="0" rtlCol="0" anchor="ctr"/>
           <a:lstStyle/>
           <a:p>
-            <a:pPr algn="r" indent="0" marL="0">
+            <a:pPr marL="0" indent="0" algn="r">
               <a:buNone/>
             </a:pPr>
             <a:r>
@@ -5335,7 +5087,7 @@
         </p:nvSpPr>
         <p:spPr>
           <a:xfrm>
-            <a:off x="7269480" y="3410712"/>
+            <a:off x="7269480" y="3330326"/>
             <a:ext cx="4114800" cy="365760"/>
           </a:xfrm>
           <a:prstGeom prst="rect">
@@ -5348,7 +5100,7 @@
           <a:bodyPr wrap="square" lIns="0" tIns="0" rIns="0" bIns="0" rtlCol="0" anchor="ctr"/>
           <a:lstStyle/>
           <a:p>
-            <a:pPr indent="0" marL="0">
+            <a:pPr marL="0" indent="0">
               <a:buNone/>
             </a:pPr>
             <a:r>
@@ -5387,7 +5139,7 @@
           <a:bodyPr wrap="square" lIns="0" tIns="0" rIns="0" bIns="0" rtlCol="0" anchor="ctr"/>
           <a:lstStyle/>
           <a:p>
-            <a:pPr algn="r" indent="0" marL="0">
+            <a:pPr marL="0" indent="0" algn="r">
               <a:buNone/>
             </a:pPr>
             <a:r>
@@ -5413,7 +5165,7 @@
         </p:nvSpPr>
         <p:spPr>
           <a:xfrm>
-            <a:off x="7269480" y="3794760"/>
+            <a:off x="7269480" y="3714374"/>
             <a:ext cx="4114800" cy="365760"/>
           </a:xfrm>
           <a:prstGeom prst="rect">
@@ -5426,7 +5178,7 @@
           <a:bodyPr wrap="square" lIns="0" tIns="0" rIns="0" bIns="0" rtlCol="0" anchor="ctr"/>
           <a:lstStyle/>
           <a:p>
-            <a:pPr indent="0" marL="0">
+            <a:pPr marL="0" indent="0">
               <a:buNone/>
             </a:pPr>
             <a:r>
@@ -5465,7 +5217,7 @@
           <a:bodyPr wrap="square" lIns="0" tIns="0" rIns="0" bIns="0" rtlCol="0" anchor="ctr"/>
           <a:lstStyle/>
           <a:p>
-            <a:pPr algn="r" indent="0" marL="0">
+            <a:pPr marL="0" indent="0" algn="r">
               <a:buNone/>
             </a:pPr>
             <a:r>
@@ -5491,7 +5243,7 @@
         </p:nvSpPr>
         <p:spPr>
           <a:xfrm>
-            <a:off x="7269480" y="4178808"/>
+            <a:off x="7269480" y="4098422"/>
             <a:ext cx="4114800" cy="365760"/>
           </a:xfrm>
           <a:prstGeom prst="rect">
@@ -5504,7 +5256,7 @@
           <a:bodyPr wrap="square" lIns="0" tIns="0" rIns="0" bIns="0" rtlCol="0" anchor="ctr"/>
           <a:lstStyle/>
           <a:p>
-            <a:pPr indent="0" marL="0">
+            <a:pPr marL="0" indent="0">
               <a:buNone/>
             </a:pPr>
             <a:r>
@@ -5543,7 +5295,7 @@
           <a:bodyPr wrap="square" lIns="0" tIns="0" rIns="0" bIns="0" rtlCol="0" anchor="ctr"/>
           <a:lstStyle/>
           <a:p>
-            <a:pPr indent="0" marL="0">
+            <a:pPr marL="0" indent="0">
               <a:buNone/>
             </a:pPr>
             <a:r>
@@ -5587,6 +5339,13 @@
             <a:prstDash val="solid"/>
           </a:ln>
         </p:spPr>
+        <p:txBody>
+          <a:bodyPr/>
+          <a:lstStyle/>
+          <a:p>
+            <a:endParaRPr lang="en-US"/>
+          </a:p>
+        </p:txBody>
       </p:sp>
       <p:sp>
         <p:nvSpPr>
@@ -5609,7 +5368,7 @@
           <a:bodyPr wrap="square" lIns="0" tIns="0" rIns="0" bIns="0" rtlCol="0" anchor="ctr"/>
           <a:lstStyle/>
           <a:p>
-            <a:pPr indent="0" marL="0">
+            <a:pPr marL="0" indent="0">
               <a:buNone/>
             </a:pPr>
             <a:r>
@@ -5648,7 +5407,7 @@
           <a:bodyPr wrap="square" lIns="0" tIns="0" rIns="0" bIns="0" rtlCol="0" anchor="ctr"/>
           <a:lstStyle/>
           <a:p>
-            <a:pPr indent="0" marL="0">
+            <a:pPr marL="0" indent="0">
               <a:buNone/>
             </a:pPr>
             <a:r>
@@ -5682,6 +5441,7 @@
         <a:solidFill>
           <a:srgbClr val="16181D"/>
         </a:solidFill>
+        <a:effectLst/>
       </p:bgPr>
     </p:bg>
     <p:spTree>
@@ -5719,11 +5479,11 @@
           <a:bodyPr wrap="square" lIns="0" tIns="0" rIns="0" bIns="0" rtlCol="0" anchor="ctr"/>
           <a:lstStyle/>
           <a:p>
-            <a:pPr indent="0" marL="0">
-              <a:buNone/>
-            </a:pPr>
-            <a:r>
-              <a:rPr lang="en-US" sz="1100" b="1" spc="200" kern="0" dirty="0">
+            <a:pPr marL="0" indent="0">
+              <a:buNone/>
+            </a:pPr>
+            <a:r>
+              <a:rPr lang="en-US" sz="1100" b="1" kern="0" spc="200" dirty="0">
                 <a:solidFill>
                   <a:srgbClr val="EB6834"/>
                 </a:solidFill>
@@ -5758,7 +5518,7 @@
           <a:bodyPr wrap="square" lIns="0" tIns="0" rIns="0" bIns="0" rtlCol="0" anchor="ctr"/>
           <a:lstStyle/>
           <a:p>
-            <a:pPr indent="0" marL="0">
+            <a:pPr marL="0" indent="0">
               <a:buNone/>
             </a:pPr>
             <a:r>
@@ -5797,7 +5557,7 @@
           <a:bodyPr wrap="square" lIns="0" tIns="0" rIns="0" bIns="0" rtlCol="0" anchor="ctr"/>
           <a:lstStyle/>
           <a:p>
-            <a:pPr indent="0" marL="0">
+            <a:pPr marL="0" indent="0">
               <a:buNone/>
             </a:pPr>
             <a:r>
@@ -5836,7 +5596,7 @@
           <a:bodyPr wrap="square" lIns="0" tIns="0" rIns="0" bIns="0" rtlCol="0" anchor="ctr"/>
           <a:lstStyle/>
           <a:p>
-            <a:pPr indent="0" marL="0">
+            <a:pPr marL="0" indent="0">
               <a:buNone/>
             </a:pPr>
             <a:r>
@@ -5875,7 +5635,7 @@
           <a:bodyPr wrap="square" lIns="0" tIns="0" rIns="0" bIns="0" rtlCol="0" anchor="ctr"/>
           <a:lstStyle/>
           <a:p>
-            <a:pPr indent="0" marL="0">
+            <a:pPr marL="0" indent="0">
               <a:buNone/>
             </a:pPr>
             <a:r>
@@ -5914,7 +5674,7 @@
           <a:bodyPr wrap="square" lIns="0" tIns="0" rIns="0" bIns="0" rtlCol="0" anchor="ctr"/>
           <a:lstStyle/>
           <a:p>
-            <a:pPr indent="0" marL="0">
+            <a:pPr marL="0" indent="0">
               <a:buNone/>
             </a:pPr>
             <a:r>
@@ -5953,7 +5713,7 @@
           <a:bodyPr wrap="square" lIns="0" tIns="0" rIns="0" bIns="0" rtlCol="0" anchor="ctr"/>
           <a:lstStyle/>
           <a:p>
-            <a:pPr indent="0" marL="0">
+            <a:pPr marL="0" indent="0">
               <a:buNone/>
             </a:pPr>
             <a:r>
@@ -5992,7 +5752,7 @@
           <a:bodyPr wrap="square" lIns="0" tIns="0" rIns="0" bIns="0" rtlCol="0" anchor="ctr"/>
           <a:lstStyle/>
           <a:p>
-            <a:pPr indent="0" marL="0">
+            <a:pPr marL="0" indent="0">
               <a:buNone/>
             </a:pPr>
             <a:r>
@@ -6031,7 +5791,7 @@
           <a:bodyPr wrap="square" lIns="0" tIns="0" rIns="0" bIns="0" rtlCol="0" anchor="ctr"/>
           <a:lstStyle/>
           <a:p>
-            <a:pPr indent="0" marL="0">
+            <a:pPr marL="0" indent="0">
               <a:buNone/>
             </a:pPr>
             <a:r>
@@ -6070,7 +5830,7 @@
           <a:bodyPr wrap="square" lIns="0" tIns="0" rIns="0" bIns="0" rtlCol="0" anchor="ctr"/>
           <a:lstStyle/>
           <a:p>
-            <a:pPr indent="0" marL="0">
+            <a:pPr marL="0" indent="0">
               <a:buNone/>
             </a:pPr>
             <a:r>
@@ -6109,7 +5869,7 @@
           <a:bodyPr wrap="square" lIns="0" tIns="0" rIns="0" bIns="0" rtlCol="0" anchor="ctr"/>
           <a:lstStyle/>
           <a:p>
-            <a:pPr indent="0" marL="0">
+            <a:pPr marL="0" indent="0">
               <a:buNone/>
             </a:pPr>
             <a:r>
@@ -6173,11 +5933,11 @@
           <a:bodyPr wrap="square" lIns="0" tIns="0" rIns="0" bIns="0" rtlCol="0" anchor="ctr"/>
           <a:lstStyle/>
           <a:p>
-            <a:pPr indent="0" marL="0">
-              <a:buNone/>
-            </a:pPr>
-            <a:r>
-              <a:rPr lang="en-US" sz="1100" b="1" spc="200" kern="0" dirty="0">
+            <a:pPr marL="0" indent="0">
+              <a:buNone/>
+            </a:pPr>
+            <a:r>
+              <a:rPr lang="en-US" sz="1100" b="1" kern="0" spc="200" dirty="0">
                 <a:solidFill>
                   <a:srgbClr val="5A5F6B"/>
                 </a:solidFill>
@@ -6212,7 +5972,7 @@
           <a:bodyPr wrap="square" lIns="0" tIns="0" rIns="0" bIns="0" rtlCol="0" anchor="ctr"/>
           <a:lstStyle/>
           <a:p>
-            <a:pPr indent="0" marL="0">
+            <a:pPr marL="0" indent="0">
               <a:buNone/>
             </a:pPr>
             <a:r>
@@ -6251,7 +6011,7 @@
           <a:bodyPr wrap="square" lIns="0" tIns="0" rIns="0" bIns="0" rtlCol="0" anchor="ctr"/>
           <a:lstStyle/>
           <a:p>
-            <a:pPr indent="0" marL="0">
+            <a:pPr marL="0" indent="0">
               <a:buNone/>
             </a:pPr>
             <a:r>
@@ -6265,9 +6025,6 @@
               </a:rPr>
               <a:t>Senior Product Manager, Microsoft 365 Data Platform.</a:t>
             </a:r>
-            <a:pPr indent="0" marL="0">
-              <a:buNone/>
-            </a:pPr>
             <a:r>
               <a:rPr lang="en-US" sz="1600" dirty="0">
                 <a:solidFill>
@@ -6304,7 +6061,7 @@
           <a:bodyPr wrap="square" lIns="0" tIns="0" rIns="0" bIns="0" rtlCol="0" anchor="ctr"/>
           <a:lstStyle/>
           <a:p>
-            <a:pPr indent="0" marL="0">
+            <a:pPr marL="0" indent="0">
               <a:buNone/>
             </a:pPr>
             <a:r>
@@ -6316,11 +6073,8 @@
                 <a:ea typeface="Calibri" pitchFamily="34" charset="-122"/>
                 <a:cs typeface="Calibri" pitchFamily="34" charset="-120"/>
               </a:rPr>
-              <a:t>Mu Sigma  →  Bing Ads  →  Azure Event Hubs  →  Microsoft 365.</a:t>
-            </a:r>
-            <a:pPr indent="0" marL="0">
-              <a:buNone/>
-            </a:pPr>
+              <a:t>Mu Sigma  →  Bing Ads  →  Azure Messaging  →  Microsoft 365.</a:t>
+            </a:r>
             <a:r>
               <a:rPr lang="en-US" sz="1600" dirty="0">
                 <a:solidFill>
@@ -6362,6 +6116,13 @@
             <a:prstDash val="solid"/>
           </a:ln>
         </p:spPr>
+        <p:txBody>
+          <a:bodyPr/>
+          <a:lstStyle/>
+          <a:p>
+            <a:endParaRPr lang="en-US"/>
+          </a:p>
+        </p:txBody>
       </p:sp>
       <p:sp>
         <p:nvSpPr>
@@ -6384,7 +6145,7 @@
           <a:bodyPr wrap="square" lIns="0" tIns="0" rIns="0" bIns="0" rtlCol="0" anchor="ctr"/>
           <a:lstStyle/>
           <a:p>
-            <a:pPr indent="0" marL="0">
+            <a:pPr marL="0" indent="0">
               <a:lnSpc>
                 <a:spcPts val="3200"/>
               </a:lnSpc>
@@ -6404,7 +6165,7 @@
             <a:endParaRPr lang="en-US" sz="2700" dirty="0"/>
           </a:p>
           <a:p>
-            <a:pPr indent="0" marL="0">
+            <a:pPr marL="0" indent="0">
               <a:lnSpc>
                 <a:spcPts val="3200"/>
               </a:lnSpc>
@@ -6451,6 +6212,13 @@
             <a:prstDash val="solid"/>
           </a:ln>
         </p:spPr>
+        <p:txBody>
+          <a:bodyPr/>
+          <a:lstStyle/>
+          <a:p>
+            <a:endParaRPr lang="en-US"/>
+          </a:p>
+        </p:txBody>
       </p:sp>
       <p:sp>
         <p:nvSpPr>
@@ -6473,7 +6241,7 @@
           <a:bodyPr wrap="square" lIns="0" tIns="0" rIns="0" bIns="0" rtlCol="0" anchor="ctr"/>
           <a:lstStyle/>
           <a:p>
-            <a:pPr indent="0" marL="0">
+            <a:pPr marL="0" indent="0">
               <a:lnSpc>
                 <a:spcPts val="3200"/>
               </a:lnSpc>
@@ -6493,7 +6261,7 @@
             <a:endParaRPr lang="en-US" sz="2700" dirty="0"/>
           </a:p>
           <a:p>
-            <a:pPr indent="0" marL="0">
+            <a:pPr marL="0" indent="0">
               <a:lnSpc>
                 <a:spcPts val="3200"/>
               </a:lnSpc>
@@ -6540,6 +6308,13 @@
             <a:prstDash val="solid"/>
           </a:ln>
         </p:spPr>
+        <p:txBody>
+          <a:bodyPr/>
+          <a:lstStyle/>
+          <a:p>
+            <a:endParaRPr lang="en-US"/>
+          </a:p>
+        </p:txBody>
       </p:sp>
       <p:sp>
         <p:nvSpPr>
@@ -6562,7 +6337,7 @@
           <a:bodyPr wrap="square" lIns="0" tIns="0" rIns="0" bIns="0" rtlCol="0" anchor="ctr"/>
           <a:lstStyle/>
           <a:p>
-            <a:pPr indent="0" marL="0">
+            <a:pPr marL="0" indent="0">
               <a:lnSpc>
                 <a:spcPts val="3200"/>
               </a:lnSpc>
@@ -6609,6 +6384,13 @@
             <a:prstDash val="solid"/>
           </a:ln>
         </p:spPr>
+        <p:txBody>
+          <a:bodyPr/>
+          <a:lstStyle/>
+          <a:p>
+            <a:endParaRPr lang="en-US"/>
+          </a:p>
+        </p:txBody>
       </p:sp>
       <p:sp>
         <p:nvSpPr>
@@ -6631,7 +6413,7 @@
           <a:bodyPr wrap="square" lIns="0" tIns="0" rIns="0" bIns="0" rtlCol="0" anchor="ctr"/>
           <a:lstStyle/>
           <a:p>
-            <a:pPr indent="0" marL="0">
+            <a:pPr marL="0" indent="0">
               <a:buNone/>
             </a:pPr>
             <a:r>
@@ -6695,11 +6477,11 @@
           <a:bodyPr wrap="square" lIns="0" tIns="0" rIns="0" bIns="0" rtlCol="0" anchor="ctr"/>
           <a:lstStyle/>
           <a:p>
-            <a:pPr indent="0" marL="0">
-              <a:buNone/>
-            </a:pPr>
-            <a:r>
-              <a:rPr lang="en-US" sz="1100" b="1" spc="200" kern="0" dirty="0">
+            <a:pPr marL="0" indent="0">
+              <a:buNone/>
+            </a:pPr>
+            <a:r>
+              <a:rPr lang="en-US" sz="1100" b="1" kern="0" spc="200" dirty="0">
                 <a:solidFill>
                   <a:srgbClr val="5A5F6B"/>
                 </a:solidFill>
@@ -6734,7 +6516,7 @@
           <a:bodyPr wrap="square" lIns="0" tIns="0" rIns="0" bIns="0" rtlCol="0" anchor="ctr"/>
           <a:lstStyle/>
           <a:p>
-            <a:pPr indent="0" marL="0">
+            <a:pPr marL="0" indent="0">
               <a:buNone/>
             </a:pPr>
             <a:r>
@@ -6778,6 +6560,13 @@
             <a:prstDash val="solid"/>
           </a:ln>
         </p:spPr>
+        <p:txBody>
+          <a:bodyPr/>
+          <a:lstStyle/>
+          <a:p>
+            <a:endParaRPr lang="en-US"/>
+          </a:p>
+        </p:txBody>
       </p:sp>
       <p:sp>
         <p:nvSpPr>
@@ -6800,7 +6589,7 @@
           <a:bodyPr wrap="square" lIns="0" tIns="0" rIns="0" bIns="0" rtlCol="0" anchor="ctr"/>
           <a:lstStyle/>
           <a:p>
-            <a:pPr indent="0" marL="0">
+            <a:pPr marL="0" indent="0">
               <a:buNone/>
             </a:pPr>
             <a:r>
@@ -6839,7 +6628,7 @@
           <a:bodyPr wrap="square" lIns="0" tIns="0" rIns="0" bIns="0" rtlCol="0" anchor="ctr"/>
           <a:lstStyle/>
           <a:p>
-            <a:pPr indent="0" marL="0">
+            <a:pPr marL="0" indent="0">
               <a:buNone/>
             </a:pPr>
             <a:r>
@@ -6878,7 +6667,7 @@
           <a:bodyPr wrap="square" lIns="0" tIns="0" rIns="0" bIns="0" rtlCol="0" anchor="ctr"/>
           <a:lstStyle/>
           <a:p>
-            <a:pPr algn="ctr" indent="0" marL="0">
+            <a:pPr marL="0" indent="0" algn="ctr">
               <a:buNone/>
             </a:pPr>
             <a:r>
@@ -6922,6 +6711,13 @@
             <a:prstDash val="solid"/>
           </a:ln>
         </p:spPr>
+        <p:txBody>
+          <a:bodyPr/>
+          <a:lstStyle/>
+          <a:p>
+            <a:endParaRPr lang="en-US"/>
+          </a:p>
+        </p:txBody>
       </p:sp>
       <p:sp>
         <p:nvSpPr>
@@ -6944,7 +6740,7 @@
           <a:bodyPr wrap="square" lIns="0" tIns="0" rIns="0" bIns="0" rtlCol="0" anchor="ctr"/>
           <a:lstStyle/>
           <a:p>
-            <a:pPr indent="0" marL="0">
+            <a:pPr marL="0" indent="0">
               <a:buNone/>
             </a:pPr>
             <a:r>
@@ -6983,7 +6779,7 @@
           <a:bodyPr wrap="square" lIns="0" tIns="0" rIns="0" bIns="0" rtlCol="0" anchor="ctr"/>
           <a:lstStyle/>
           <a:p>
-            <a:pPr indent="0" marL="0">
+            <a:pPr marL="0" indent="0">
               <a:buNone/>
             </a:pPr>
             <a:r>
@@ -7022,7 +6818,7 @@
           <a:bodyPr wrap="square" lIns="0" tIns="0" rIns="0" bIns="0" rtlCol="0" anchor="ctr"/>
           <a:lstStyle/>
           <a:p>
-            <a:pPr algn="ctr" indent="0" marL="0">
+            <a:pPr marL="0" indent="0" algn="ctr">
               <a:buNone/>
             </a:pPr>
             <a:r>
@@ -7066,6 +6862,13 @@
             <a:prstDash val="solid"/>
           </a:ln>
         </p:spPr>
+        <p:txBody>
+          <a:bodyPr/>
+          <a:lstStyle/>
+          <a:p>
+            <a:endParaRPr lang="en-US"/>
+          </a:p>
+        </p:txBody>
       </p:sp>
       <p:sp>
         <p:nvSpPr>
@@ -7088,7 +6891,7 @@
           <a:bodyPr wrap="square" lIns="0" tIns="0" rIns="0" bIns="0" rtlCol="0" anchor="ctr"/>
           <a:lstStyle/>
           <a:p>
-            <a:pPr indent="0" marL="0">
+            <a:pPr marL="0" indent="0">
               <a:buNone/>
             </a:pPr>
             <a:r>
@@ -7127,7 +6930,7 @@
           <a:bodyPr wrap="square" lIns="0" tIns="0" rIns="0" bIns="0" rtlCol="0" anchor="ctr"/>
           <a:lstStyle/>
           <a:p>
-            <a:pPr indent="0" marL="0">
+            <a:pPr marL="0" indent="0">
               <a:buNone/>
             </a:pPr>
             <a:r>
@@ -7166,7 +6969,7 @@
           <a:bodyPr wrap="square" lIns="0" tIns="0" rIns="0" bIns="0" rtlCol="0" anchor="ctr"/>
           <a:lstStyle/>
           <a:p>
-            <a:pPr algn="ctr" indent="0" marL="0">
+            <a:pPr marL="0" indent="0" algn="ctr">
               <a:buNone/>
             </a:pPr>
             <a:r>
@@ -7210,6 +7013,13 @@
             <a:prstDash val="solid"/>
           </a:ln>
         </p:spPr>
+        <p:txBody>
+          <a:bodyPr/>
+          <a:lstStyle/>
+          <a:p>
+            <a:endParaRPr lang="en-US"/>
+          </a:p>
+        </p:txBody>
       </p:sp>
       <p:sp>
         <p:nvSpPr>
@@ -7232,7 +7042,7 @@
           <a:bodyPr wrap="square" lIns="0" tIns="0" rIns="0" bIns="0" rtlCol="0" anchor="ctr"/>
           <a:lstStyle/>
           <a:p>
-            <a:pPr indent="0" marL="0">
+            <a:pPr marL="0" indent="0">
               <a:buNone/>
             </a:pPr>
             <a:r>
@@ -7271,7 +7081,7 @@
           <a:bodyPr wrap="square" lIns="0" tIns="0" rIns="0" bIns="0" rtlCol="0" anchor="ctr"/>
           <a:lstStyle/>
           <a:p>
-            <a:pPr indent="0" marL="0">
+            <a:pPr marL="0" indent="0">
               <a:buNone/>
             </a:pPr>
             <a:r>
@@ -7310,7 +7120,7 @@
           <a:bodyPr wrap="square" lIns="0" tIns="0" rIns="0" bIns="0" rtlCol="0" anchor="ctr"/>
           <a:lstStyle/>
           <a:p>
-            <a:pPr algn="ctr" indent="0" marL="0">
+            <a:pPr marL="0" indent="0" algn="ctr">
               <a:buNone/>
             </a:pPr>
             <a:r>
@@ -7354,6 +7164,13 @@
             <a:prstDash val="solid"/>
           </a:ln>
         </p:spPr>
+        <p:txBody>
+          <a:bodyPr/>
+          <a:lstStyle/>
+          <a:p>
+            <a:endParaRPr lang="en-US"/>
+          </a:p>
+        </p:txBody>
       </p:sp>
       <p:sp>
         <p:nvSpPr>
@@ -7376,7 +7193,7 @@
           <a:bodyPr wrap="square" lIns="0" tIns="0" rIns="0" bIns="0" rtlCol="0" anchor="ctr"/>
           <a:lstStyle/>
           <a:p>
-            <a:pPr indent="0" marL="0">
+            <a:pPr marL="0" indent="0">
               <a:buNone/>
             </a:pPr>
             <a:r>
@@ -7415,7 +7232,7 @@
           <a:bodyPr wrap="square" lIns="0" tIns="0" rIns="0" bIns="0" rtlCol="0" anchor="ctr"/>
           <a:lstStyle/>
           <a:p>
-            <a:pPr indent="0" marL="0">
+            <a:pPr marL="0" indent="0">
               <a:buNone/>
             </a:pPr>
             <a:r>
@@ -7432,7 +7249,7 @@
             <a:endParaRPr lang="en-US" sz="1200" dirty="0"/>
           </a:p>
           <a:p>
-            <a:pPr indent="0" marL="0">
+            <a:pPr marL="0" indent="0">
               <a:buNone/>
             </a:pPr>
             <a:r>
@@ -7471,7 +7288,7 @@
           <a:bodyPr wrap="square" lIns="0" tIns="0" rIns="0" bIns="0" rtlCol="0" anchor="ctr"/>
           <a:lstStyle/>
           <a:p>
-            <a:pPr indent="0" marL="0">
+            <a:pPr marL="0" indent="0">
               <a:buNone/>
             </a:pPr>
             <a:r>
@@ -7485,9 +7302,6 @@
               </a:rPr>
               <a:t>More than half</a:t>
             </a:r>
-            <a:pPr indent="0" marL="0">
-              <a:buNone/>
-            </a:pPr>
             <a:r>
               <a:rPr lang="en-US" sz="1700" dirty="0">
                 <a:solidFill>
@@ -7524,7 +7338,7 @@
           <a:bodyPr wrap="square" lIns="0" tIns="0" rIns="0" bIns="0" rtlCol="0" anchor="ctr"/>
           <a:lstStyle/>
           <a:p>
-            <a:pPr indent="0" marL="0">
+            <a:pPr marL="0" indent="0">
               <a:buNone/>
             </a:pPr>
             <a:r>
@@ -7588,11 +7402,11 @@
           <a:bodyPr wrap="square" lIns="0" tIns="0" rIns="0" bIns="0" rtlCol="0" anchor="ctr"/>
           <a:lstStyle/>
           <a:p>
-            <a:pPr indent="0" marL="0">
-              <a:buNone/>
-            </a:pPr>
-            <a:r>
-              <a:rPr lang="en-US" sz="1100" b="1" spc="200" kern="0" dirty="0">
+            <a:pPr marL="0" indent="0">
+              <a:buNone/>
+            </a:pPr>
+            <a:r>
+              <a:rPr lang="en-US" sz="1100" b="1" kern="0" spc="200" dirty="0">
                 <a:solidFill>
                   <a:srgbClr val="5A5F6B"/>
                 </a:solidFill>
@@ -7627,7 +7441,7 @@
           <a:bodyPr wrap="square" lIns="0" tIns="0" rIns="0" bIns="0" rtlCol="0" anchor="ctr"/>
           <a:lstStyle/>
           <a:p>
-            <a:pPr indent="0" marL="0">
+            <a:pPr marL="0" indent="0">
               <a:buNone/>
             </a:pPr>
             <a:r>
@@ -7671,6 +7485,13 @@
             <a:prstDash val="solid"/>
           </a:ln>
         </p:spPr>
+        <p:txBody>
+          <a:bodyPr/>
+          <a:lstStyle/>
+          <a:p>
+            <a:endParaRPr lang="en-US"/>
+          </a:p>
+        </p:txBody>
       </p:sp>
       <p:sp>
         <p:nvSpPr>
@@ -7693,7 +7514,7 @@
           <a:bodyPr wrap="square" lIns="0" tIns="0" rIns="0" bIns="0" rtlCol="0" anchor="ctr"/>
           <a:lstStyle/>
           <a:p>
-            <a:pPr algn="ctr" indent="0" marL="0">
+            <a:pPr marL="0" indent="0" algn="ctr">
               <a:buNone/>
             </a:pPr>
             <a:r>
@@ -7707,9 +7528,6 @@
               </a:rPr>
               <a:t>VRR</a:t>
             </a:r>
-            <a:pPr algn="ctr" indent="0" marL="0">
-              <a:buNone/>
-            </a:pPr>
             <a:r>
               <a:rPr lang="en-US" sz="1800" dirty="0">
                 <a:solidFill>
@@ -7721,9 +7539,6 @@
               </a:rPr>
               <a:t>   =   </a:t>
             </a:r>
-            <a:pPr algn="ctr" indent="0" marL="0">
-              <a:buNone/>
-            </a:pPr>
             <a:r>
               <a:rPr lang="en-US" sz="1800" dirty="0">
                 <a:solidFill>
@@ -7735,9 +7550,6 @@
               </a:rPr>
               <a:t>% of their features they use</a:t>
             </a:r>
-            <a:pPr algn="ctr" indent="0" marL="0">
-              <a:buNone/>
-            </a:pPr>
             <a:r>
               <a:rPr lang="en-US" sz="1800" dirty="0">
                 <a:solidFill>
@@ -7749,9 +7561,6 @@
               </a:rPr>
               <a:t>   ×   </a:t>
             </a:r>
-            <a:pPr algn="ctr" indent="0" marL="0">
-              <a:buNone/>
-            </a:pPr>
             <a:r>
               <a:rPr lang="en-US" sz="1800" dirty="0">
                 <a:solidFill>
@@ -7788,7 +7597,7 @@
           <a:bodyPr wrap="square" lIns="0" tIns="0" rIns="0" bIns="0" rtlCol="0" anchor="ctr"/>
           <a:lstStyle/>
           <a:p>
-            <a:pPr indent="0" marL="0">
+            <a:pPr marL="0" indent="0">
               <a:buNone/>
             </a:pPr>
             <a:r>
@@ -7830,6 +7639,13 @@
             <a:prstDash val="solid"/>
           </a:ln>
         </p:spPr>
+        <p:txBody>
+          <a:bodyPr/>
+          <a:lstStyle/>
+          <a:p>
+            <a:endParaRPr lang="en-US"/>
+          </a:p>
+        </p:txBody>
       </p:sp>
       <p:sp>
         <p:nvSpPr>
@@ -7855,6 +7671,13 @@
             <a:prstDash val="solid"/>
           </a:ln>
         </p:spPr>
+        <p:txBody>
+          <a:bodyPr/>
+          <a:lstStyle/>
+          <a:p>
+            <a:endParaRPr lang="en-US"/>
+          </a:p>
+        </p:txBody>
       </p:sp>
       <p:sp>
         <p:nvSpPr>
@@ -7877,7 +7700,7 @@
           <a:bodyPr wrap="square" lIns="0" tIns="0" rIns="0" bIns="0" rtlCol="0" anchor="ctr"/>
           <a:lstStyle/>
           <a:p>
-            <a:pPr algn="ctr" indent="0" marL="0">
+            <a:pPr marL="0" indent="0" algn="ctr">
               <a:buNone/>
             </a:pPr>
             <a:r>
@@ -7916,7 +7739,7 @@
           <a:bodyPr wrap="square" lIns="0" tIns="0" rIns="0" bIns="0" rtlCol="0" anchor="ctr"/>
           <a:lstStyle/>
           <a:p>
-            <a:pPr indent="0" marL="0">
+            <a:pPr marL="0" indent="0">
               <a:buNone/>
             </a:pPr>
             <a:r>
@@ -7955,7 +7778,7 @@
           <a:bodyPr wrap="square" lIns="0" tIns="0" rIns="0" bIns="0" rtlCol="0" anchor="ctr"/>
           <a:lstStyle/>
           <a:p>
-            <a:pPr algn="ctr" indent="0" marL="0">
+            <a:pPr marL="0" indent="0" algn="ctr">
               <a:buNone/>
             </a:pPr>
             <a:r>
@@ -7994,7 +7817,7 @@
           <a:bodyPr wrap="square" lIns="0" tIns="0" rIns="0" bIns="0" rtlCol="0" anchor="ctr"/>
           <a:lstStyle/>
           <a:p>
-            <a:pPr indent="0" marL="0">
+            <a:pPr marL="0" indent="0">
               <a:buNone/>
             </a:pPr>
             <a:r>
@@ -8033,7 +7856,7 @@
           <a:bodyPr wrap="square" lIns="0" tIns="0" rIns="0" bIns="0" rtlCol="0" anchor="ctr"/>
           <a:lstStyle/>
           <a:p>
-            <a:pPr indent="0" marL="0">
+            <a:pPr marL="0" indent="0">
               <a:buNone/>
             </a:pPr>
             <a:r>
@@ -8077,6 +7900,13 @@
             <a:prstDash val="solid"/>
           </a:ln>
         </p:spPr>
+        <p:txBody>
+          <a:bodyPr/>
+          <a:lstStyle/>
+          <a:p>
+            <a:endParaRPr lang="en-US"/>
+          </a:p>
+        </p:txBody>
       </p:sp>
       <p:sp>
         <p:nvSpPr>
@@ -8099,7 +7929,7 @@
           <a:bodyPr wrap="square" lIns="0" tIns="0" rIns="0" bIns="0" rtlCol="0" anchor="ctr"/>
           <a:lstStyle/>
           <a:p>
-            <a:pPr indent="0" marL="0">
+            <a:pPr marL="0" indent="0">
               <a:buNone/>
             </a:pPr>
             <a:r>
@@ -8138,7 +7968,7 @@
           <a:bodyPr wrap="square" lIns="0" tIns="0" rIns="0" bIns="0" rtlCol="0" anchor="ctr"/>
           <a:lstStyle/>
           <a:p>
-            <a:pPr indent="0" marL="0">
+            <a:pPr marL="0" indent="0">
               <a:buNone/>
             </a:pPr>
             <a:r>
@@ -8177,7 +8007,7 @@
           <a:bodyPr wrap="square" lIns="0" tIns="0" rIns="0" bIns="0" rtlCol="0" anchor="ctr"/>
           <a:lstStyle/>
           <a:p>
-            <a:pPr algn="r" indent="0" marL="0">
+            <a:pPr marL="0" indent="0" algn="r">
               <a:buNone/>
             </a:pPr>
             <a:r>
@@ -8221,6 +8051,13 @@
             <a:prstDash val="solid"/>
           </a:ln>
         </p:spPr>
+        <p:txBody>
+          <a:bodyPr/>
+          <a:lstStyle/>
+          <a:p>
+            <a:endParaRPr lang="en-US"/>
+          </a:p>
+        </p:txBody>
       </p:sp>
       <p:sp>
         <p:nvSpPr>
@@ -8243,7 +8080,7 @@
           <a:bodyPr wrap="square" lIns="0" tIns="0" rIns="0" bIns="0" rtlCol="0" anchor="ctr"/>
           <a:lstStyle/>
           <a:p>
-            <a:pPr indent="0" marL="0">
+            <a:pPr marL="0" indent="0">
               <a:buNone/>
             </a:pPr>
             <a:r>
@@ -8282,7 +8119,7 @@
           <a:bodyPr wrap="square" lIns="0" tIns="0" rIns="0" bIns="0" rtlCol="0" anchor="ctr"/>
           <a:lstStyle/>
           <a:p>
-            <a:pPr indent="0" marL="0">
+            <a:pPr marL="0" indent="0">
               <a:buNone/>
             </a:pPr>
             <a:r>
@@ -8321,7 +8158,7 @@
           <a:bodyPr wrap="square" lIns="0" tIns="0" rIns="0" bIns="0" rtlCol="0" anchor="ctr"/>
           <a:lstStyle/>
           <a:p>
-            <a:pPr algn="r" indent="0" marL="0">
+            <a:pPr marL="0" indent="0" algn="r">
               <a:buNone/>
             </a:pPr>
             <a:r>
@@ -8365,6 +8202,13 @@
             <a:prstDash val="solid"/>
           </a:ln>
         </p:spPr>
+        <p:txBody>
+          <a:bodyPr/>
+          <a:lstStyle/>
+          <a:p>
+            <a:endParaRPr lang="en-US"/>
+          </a:p>
+        </p:txBody>
       </p:sp>
       <p:sp>
         <p:nvSpPr>
@@ -8387,7 +8231,7 @@
           <a:bodyPr wrap="square" lIns="0" tIns="0" rIns="0" bIns="0" rtlCol="0" anchor="ctr"/>
           <a:lstStyle/>
           <a:p>
-            <a:pPr indent="0" marL="0">
+            <a:pPr marL="0" indent="0">
               <a:buNone/>
             </a:pPr>
             <a:r>
@@ -8426,7 +8270,7 @@
           <a:bodyPr wrap="square" lIns="0" tIns="0" rIns="0" bIns="0" rtlCol="0" anchor="ctr"/>
           <a:lstStyle/>
           <a:p>
-            <a:pPr indent="0" marL="0">
+            <a:pPr marL="0" indent="0">
               <a:buNone/>
             </a:pPr>
             <a:r>
@@ -8465,7 +8309,7 @@
           <a:bodyPr wrap="square" lIns="0" tIns="0" rIns="0" bIns="0" rtlCol="0" anchor="ctr"/>
           <a:lstStyle/>
           <a:p>
-            <a:pPr algn="r" indent="0" marL="0">
+            <a:pPr marL="0" indent="0" algn="r">
               <a:buNone/>
             </a:pPr>
             <a:r>
@@ -8509,6 +8353,13 @@
             <a:prstDash val="solid"/>
           </a:ln>
         </p:spPr>
+        <p:txBody>
+          <a:bodyPr/>
+          <a:lstStyle/>
+          <a:p>
+            <a:endParaRPr lang="en-US"/>
+          </a:p>
+        </p:txBody>
       </p:sp>
       <p:sp>
         <p:nvSpPr>
@@ -8531,7 +8382,7 @@
           <a:bodyPr wrap="square" lIns="0" tIns="0" rIns="0" bIns="0" rtlCol="0" anchor="ctr"/>
           <a:lstStyle/>
           <a:p>
-            <a:pPr indent="0" marL="0">
+            <a:pPr marL="0" indent="0">
               <a:buNone/>
             </a:pPr>
             <a:r>
@@ -8575,6 +8426,13 @@
             <a:prstDash val="solid"/>
           </a:ln>
         </p:spPr>
+        <p:txBody>
+          <a:bodyPr/>
+          <a:lstStyle/>
+          <a:p>
+            <a:endParaRPr lang="en-US"/>
+          </a:p>
+        </p:txBody>
       </p:sp>
       <p:sp>
         <p:nvSpPr>
@@ -8597,7 +8455,7 @@
           <a:bodyPr wrap="square" lIns="0" tIns="0" rIns="0" bIns="0" rtlCol="0" anchor="ctr"/>
           <a:lstStyle/>
           <a:p>
-            <a:pPr indent="0" marL="0">
+            <a:pPr marL="0" indent="0">
               <a:buNone/>
             </a:pPr>
             <a:r>
@@ -8636,7 +8494,7 @@
           <a:bodyPr wrap="square" lIns="0" tIns="0" rIns="0" bIns="0" rtlCol="0" anchor="ctr"/>
           <a:lstStyle/>
           <a:p>
-            <a:pPr indent="0" marL="0">
+            <a:pPr marL="0" indent="0">
               <a:buNone/>
             </a:pPr>
             <a:r>
@@ -8680,6 +8538,13 @@
             <a:prstDash val="solid"/>
           </a:ln>
         </p:spPr>
+        <p:txBody>
+          <a:bodyPr/>
+          <a:lstStyle/>
+          <a:p>
+            <a:endParaRPr lang="en-US"/>
+          </a:p>
+        </p:txBody>
       </p:sp>
       <p:sp>
         <p:nvSpPr>
@@ -8702,7 +8567,7 @@
           <a:bodyPr wrap="square" lIns="0" tIns="0" rIns="0" bIns="0" rtlCol="0" anchor="ctr"/>
           <a:lstStyle/>
           <a:p>
-            <a:pPr indent="0" marL="0">
+            <a:pPr marL="0" indent="0">
               <a:buNone/>
             </a:pPr>
             <a:r>
@@ -8741,7 +8606,7 @@
           <a:bodyPr wrap="square" lIns="0" tIns="0" rIns="0" bIns="0" rtlCol="0" anchor="ctr"/>
           <a:lstStyle/>
           <a:p>
-            <a:pPr indent="0" marL="0">
+            <a:pPr marL="0" indent="0">
               <a:buNone/>
             </a:pPr>
             <a:r>
@@ -8805,11 +8670,11 @@
           <a:bodyPr wrap="square" lIns="0" tIns="0" rIns="0" bIns="0" rtlCol="0" anchor="ctr"/>
           <a:lstStyle/>
           <a:p>
-            <a:pPr indent="0" marL="0">
-              <a:buNone/>
-            </a:pPr>
-            <a:r>
-              <a:rPr lang="en-US" sz="1100" b="1" spc="200" kern="0" dirty="0">
+            <a:pPr marL="0" indent="0">
+              <a:buNone/>
+            </a:pPr>
+            <a:r>
+              <a:rPr lang="en-US" sz="1100" b="1" kern="0" spc="200" dirty="0">
                 <a:solidFill>
                   <a:srgbClr val="5A5F6B"/>
                 </a:solidFill>
@@ -8844,7 +8709,7 @@
           <a:bodyPr wrap="square" lIns="0" tIns="0" rIns="0" bIns="0" rtlCol="0" anchor="ctr"/>
           <a:lstStyle/>
           <a:p>
-            <a:pPr indent="0" marL="0">
+            <a:pPr marL="0" indent="0">
               <a:buNone/>
             </a:pPr>
             <a:r>
@@ -8883,7 +8748,7 @@
           <a:bodyPr wrap="square" lIns="0" tIns="0" rIns="0" bIns="0" rtlCol="0" anchor="ctr"/>
           <a:lstStyle/>
           <a:p>
-            <a:pPr indent="0" marL="0">
+            <a:pPr marL="0" indent="0">
               <a:buNone/>
             </a:pPr>
             <a:r>
@@ -8901,30 +8766,6 @@
           </a:p>
         </p:txBody>
       </p:sp>
-      <p:pic>
-        <p:nvPicPr>
-          <p:cNvPr id="5" name="Image 0" descr="docs/screenshots/crop_quadrant.png">    </p:cNvPr>
-          <p:cNvPicPr>
-            <a:picLocks noChangeAspect="1"/>
-          </p:cNvPicPr>
-          <p:nvPr/>
-        </p:nvPicPr>
-        <p:blipFill>
-          <a:blip r:embed="rId1"/>
-          <a:stretch>
-            <a:fillRect/>
-          </a:stretch>
-        </p:blipFill>
-        <p:spPr>
-          <a:xfrm>
-            <a:off x="548640" y="1920240"/>
-            <a:ext cx="6903720" cy="2606040"/>
-          </a:xfrm>
-          <a:prstGeom prst="rect">
-            <a:avLst/>
-          </a:prstGeom>
-        </p:spPr>
-      </p:pic>
       <p:sp>
         <p:nvSpPr>
           <p:cNvPr id="6" name="Shape 3"/>
@@ -8951,6 +8792,13 @@
             <a:prstDash val="solid"/>
           </a:ln>
         </p:spPr>
+        <p:txBody>
+          <a:bodyPr/>
+          <a:lstStyle/>
+          <a:p>
+            <a:endParaRPr lang="en-US"/>
+          </a:p>
+        </p:txBody>
       </p:sp>
       <p:sp>
         <p:nvSpPr>
@@ -8971,6 +8819,13 @@
           </a:solidFill>
           <a:ln/>
         </p:spPr>
+        <p:txBody>
+          <a:bodyPr/>
+          <a:lstStyle/>
+          <a:p>
+            <a:endParaRPr lang="en-US"/>
+          </a:p>
+        </p:txBody>
       </p:sp>
       <p:sp>
         <p:nvSpPr>
@@ -8993,7 +8848,7 @@
           <a:bodyPr wrap="square" lIns="0" tIns="0" rIns="0" bIns="0" rtlCol="0" anchor="ctr"/>
           <a:lstStyle/>
           <a:p>
-            <a:pPr indent="0" marL="0">
+            <a:pPr marL="0" indent="0">
               <a:buNone/>
             </a:pPr>
             <a:r>
@@ -9032,7 +8887,7 @@
           <a:bodyPr wrap="square" lIns="0" tIns="0" rIns="0" bIns="0" rtlCol="0" anchor="ctr"/>
           <a:lstStyle/>
           <a:p>
-            <a:pPr algn="r" indent="0" marL="0">
+            <a:pPr marL="0" indent="0" algn="r">
               <a:buNone/>
             </a:pPr>
             <a:r>
@@ -9071,7 +8926,7 @@
           <a:bodyPr wrap="square" lIns="0" tIns="0" rIns="0" bIns="0" rtlCol="0" anchor="ctr"/>
           <a:lstStyle/>
           <a:p>
-            <a:pPr indent="0" marL="0">
+            <a:pPr marL="0" indent="0">
               <a:buNone/>
             </a:pPr>
             <a:r>
@@ -9115,6 +8970,13 @@
             <a:prstDash val="solid"/>
           </a:ln>
         </p:spPr>
+        <p:txBody>
+          <a:bodyPr/>
+          <a:lstStyle/>
+          <a:p>
+            <a:endParaRPr lang="en-US"/>
+          </a:p>
+        </p:txBody>
       </p:sp>
       <p:sp>
         <p:nvSpPr>
@@ -9135,6 +8997,13 @@
           </a:solidFill>
           <a:ln/>
         </p:spPr>
+        <p:txBody>
+          <a:bodyPr/>
+          <a:lstStyle/>
+          <a:p>
+            <a:endParaRPr lang="en-US"/>
+          </a:p>
+        </p:txBody>
       </p:sp>
       <p:sp>
         <p:nvSpPr>
@@ -9157,7 +9026,7 @@
           <a:bodyPr wrap="square" lIns="0" tIns="0" rIns="0" bIns="0" rtlCol="0" anchor="ctr"/>
           <a:lstStyle/>
           <a:p>
-            <a:pPr indent="0" marL="0">
+            <a:pPr marL="0" indent="0">
               <a:buNone/>
             </a:pPr>
             <a:r>
@@ -9196,7 +9065,7 @@
           <a:bodyPr wrap="square" lIns="0" tIns="0" rIns="0" bIns="0" rtlCol="0" anchor="ctr"/>
           <a:lstStyle/>
           <a:p>
-            <a:pPr algn="r" indent="0" marL="0">
+            <a:pPr marL="0" indent="0" algn="r">
               <a:buNone/>
             </a:pPr>
             <a:r>
@@ -9235,7 +9104,7 @@
           <a:bodyPr wrap="square" lIns="0" tIns="0" rIns="0" bIns="0" rtlCol="0" anchor="ctr"/>
           <a:lstStyle/>
           <a:p>
-            <a:pPr indent="0" marL="0">
+            <a:pPr marL="0" indent="0">
               <a:buNone/>
             </a:pPr>
             <a:r>
@@ -9279,6 +9148,13 @@
             <a:prstDash val="solid"/>
           </a:ln>
         </p:spPr>
+        <p:txBody>
+          <a:bodyPr/>
+          <a:lstStyle/>
+          <a:p>
+            <a:endParaRPr lang="en-US"/>
+          </a:p>
+        </p:txBody>
       </p:sp>
       <p:sp>
         <p:nvSpPr>
@@ -9299,6 +9175,13 @@
           </a:solidFill>
           <a:ln/>
         </p:spPr>
+        <p:txBody>
+          <a:bodyPr/>
+          <a:lstStyle/>
+          <a:p>
+            <a:endParaRPr lang="en-US"/>
+          </a:p>
+        </p:txBody>
       </p:sp>
       <p:sp>
         <p:nvSpPr>
@@ -9321,7 +9204,7 @@
           <a:bodyPr wrap="square" lIns="0" tIns="0" rIns="0" bIns="0" rtlCol="0" anchor="ctr"/>
           <a:lstStyle/>
           <a:p>
-            <a:pPr indent="0" marL="0">
+            <a:pPr marL="0" indent="0">
               <a:buNone/>
             </a:pPr>
             <a:r>
@@ -9360,7 +9243,7 @@
           <a:bodyPr wrap="square" lIns="0" tIns="0" rIns="0" bIns="0" rtlCol="0" anchor="ctr"/>
           <a:lstStyle/>
           <a:p>
-            <a:pPr algn="r" indent="0" marL="0">
+            <a:pPr marL="0" indent="0" algn="r">
               <a:buNone/>
             </a:pPr>
             <a:r>
@@ -9399,7 +9282,7 @@
           <a:bodyPr wrap="square" lIns="0" tIns="0" rIns="0" bIns="0" rtlCol="0" anchor="ctr"/>
           <a:lstStyle/>
           <a:p>
-            <a:pPr indent="0" marL="0">
+            <a:pPr marL="0" indent="0">
               <a:buNone/>
             </a:pPr>
             <a:r>
@@ -9443,6 +9326,13 @@
             <a:prstDash val="solid"/>
           </a:ln>
         </p:spPr>
+        <p:txBody>
+          <a:bodyPr/>
+          <a:lstStyle/>
+          <a:p>
+            <a:endParaRPr lang="en-US"/>
+          </a:p>
+        </p:txBody>
       </p:sp>
       <p:sp>
         <p:nvSpPr>
@@ -9463,6 +9353,13 @@
           </a:solidFill>
           <a:ln/>
         </p:spPr>
+        <p:txBody>
+          <a:bodyPr/>
+          <a:lstStyle/>
+          <a:p>
+            <a:endParaRPr lang="en-US"/>
+          </a:p>
+        </p:txBody>
       </p:sp>
       <p:sp>
         <p:nvSpPr>
@@ -9485,7 +9382,7 @@
           <a:bodyPr wrap="square" lIns="0" tIns="0" rIns="0" bIns="0" rtlCol="0" anchor="ctr"/>
           <a:lstStyle/>
           <a:p>
-            <a:pPr indent="0" marL="0">
+            <a:pPr marL="0" indent="0">
               <a:buNone/>
             </a:pPr>
             <a:r>
@@ -9524,7 +9421,7 @@
           <a:bodyPr wrap="square" lIns="0" tIns="0" rIns="0" bIns="0" rtlCol="0" anchor="ctr"/>
           <a:lstStyle/>
           <a:p>
-            <a:pPr algn="r" indent="0" marL="0">
+            <a:pPr marL="0" indent="0" algn="r">
               <a:buNone/>
             </a:pPr>
             <a:r>
@@ -9563,7 +9460,7 @@
           <a:bodyPr wrap="square" lIns="0" tIns="0" rIns="0" bIns="0" rtlCol="0" anchor="ctr"/>
           <a:lstStyle/>
           <a:p>
-            <a:pPr indent="0" marL="0">
+            <a:pPr marL="0" indent="0">
               <a:buNone/>
             </a:pPr>
             <a:r>
@@ -9607,6 +9504,13 @@
             <a:prstDash val="solid"/>
           </a:ln>
         </p:spPr>
+        <p:txBody>
+          <a:bodyPr/>
+          <a:lstStyle/>
+          <a:p>
+            <a:endParaRPr lang="en-US"/>
+          </a:p>
+        </p:txBody>
       </p:sp>
       <p:sp>
         <p:nvSpPr>
@@ -9629,7 +9533,7 @@
           <a:bodyPr wrap="square" lIns="0" tIns="0" rIns="0" bIns="0" rtlCol="0" anchor="ctr"/>
           <a:lstStyle/>
           <a:p>
-            <a:pPr indent="0" marL="0">
+            <a:pPr marL="0" indent="0">
               <a:buNone/>
             </a:pPr>
             <a:r>
@@ -9668,7 +9572,7 @@
           <a:bodyPr wrap="square" lIns="0" tIns="0" rIns="0" bIns="0" rtlCol="0" anchor="ctr"/>
           <a:lstStyle/>
           <a:p>
-            <a:pPr indent="0" marL="0">
+            <a:pPr marL="0" indent="0">
               <a:buNone/>
             </a:pPr>
             <a:r>
@@ -9686,6 +9590,36 @@
           </a:p>
         </p:txBody>
       </p:sp>
+      <p:pic>
+        <p:nvPicPr>
+          <p:cNvPr id="29" name="Picture 28">
+            <a:extLst>
+              <a:ext uri="{FF2B5EF4-FFF2-40B4-BE49-F238E27FC236}">
+                <a16:creationId xmlns:a16="http://schemas.microsoft.com/office/drawing/2014/main" id="{23A4928A-26CB-9342-1F1B-07D42A2C8F06}"/>
+              </a:ext>
+            </a:extLst>
+          </p:cNvPr>
+          <p:cNvPicPr>
+            <a:picLocks noChangeAspect="1"/>
+          </p:cNvPicPr>
+          <p:nvPr/>
+        </p:nvPicPr>
+        <p:blipFill>
+          <a:blip r:embed="rId3"/>
+          <a:stretch>
+            <a:fillRect/>
+          </a:stretch>
+        </p:blipFill>
+        <p:spPr>
+          <a:xfrm>
+            <a:off x="548640" y="1866280"/>
+            <a:ext cx="7004304" cy="2721630"/>
+          </a:xfrm>
+          <a:prstGeom prst="rect">
+            <a:avLst/>
+          </a:prstGeom>
+        </p:spPr>
+      </p:pic>
     </p:spTree>
   </p:cSld>
   <p:clrMapOvr>
@@ -9732,11 +9666,11 @@
           <a:bodyPr wrap="square" lIns="0" tIns="0" rIns="0" bIns="0" rtlCol="0" anchor="ctr"/>
           <a:lstStyle/>
           <a:p>
-            <a:pPr indent="0" marL="0">
-              <a:buNone/>
-            </a:pPr>
-            <a:r>
-              <a:rPr lang="en-US" sz="1100" b="1" spc="200" kern="0" dirty="0">
+            <a:pPr marL="0" indent="0">
+              <a:buNone/>
+            </a:pPr>
+            <a:r>
+              <a:rPr lang="en-US" sz="1100" b="1" kern="0" spc="200" dirty="0">
                 <a:solidFill>
                   <a:srgbClr val="5A5F6B"/>
                 </a:solidFill>
@@ -9771,7 +9705,7 @@
           <a:bodyPr wrap="square" lIns="0" tIns="0" rIns="0" bIns="0" rtlCol="0" anchor="ctr"/>
           <a:lstStyle/>
           <a:p>
-            <a:pPr indent="0" marL="0">
+            <a:pPr marL="0" indent="0">
               <a:buNone/>
             </a:pPr>
             <a:r>
@@ -9791,14 +9725,14 @@
       </p:sp>
       <p:pic>
         <p:nvPicPr>
-          <p:cNvPr id="4" name="Image 0" descr="docs/screenshots/crop_depth.png">    </p:cNvPr>
+          <p:cNvPr id="4" name="Image 0" descr="docs/screenshots/crop_depth.png"/>
           <p:cNvPicPr>
             <a:picLocks noChangeAspect="1"/>
           </p:cNvPicPr>
           <p:nvPr/>
         </p:nvPicPr>
         <p:blipFill>
-          <a:blip r:embed="rId1"/>
+          <a:blip r:embed="rId3"/>
           <a:stretch>
             <a:fillRect/>
           </a:stretch>
@@ -9839,6 +9773,13 @@
             <a:prstDash val="solid"/>
           </a:ln>
         </p:spPr>
+        <p:txBody>
+          <a:bodyPr/>
+          <a:lstStyle/>
+          <a:p>
+            <a:endParaRPr lang="en-US"/>
+          </a:p>
+        </p:txBody>
       </p:sp>
       <p:sp>
         <p:nvSpPr>
@@ -9848,7 +9789,7 @@
         </p:nvSpPr>
         <p:spPr>
           <a:xfrm>
-            <a:off x="777240" y="4617720"/>
+            <a:off x="777240" y="4698104"/>
             <a:ext cx="1371600" cy="566928"/>
           </a:xfrm>
           <a:prstGeom prst="rect">
@@ -9861,7 +9802,7 @@
           <a:bodyPr wrap="square" lIns="0" tIns="0" rIns="0" bIns="0" rtlCol="0" anchor="ctr"/>
           <a:lstStyle/>
           <a:p>
-            <a:pPr indent="0" marL="0">
+            <a:pPr marL="0" indent="0">
               <a:buNone/>
             </a:pPr>
             <a:r>
@@ -9900,7 +9841,7 @@
           <a:bodyPr wrap="square" lIns="0" tIns="0" rIns="0" bIns="0" rtlCol="0" anchor="ctr"/>
           <a:lstStyle/>
           <a:p>
-            <a:pPr indent="0" marL="0">
+            <a:pPr marL="0" indent="0">
               <a:buNone/>
             </a:pPr>
             <a:r>
@@ -9912,7 +9853,7 @@
                 <a:ea typeface="Calibri" pitchFamily="34" charset="-122"/>
                 <a:cs typeface="Calibri" pitchFamily="34" charset="-120"/>
               </a:rPr>
-              <a:t>use every feature they bought</a:t>
+              <a:t>Fully deployed on the widest SKU (with 5 features)</a:t>
             </a:r>
             <a:endParaRPr lang="en-US" sz="1250" dirty="0"/>
           </a:p>
@@ -9944,6 +9885,13 @@
             <a:prstDash val="solid"/>
           </a:ln>
         </p:spPr>
+        <p:txBody>
+          <a:bodyPr/>
+          <a:lstStyle/>
+          <a:p>
+            <a:endParaRPr lang="en-US"/>
+          </a:p>
+        </p:txBody>
       </p:sp>
       <p:sp>
         <p:nvSpPr>
@@ -9953,7 +9901,7 @@
         </p:nvSpPr>
         <p:spPr>
           <a:xfrm>
-            <a:off x="4498848" y="4617720"/>
+            <a:off x="4498848" y="4678010"/>
             <a:ext cx="1371600" cy="566928"/>
           </a:xfrm>
           <a:prstGeom prst="rect">
@@ -9966,7 +9914,7 @@
           <a:bodyPr wrap="square" lIns="0" tIns="0" rIns="0" bIns="0" rtlCol="0" anchor="ctr"/>
           <a:lstStyle/>
           <a:p>
-            <a:pPr indent="0" marL="0">
+            <a:pPr marL="0" indent="0">
               <a:buNone/>
             </a:pPr>
             <a:r>
@@ -10005,7 +9953,7 @@
           <a:bodyPr wrap="square" lIns="0" tIns="0" rIns="0" bIns="0" rtlCol="0" anchor="ctr"/>
           <a:lstStyle/>
           <a:p>
-            <a:pPr indent="0" marL="0">
+            <a:pPr marL="0" indent="0">
               <a:buNone/>
             </a:pPr>
             <a:r>
@@ -10049,6 +9997,13 @@
             <a:prstDash val="solid"/>
           </a:ln>
         </p:spPr>
+        <p:txBody>
+          <a:bodyPr/>
+          <a:lstStyle/>
+          <a:p>
+            <a:endParaRPr lang="en-US"/>
+          </a:p>
+        </p:txBody>
       </p:sp>
       <p:sp>
         <p:nvSpPr>
@@ -10058,7 +10013,7 @@
         </p:nvSpPr>
         <p:spPr>
           <a:xfrm>
-            <a:off x="8220456" y="4617720"/>
+            <a:off x="8220456" y="4688056"/>
             <a:ext cx="1371600" cy="566928"/>
           </a:xfrm>
           <a:prstGeom prst="rect">
@@ -10071,7 +10026,7 @@
           <a:bodyPr wrap="square" lIns="0" tIns="0" rIns="0" bIns="0" rtlCol="0" anchor="ctr"/>
           <a:lstStyle/>
           <a:p>
-            <a:pPr indent="0" marL="0">
+            <a:pPr marL="0" indent="0">
               <a:buNone/>
             </a:pPr>
             <a:r>
@@ -10110,7 +10065,7 @@
           <a:bodyPr wrap="square" lIns="0" tIns="0" rIns="0" bIns="0" rtlCol="0" anchor="ctr"/>
           <a:lstStyle/>
           <a:p>
-            <a:pPr indent="0" marL="0">
+            <a:pPr marL="0" indent="0">
               <a:buNone/>
             </a:pPr>
             <a:r>
@@ -10130,80 +10085,13 @@
       </p:sp>
       <p:sp>
         <p:nvSpPr>
-          <p:cNvPr id="14" name="Text 11"/>
-          <p:cNvSpPr/>
-          <p:nvPr/>
-        </p:nvSpPr>
-        <p:spPr>
-          <a:xfrm>
-            <a:off x="548640" y="5742432"/>
-            <a:ext cx="11064240" cy="365760"/>
-          </a:xfrm>
-          <a:prstGeom prst="rect">
-            <a:avLst/>
-          </a:prstGeom>
-          <a:noFill/>
-          <a:ln/>
-        </p:spPr>
-        <p:txBody>
-          <a:bodyPr wrap="square" lIns="0" tIns="0" rIns="0" bIns="0" rtlCol="0" anchor="ctr"/>
-          <a:lstStyle/>
-          <a:p>
-            <a:pPr indent="0" marL="0">
-              <a:buNone/>
-            </a:pPr>
-            <a:r>
-              <a:rPr lang="en-US" sz="1400" dirty="0">
-                <a:solidFill>
-                  <a:srgbClr val="5A5F6B"/>
-                </a:solidFill>
-                <a:latin typeface="Calibri" pitchFamily="34" charset="0"/>
-                <a:ea typeface="Calibri" pitchFamily="34" charset="-122"/>
-                <a:cs typeface="Calibri" pitchFamily="34" charset="-120"/>
-              </a:rPr>
-              <a:t>Which is where the number from earlier comes from:  </a:t>
-            </a:r>
-            <a:pPr indent="0" marL="0">
-              <a:buNone/>
-            </a:pPr>
-            <a:r>
-              <a:rPr lang="en-US" sz="1800" b="1" dirty="0">
-                <a:solidFill>
-                  <a:srgbClr val="EB6834"/>
-                </a:solidFill>
-                <a:latin typeface="Calibri" pitchFamily="34" charset="0"/>
-                <a:ea typeface="Calibri" pitchFamily="34" charset="-122"/>
-                <a:cs typeface="Calibri" pitchFamily="34" charset="-120"/>
-              </a:rPr>
-              <a:t>$13.2M of $25M</a:t>
-            </a:r>
-            <a:pPr indent="0" marL="0">
-              <a:buNone/>
-            </a:pPr>
-            <a:r>
-              <a:rPr lang="en-US" sz="1400" dirty="0">
-                <a:solidFill>
-                  <a:srgbClr val="16181D"/>
-                </a:solidFill>
-                <a:latin typeface="Calibri" pitchFamily="34" charset="0"/>
-                <a:ea typeface="Calibri" pitchFamily="34" charset="-122"/>
-                <a:cs typeface="Calibri" pitchFamily="34" charset="-120"/>
-              </a:rPr>
-              <a:t>  in active contract value is not converting.</a:t>
-            </a:r>
-            <a:endParaRPr lang="en-US" sz="1400" dirty="0"/>
-          </a:p>
-        </p:txBody>
-      </p:sp>
-      <p:sp>
-        <p:nvSpPr>
           <p:cNvPr id="15" name="Text 12"/>
           <p:cNvSpPr/>
           <p:nvPr/>
         </p:nvSpPr>
         <p:spPr>
           <a:xfrm>
-            <a:off x="548640" y="6172200"/>
+            <a:off x="548640" y="5709977"/>
             <a:ext cx="11064240" cy="320040"/>
           </a:xfrm>
           <a:prstGeom prst="rect">
@@ -10216,7 +10104,7 @@
           <a:bodyPr wrap="square" lIns="0" tIns="0" rIns="0" bIns="0" rtlCol="0" anchor="ctr"/>
           <a:lstStyle/>
           <a:p>
-            <a:pPr indent="0" marL="0">
+            <a:pPr marL="0" indent="0">
               <a:buNone/>
             </a:pPr>
             <a:r>
@@ -10250,6 +10138,7 @@
         <a:solidFill>
           <a:srgbClr val="1E2761"/>
         </a:solidFill>
+        <a:effectLst/>
       </p:bgPr>
     </p:bg>
     <p:spTree>
@@ -10287,11 +10176,11 @@
           <a:bodyPr wrap="square" lIns="0" tIns="0" rIns="0" bIns="0" rtlCol="0" anchor="ctr"/>
           <a:lstStyle/>
           <a:p>
-            <a:pPr indent="0" marL="0">
-              <a:buNone/>
-            </a:pPr>
-            <a:r>
-              <a:rPr lang="en-US" sz="1200" b="1" spc="300" kern="0" dirty="0">
+            <a:pPr marL="0" indent="0">
+              <a:buNone/>
+            </a:pPr>
+            <a:r>
+              <a:rPr lang="en-US" sz="1200" b="1" kern="0" spc="300" dirty="0">
                 <a:solidFill>
                   <a:srgbClr val="EB6834"/>
                 </a:solidFill>
@@ -10326,7 +10215,7 @@
           <a:bodyPr wrap="square" lIns="0" tIns="0" rIns="0" bIns="0" rtlCol="0" anchor="ctr"/>
           <a:lstStyle/>
           <a:p>
-            <a:pPr indent="0" marL="0">
+            <a:pPr marL="0" indent="0">
               <a:buNone/>
             </a:pPr>
             <a:r>
@@ -10365,7 +10254,7 @@
           <a:bodyPr wrap="square" lIns="0" tIns="0" rIns="0" bIns="0" rtlCol="0" anchor="ctr"/>
           <a:lstStyle/>
           <a:p>
-            <a:pPr indent="0" marL="0">
+            <a:pPr marL="0" indent="0">
               <a:buNone/>
             </a:pPr>
             <a:r>
@@ -10402,6 +10291,13 @@
           </a:solidFill>
           <a:ln/>
         </p:spPr>
+        <p:txBody>
+          <a:bodyPr/>
+          <a:lstStyle/>
+          <a:p>
+            <a:endParaRPr lang="en-US"/>
+          </a:p>
+        </p:txBody>
       </p:sp>
       <p:sp>
         <p:nvSpPr>
@@ -10424,7 +10320,7 @@
           <a:bodyPr wrap="square" lIns="0" tIns="0" rIns="0" bIns="0" rtlCol="0" anchor="ctr"/>
           <a:lstStyle/>
           <a:p>
-            <a:pPr algn="ctr" indent="0" marL="0">
+            <a:pPr marL="0" indent="0" algn="ctr">
               <a:buNone/>
             </a:pPr>
             <a:r>
@@ -10463,7 +10359,7 @@
           <a:bodyPr wrap="square" lIns="0" tIns="0" rIns="0" bIns="0" rtlCol="0" anchor="ctr"/>
           <a:lstStyle/>
           <a:p>
-            <a:pPr indent="0" marL="0">
+            <a:pPr marL="0" indent="0">
               <a:buNone/>
             </a:pPr>
             <a:r>
@@ -10502,7 +10398,7 @@
           <a:bodyPr wrap="square" lIns="0" tIns="0" rIns="0" bIns="0" rtlCol="0" anchor="ctr"/>
           <a:lstStyle/>
           <a:p>
-            <a:pPr indent="0" marL="0">
+            <a:pPr marL="0" indent="0">
               <a:buNone/>
             </a:pPr>
             <a:r>
@@ -10539,6 +10435,13 @@
           </a:solidFill>
           <a:ln/>
         </p:spPr>
+        <p:txBody>
+          <a:bodyPr/>
+          <a:lstStyle/>
+          <a:p>
+            <a:endParaRPr lang="en-US"/>
+          </a:p>
+        </p:txBody>
       </p:sp>
       <p:sp>
         <p:nvSpPr>
@@ -10561,7 +10464,7 @@
           <a:bodyPr wrap="square" lIns="0" tIns="0" rIns="0" bIns="0" rtlCol="0" anchor="ctr"/>
           <a:lstStyle/>
           <a:p>
-            <a:pPr algn="ctr" indent="0" marL="0">
+            <a:pPr marL="0" indent="0" algn="ctr">
               <a:buNone/>
             </a:pPr>
             <a:r>
@@ -10600,7 +10503,7 @@
           <a:bodyPr wrap="square" lIns="0" tIns="0" rIns="0" bIns="0" rtlCol="0" anchor="ctr"/>
           <a:lstStyle/>
           <a:p>
-            <a:pPr indent="0" marL="0">
+            <a:pPr marL="0" indent="0">
               <a:buNone/>
             </a:pPr>
             <a:r>
@@ -10639,7 +10542,7 @@
           <a:bodyPr wrap="square" lIns="0" tIns="0" rIns="0" bIns="0" rtlCol="0" anchor="ctr"/>
           <a:lstStyle/>
           <a:p>
-            <a:pPr indent="0" marL="0">
+            <a:pPr marL="0" indent="0">
               <a:buNone/>
             </a:pPr>
             <a:r>
@@ -10676,6 +10579,13 @@
           </a:solidFill>
           <a:ln/>
         </p:spPr>
+        <p:txBody>
+          <a:bodyPr/>
+          <a:lstStyle/>
+          <a:p>
+            <a:endParaRPr lang="en-US"/>
+          </a:p>
+        </p:txBody>
       </p:sp>
       <p:sp>
         <p:nvSpPr>
@@ -10698,7 +10608,7 @@
           <a:bodyPr wrap="square" lIns="0" tIns="0" rIns="0" bIns="0" rtlCol="0" anchor="ctr"/>
           <a:lstStyle/>
           <a:p>
-            <a:pPr algn="ctr" indent="0" marL="0">
+            <a:pPr marL="0" indent="0" algn="ctr">
               <a:buNone/>
             </a:pPr>
             <a:r>
@@ -10737,7 +10647,7 @@
           <a:bodyPr wrap="square" lIns="0" tIns="0" rIns="0" bIns="0" rtlCol="0" anchor="ctr"/>
           <a:lstStyle/>
           <a:p>
-            <a:pPr indent="0" marL="0">
+            <a:pPr marL="0" indent="0">
               <a:buNone/>
             </a:pPr>
             <a:r>
@@ -10776,7 +10686,7 @@
           <a:bodyPr wrap="square" lIns="0" tIns="0" rIns="0" bIns="0" rtlCol="0" anchor="ctr"/>
           <a:lstStyle/>
           <a:p>
-            <a:pPr indent="0" marL="0">
+            <a:pPr marL="0" indent="0">
               <a:buNone/>
             </a:pPr>
             <a:r>
@@ -10813,6 +10723,13 @@
           </a:solidFill>
           <a:ln/>
         </p:spPr>
+        <p:txBody>
+          <a:bodyPr/>
+          <a:lstStyle/>
+          <a:p>
+            <a:endParaRPr lang="en-US"/>
+          </a:p>
+        </p:txBody>
       </p:sp>
       <p:sp>
         <p:nvSpPr>
@@ -10835,7 +10752,7 @@
           <a:bodyPr wrap="square" lIns="0" tIns="0" rIns="0" bIns="0" rtlCol="0" anchor="ctr"/>
           <a:lstStyle/>
           <a:p>
-            <a:pPr algn="ctr" indent="0" marL="0">
+            <a:pPr marL="0" indent="0" algn="ctr">
               <a:buNone/>
             </a:pPr>
             <a:r>
@@ -10874,7 +10791,7 @@
           <a:bodyPr wrap="square" lIns="0" tIns="0" rIns="0" bIns="0" rtlCol="0" anchor="ctr"/>
           <a:lstStyle/>
           <a:p>
-            <a:pPr indent="0" marL="0">
+            <a:pPr marL="0" indent="0">
               <a:buNone/>
             </a:pPr>
             <a:r>
@@ -10913,7 +10830,7 @@
           <a:bodyPr wrap="square" lIns="0" tIns="0" rIns="0" bIns="0" rtlCol="0" anchor="ctr"/>
           <a:lstStyle/>
           <a:p>
-            <a:pPr indent="0" marL="0">
+            <a:pPr marL="0" indent="0">
               <a:buNone/>
             </a:pPr>
             <a:r>
@@ -10952,7 +10869,7 @@
           <a:bodyPr wrap="square" lIns="0" tIns="0" rIns="0" bIns="0" rtlCol="0" anchor="ctr"/>
           <a:lstStyle/>
           <a:p>
-            <a:pPr indent="0" marL="0">
+            <a:pPr marL="0" indent="0">
               <a:buNone/>
             </a:pPr>
             <a:r>
@@ -11016,11 +10933,11 @@
           <a:bodyPr wrap="square" lIns="0" tIns="0" rIns="0" bIns="0" rtlCol="0" anchor="ctr"/>
           <a:lstStyle/>
           <a:p>
-            <a:pPr indent="0" marL="0">
-              <a:buNone/>
-            </a:pPr>
-            <a:r>
-              <a:rPr lang="en-US" sz="1100" b="1" spc="200" kern="0" dirty="0">
+            <a:pPr marL="0" indent="0">
+              <a:buNone/>
+            </a:pPr>
+            <a:r>
+              <a:rPr lang="en-US" sz="1100" b="1" kern="0" spc="200" dirty="0">
                 <a:solidFill>
                   <a:srgbClr val="5A5F6B"/>
                 </a:solidFill>
@@ -11055,7 +10972,7 @@
           <a:bodyPr wrap="square" lIns="0" tIns="0" rIns="0" bIns="0" rtlCol="0" anchor="ctr"/>
           <a:lstStyle/>
           <a:p>
-            <a:pPr indent="0" marL="0">
+            <a:pPr marL="0" indent="0">
               <a:buNone/>
             </a:pPr>
             <a:r>
@@ -11099,6 +11016,13 @@
             <a:prstDash val="solid"/>
           </a:ln>
         </p:spPr>
+        <p:txBody>
+          <a:bodyPr/>
+          <a:lstStyle/>
+          <a:p>
+            <a:endParaRPr lang="en-US"/>
+          </a:p>
+        </p:txBody>
       </p:sp>
       <p:sp>
         <p:nvSpPr>
@@ -11121,7 +11045,7 @@
           <a:bodyPr wrap="square" lIns="0" tIns="0" rIns="0" bIns="0" rtlCol="0" anchor="ctr"/>
           <a:lstStyle/>
           <a:p>
-            <a:pPr indent="0" marL="0">
+            <a:pPr marL="0" indent="0">
               <a:buNone/>
             </a:pPr>
             <a:r>
@@ -11160,7 +11084,7 @@
           <a:bodyPr wrap="square" lIns="0" tIns="0" rIns="0" bIns="0" rtlCol="0" anchor="ctr"/>
           <a:lstStyle/>
           <a:p>
-            <a:pPr indent="0" marL="0">
+            <a:pPr marL="0" indent="0">
               <a:buNone/>
             </a:pPr>
             <a:r>
@@ -11199,7 +11123,7 @@
           <a:bodyPr wrap="square" lIns="0" tIns="0" rIns="0" bIns="0" rtlCol="0" anchor="ctr"/>
           <a:lstStyle/>
           <a:p>
-            <a:pPr indent="0" marL="0">
+            <a:pPr marL="0" indent="0">
               <a:buNone/>
             </a:pPr>
             <a:r>
@@ -11243,6 +11167,13 @@
             <a:prstDash val="solid"/>
           </a:ln>
         </p:spPr>
+        <p:txBody>
+          <a:bodyPr/>
+          <a:lstStyle/>
+          <a:p>
+            <a:endParaRPr lang="en-US"/>
+          </a:p>
+        </p:txBody>
       </p:sp>
       <p:sp>
         <p:nvSpPr>
@@ -11265,7 +11196,7 @@
           <a:bodyPr wrap="square" lIns="0" tIns="0" rIns="0" bIns="0" rtlCol="0" anchor="ctr"/>
           <a:lstStyle/>
           <a:p>
-            <a:pPr indent="0" marL="0">
+            <a:pPr marL="0" indent="0">
               <a:buNone/>
             </a:pPr>
             <a:r>
@@ -11304,7 +11235,7 @@
           <a:bodyPr wrap="square" lIns="0" tIns="0" rIns="0" bIns="0" rtlCol="0" anchor="ctr"/>
           <a:lstStyle/>
           <a:p>
-            <a:pPr indent="0" marL="0">
+            <a:pPr marL="0" indent="0">
               <a:buNone/>
             </a:pPr>
             <a:r>
@@ -11343,7 +11274,7 @@
           <a:bodyPr wrap="square" lIns="0" tIns="0" rIns="0" bIns="0" rtlCol="0" anchor="ctr"/>
           <a:lstStyle/>
           <a:p>
-            <a:pPr indent="0" marL="0">
+            <a:pPr marL="0" indent="0">
               <a:buNone/>
             </a:pPr>
             <a:r>
@@ -11387,6 +11318,13 @@
             <a:prstDash val="solid"/>
           </a:ln>
         </p:spPr>
+        <p:txBody>
+          <a:bodyPr/>
+          <a:lstStyle/>
+          <a:p>
+            <a:endParaRPr lang="en-US"/>
+          </a:p>
+        </p:txBody>
       </p:sp>
       <p:sp>
         <p:nvSpPr>
@@ -11409,7 +11347,7 @@
           <a:bodyPr wrap="square" lIns="0" tIns="0" rIns="0" bIns="0" rtlCol="0" anchor="ctr"/>
           <a:lstStyle/>
           <a:p>
-            <a:pPr indent="0" marL="0">
+            <a:pPr marL="0" indent="0">
               <a:buNone/>
             </a:pPr>
             <a:r>
@@ -11448,7 +11386,7 @@
           <a:bodyPr wrap="square" lIns="0" tIns="0" rIns="0" bIns="0" rtlCol="0" anchor="ctr"/>
           <a:lstStyle/>
           <a:p>
-            <a:pPr indent="0" marL="0">
+            <a:pPr marL="0" indent="0">
               <a:buNone/>
             </a:pPr>
             <a:r>
@@ -11487,7 +11425,7 @@
           <a:bodyPr wrap="square" lIns="0" tIns="0" rIns="0" bIns="0" rtlCol="0" anchor="ctr"/>
           <a:lstStyle/>
           <a:p>
-            <a:pPr indent="0" marL="0">
+            <a:pPr marL="0" indent="0">
               <a:buNone/>
             </a:pPr>
             <a:r>
@@ -11531,6 +11469,13 @@
             <a:prstDash val="solid"/>
           </a:ln>
         </p:spPr>
+        <p:txBody>
+          <a:bodyPr/>
+          <a:lstStyle/>
+          <a:p>
+            <a:endParaRPr lang="en-US"/>
+          </a:p>
+        </p:txBody>
       </p:sp>
       <p:sp>
         <p:nvSpPr>
@@ -11553,7 +11498,7 @@
           <a:bodyPr wrap="square" lIns="0" tIns="0" rIns="0" bIns="0" rtlCol="0" anchor="ctr"/>
           <a:lstStyle/>
           <a:p>
-            <a:pPr indent="0" marL="0">
+            <a:pPr marL="0" indent="0">
               <a:buNone/>
             </a:pPr>
             <a:r>
@@ -11592,7 +11537,7 @@
           <a:bodyPr wrap="square" lIns="0" tIns="0" rIns="0" bIns="0" rtlCol="0" anchor="ctr"/>
           <a:lstStyle/>
           <a:p>
-            <a:pPr indent="0" marL="0">
+            <a:pPr marL="0" indent="0">
               <a:buNone/>
             </a:pPr>
             <a:r>
@@ -11631,7 +11576,7 @@
           <a:bodyPr wrap="square" lIns="0" tIns="0" rIns="0" bIns="0" rtlCol="0" anchor="ctr"/>
           <a:lstStyle/>
           <a:p>
-            <a:pPr indent="0" marL="0">
+            <a:pPr marL="0" indent="0">
               <a:buNone/>
             </a:pPr>
             <a:r>
@@ -11645,9 +11590,6 @@
               </a:rPr>
               <a:t>“Acme Financial is paying for 13 features they did not use this month — </a:t>
             </a:r>
-            <a:pPr indent="0" marL="0">
-              <a:buNone/>
-            </a:pPr>
             <a:r>
               <a:rPr lang="en-US" sz="1300" b="1" dirty="0">
                 <a:solidFill>
@@ -11659,9 +11601,6 @@
               </a:rPr>
               <a:t>3 of them are the reason the SKU was bought</a:t>
             </a:r>
-            <a:pPr indent="0" marL="0">
-              <a:buNone/>
-            </a:pPr>
             <a:r>
               <a:rPr lang="en-US" sz="1300" dirty="0">
                 <a:solidFill>
@@ -11698,7 +11637,7 @@
           <a:bodyPr wrap="square" lIns="0" tIns="0" rIns="0" bIns="0" rtlCol="0" anchor="ctr"/>
           <a:lstStyle/>
           <a:p>
-            <a:pPr indent="0" marL="0">
+            <a:pPr marL="0" indent="0">
               <a:buNone/>
             </a:pPr>
             <a:r>
@@ -11737,7 +11676,7 @@
           <a:bodyPr wrap="square" lIns="0" tIns="0" rIns="0" bIns="0" rtlCol="0" anchor="ctr"/>
           <a:lstStyle/>
           <a:p>
-            <a:pPr indent="0" marL="0">
+            <a:pPr marL="0" indent="0">
               <a:buNone/>
             </a:pPr>
             <a:r>
@@ -11781,6 +11720,13 @@
             <a:prstDash val="solid"/>
           </a:ln>
         </p:spPr>
+        <p:txBody>
+          <a:bodyPr/>
+          <a:lstStyle/>
+          <a:p>
+            <a:endParaRPr lang="en-US"/>
+          </a:p>
+        </p:txBody>
       </p:sp>
       <p:sp>
         <p:nvSpPr>
@@ -11803,7 +11749,7 @@
           <a:bodyPr wrap="square" lIns="0" tIns="0" rIns="0" bIns="0" rtlCol="0" anchor="ctr"/>
           <a:lstStyle/>
           <a:p>
-            <a:pPr indent="0" marL="0">
+            <a:pPr marL="0" indent="0">
               <a:buNone/>
             </a:pPr>
             <a:r>
@@ -11842,7 +11788,7 @@
           <a:bodyPr wrap="square" lIns="0" tIns="0" rIns="0" bIns="0" rtlCol="0" anchor="ctr"/>
           <a:lstStyle/>
           <a:p>
-            <a:pPr indent="0" marL="0">
+            <a:pPr marL="0" indent="0">
               <a:buNone/>
             </a:pPr>
             <a:r>
@@ -11876,6 +11822,7 @@
         <a:solidFill>
           <a:srgbClr val="1E2761"/>
         </a:solidFill>
+        <a:effectLst/>
       </p:bgPr>
     </p:bg>
     <p:spTree>
@@ -11913,11 +11860,11 @@
           <a:bodyPr wrap="square" lIns="0" tIns="0" rIns="0" bIns="0" rtlCol="0" anchor="ctr"/>
           <a:lstStyle/>
           <a:p>
-            <a:pPr indent="0" marL="0">
-              <a:buNone/>
-            </a:pPr>
-            <a:r>
-              <a:rPr lang="en-US" sz="1100" b="1" spc="200" kern="0" dirty="0">
+            <a:pPr marL="0" indent="0">
+              <a:buNone/>
+            </a:pPr>
+            <a:r>
+              <a:rPr lang="en-US" sz="1100" b="1" kern="0" spc="200" dirty="0">
                 <a:solidFill>
                   <a:srgbClr val="CADCFC"/>
                 </a:solidFill>
@@ -11952,7 +11899,7 @@
           <a:bodyPr wrap="square" lIns="0" tIns="0" rIns="0" bIns="0" rtlCol="0" anchor="ctr"/>
           <a:lstStyle/>
           <a:p>
-            <a:pPr indent="0" marL="0">
+            <a:pPr marL="0" indent="0">
               <a:buNone/>
             </a:pPr>
             <a:r>
@@ -11991,7 +11938,7 @@
           <a:bodyPr wrap="square" lIns="0" tIns="0" rIns="0" bIns="0" rtlCol="0" anchor="ctr"/>
           <a:lstStyle/>
           <a:p>
-            <a:pPr indent="0" marL="0">
+            <a:pPr marL="0" indent="0">
               <a:buNone/>
             </a:pPr>
             <a:r>
@@ -12028,6 +11975,13 @@
           </a:solidFill>
           <a:ln/>
         </p:spPr>
+        <p:txBody>
+          <a:bodyPr/>
+          <a:lstStyle/>
+          <a:p>
+            <a:endParaRPr lang="en-US"/>
+          </a:p>
+        </p:txBody>
       </p:sp>
       <p:sp>
         <p:nvSpPr>
@@ -12050,7 +12004,7 @@
           <a:bodyPr wrap="square" lIns="0" tIns="0" rIns="0" bIns="0" rtlCol="0" anchor="ctr"/>
           <a:lstStyle/>
           <a:p>
-            <a:pPr indent="0" marL="0">
+            <a:pPr marL="0" indent="0">
               <a:buNone/>
             </a:pPr>
             <a:r>
@@ -12076,7 +12030,7 @@
         </p:nvSpPr>
         <p:spPr>
           <a:xfrm>
-            <a:off x="3063240" y="3712464"/>
+            <a:off x="3063240" y="3551691"/>
             <a:ext cx="8275320" cy="548640"/>
           </a:xfrm>
           <a:prstGeom prst="rect">
@@ -12089,7 +12043,7 @@
           <a:bodyPr wrap="square" lIns="0" tIns="0" rIns="0" bIns="0" rtlCol="0" anchor="ctr"/>
           <a:lstStyle/>
           <a:p>
-            <a:pPr indent="0" marL="0">
+            <a:pPr marL="0" indent="0">
               <a:buNone/>
             </a:pPr>
             <a:r>
@@ -12126,6 +12080,13 @@
           </a:solidFill>
           <a:ln/>
         </p:spPr>
+        <p:txBody>
+          <a:bodyPr/>
+          <a:lstStyle/>
+          <a:p>
+            <a:endParaRPr lang="en-US"/>
+          </a:p>
+        </p:txBody>
       </p:sp>
       <p:sp>
         <p:nvSpPr>
@@ -12148,7 +12109,7 @@
           <a:bodyPr wrap="square" lIns="0" tIns="0" rIns="0" bIns="0" rtlCol="0" anchor="ctr"/>
           <a:lstStyle/>
           <a:p>
-            <a:pPr indent="0" marL="0">
+            <a:pPr marL="0" indent="0">
               <a:buNone/>
             </a:pPr>
             <a:r>
@@ -12174,7 +12135,7 @@
         </p:nvSpPr>
         <p:spPr>
           <a:xfrm>
-            <a:off x="3063240" y="4553712"/>
+            <a:off x="3063240" y="4392939"/>
             <a:ext cx="8275320" cy="548640"/>
           </a:xfrm>
           <a:prstGeom prst="rect">
@@ -12187,7 +12148,7 @@
           <a:bodyPr wrap="square" lIns="0" tIns="0" rIns="0" bIns="0" rtlCol="0" anchor="ctr"/>
           <a:lstStyle/>
           <a:p>
-            <a:pPr indent="0" marL="0">
+            <a:pPr marL="0" indent="0">
               <a:buNone/>
             </a:pPr>
             <a:r>
@@ -12224,6 +12185,13 @@
           </a:solidFill>
           <a:ln/>
         </p:spPr>
+        <p:txBody>
+          <a:bodyPr/>
+          <a:lstStyle/>
+          <a:p>
+            <a:endParaRPr lang="en-US"/>
+          </a:p>
+        </p:txBody>
       </p:sp>
       <p:sp>
         <p:nvSpPr>
@@ -12246,7 +12214,7 @@
           <a:bodyPr wrap="square" lIns="0" tIns="0" rIns="0" bIns="0" rtlCol="0" anchor="ctr"/>
           <a:lstStyle/>
           <a:p>
-            <a:pPr indent="0" marL="0">
+            <a:pPr marL="0" indent="0">
               <a:buNone/>
             </a:pPr>
             <a:r>
@@ -12272,7 +12240,7 @@
         </p:nvSpPr>
         <p:spPr>
           <a:xfrm>
-            <a:off x="3063240" y="5394960"/>
+            <a:off x="3063240" y="5234187"/>
             <a:ext cx="8275320" cy="548640"/>
           </a:xfrm>
           <a:prstGeom prst="rect">
@@ -12285,7 +12253,7 @@
           <a:bodyPr wrap="square" lIns="0" tIns="0" rIns="0" bIns="0" rtlCol="0" anchor="ctr"/>
           <a:lstStyle/>
           <a:p>
-            <a:pPr indent="0" marL="0">
+            <a:pPr marL="0" indent="0">
               <a:buNone/>
             </a:pPr>
             <a:r>
@@ -12604,4 +12572,319 @@
     </a:ext>
   </a:extLst>
 </a:theme>
+</file>
+
+<file path=ppt/theme/theme2.xml><?xml version="1.0" encoding="utf-8"?>
+<a:theme xmlns:a="http://schemas.openxmlformats.org/drawingml/2006/main" name="Office Theme">
+  <a:themeElements>
+    <a:clrScheme name="Office">
+      <a:dk1>
+        <a:sysClr val="windowText" lastClr="000000"/>
+      </a:dk1>
+      <a:lt1>
+        <a:sysClr val="window" lastClr="FFFFFF"/>
+      </a:lt1>
+      <a:dk2>
+        <a:srgbClr val="0E2841"/>
+      </a:dk2>
+      <a:lt2>
+        <a:srgbClr val="E8E8E8"/>
+      </a:lt2>
+      <a:accent1>
+        <a:srgbClr val="156082"/>
+      </a:accent1>
+      <a:accent2>
+        <a:srgbClr val="E97132"/>
+      </a:accent2>
+      <a:accent3>
+        <a:srgbClr val="196B24"/>
+      </a:accent3>
+      <a:accent4>
+        <a:srgbClr val="0F9ED5"/>
+      </a:accent4>
+      <a:accent5>
+        <a:srgbClr val="A02B93"/>
+      </a:accent5>
+      <a:accent6>
+        <a:srgbClr val="4EA72E"/>
+      </a:accent6>
+      <a:hlink>
+        <a:srgbClr val="467886"/>
+      </a:hlink>
+      <a:folHlink>
+        <a:srgbClr val="96607D"/>
+      </a:folHlink>
+    </a:clrScheme>
+    <a:fontScheme name="Office">
+      <a:majorFont>
+        <a:latin typeface="Aptos Display" panose="02110004020202020204"/>
+        <a:ea typeface=""/>
+        <a:cs typeface=""/>
+        <a:font script="Jpan" typeface="游ゴシック Light"/>
+        <a:font script="Hang" typeface="맑은 고딕"/>
+        <a:font script="Hans" typeface="等线 Light"/>
+        <a:font script="Hant" typeface="新細明體"/>
+        <a:font script="Arab" typeface="Times New Roman"/>
+        <a:font script="Hebr" typeface="Times New Roman"/>
+        <a:font script="Thai" typeface="Angsana New"/>
+        <a:font script="Ethi" typeface="Nyala"/>
+        <a:font script="Beng" typeface="Vrinda"/>
+        <a:font script="Gujr" typeface="Shruti"/>
+        <a:font script="Khmr" typeface="MoolBoran"/>
+        <a:font script="Knda" typeface="Tunga"/>
+        <a:font script="Guru" typeface="Raavi"/>
+        <a:font script="Cans" typeface="Euphemia"/>
+        <a:font script="Cher" typeface="Plantagenet Cherokee"/>
+        <a:font script="Yiii" typeface="Microsoft Yi Baiti"/>
+        <a:font script="Tibt" typeface="Microsoft Himalaya"/>
+        <a:font script="Thaa" typeface="MV Boli"/>
+        <a:font script="Deva" typeface="Mangal"/>
+        <a:font script="Telu" typeface="Gautami"/>
+        <a:font script="Taml" typeface="Latha"/>
+        <a:font script="Syrc" typeface="Estrangelo Edessa"/>
+        <a:font script="Orya" typeface="Kalinga"/>
+        <a:font script="Mlym" typeface="Kartika"/>
+        <a:font script="Laoo" typeface="DokChampa"/>
+        <a:font script="Sinh" typeface="Iskoola Pota"/>
+        <a:font script="Mong" typeface="Mongolian Baiti"/>
+        <a:font script="Viet" typeface="Times New Roman"/>
+        <a:font script="Uigh" typeface="Microsoft Uighur"/>
+        <a:font script="Geor" typeface="Sylfaen"/>
+        <a:font script="Armn" typeface="Arial"/>
+        <a:font script="Bugi" typeface="Leelawadee UI"/>
+        <a:font script="Bopo" typeface="Microsoft JhengHei"/>
+        <a:font script="Java" typeface="Javanese Text"/>
+        <a:font script="Lisu" typeface="Segoe UI"/>
+        <a:font script="Mymr" typeface="Myanmar Text"/>
+        <a:font script="Nkoo" typeface="Ebrima"/>
+        <a:font script="Olck" typeface="Nirmala UI"/>
+        <a:font script="Osma" typeface="Ebrima"/>
+        <a:font script="Phag" typeface="Phagspa"/>
+        <a:font script="Syrn" typeface="Estrangelo Edessa"/>
+        <a:font script="Syrj" typeface="Estrangelo Edessa"/>
+        <a:font script="Syre" typeface="Estrangelo Edessa"/>
+        <a:font script="Sora" typeface="Nirmala UI"/>
+        <a:font script="Tale" typeface="Microsoft Tai Le"/>
+        <a:font script="Talu" typeface="Microsoft New Tai Lue"/>
+        <a:font script="Tfng" typeface="Ebrima"/>
+      </a:majorFont>
+      <a:minorFont>
+        <a:latin typeface="Aptos" panose="02110004020202020204"/>
+        <a:ea typeface=""/>
+        <a:cs typeface=""/>
+        <a:font script="Jpan" typeface="游ゴシック"/>
+        <a:font script="Hang" typeface="맑은 고딕"/>
+        <a:font script="Hans" typeface="等线"/>
+        <a:font script="Hant" typeface="新細明體"/>
+        <a:font script="Arab" typeface="Arial"/>
+        <a:font script="Hebr" typeface="Arial"/>
+        <a:font script="Thai" typeface="Cordia New"/>
+        <a:font script="Ethi" typeface="Nyala"/>
+        <a:font script="Beng" typeface="Vrinda"/>
+        <a:font script="Gujr" typeface="Shruti"/>
+        <a:font script="Khmr" typeface="DaunPenh"/>
+        <a:font script="Knda" typeface="Tunga"/>
+        <a:font script="Guru" typeface="Raavi"/>
+        <a:font script="Cans" typeface="Euphemia"/>
+        <a:font script="Cher" typeface="Plantagenet Cherokee"/>
+        <a:font script="Yiii" typeface="Microsoft Yi Baiti"/>
+        <a:font script="Tibt" typeface="Microsoft Himalaya"/>
+        <a:font script="Thaa" typeface="MV Boli"/>
+        <a:font script="Deva" typeface="Mangal"/>
+        <a:font script="Telu" typeface="Gautami"/>
+        <a:font script="Taml" typeface="Latha"/>
+        <a:font script="Syrc" typeface="Estrangelo Edessa"/>
+        <a:font script="Orya" typeface="Kalinga"/>
+        <a:font script="Mlym" typeface="Kartika"/>
+        <a:font script="Laoo" typeface="DokChampa"/>
+        <a:font script="Sinh" typeface="Iskoola Pota"/>
+        <a:font script="Mong" typeface="Mongolian Baiti"/>
+        <a:font script="Viet" typeface="Arial"/>
+        <a:font script="Uigh" typeface="Microsoft Uighur"/>
+        <a:font script="Geor" typeface="Sylfaen"/>
+        <a:font script="Armn" typeface="Arial"/>
+        <a:font script="Bugi" typeface="Leelawadee UI"/>
+        <a:font script="Bopo" typeface="Microsoft JhengHei"/>
+        <a:font script="Java" typeface="Javanese Text"/>
+        <a:font script="Lisu" typeface="Segoe UI"/>
+        <a:font script="Mymr" typeface="Myanmar Text"/>
+        <a:font script="Nkoo" typeface="Ebrima"/>
+        <a:font script="Olck" typeface="Nirmala UI"/>
+        <a:font script="Osma" typeface="Ebrima"/>
+        <a:font script="Phag" typeface="Phagspa"/>
+        <a:font script="Syrn" typeface="Estrangelo Edessa"/>
+        <a:font script="Syrj" typeface="Estrangelo Edessa"/>
+        <a:font script="Syre" typeface="Estrangelo Edessa"/>
+        <a:font script="Sora" typeface="Nirmala UI"/>
+        <a:font script="Tale" typeface="Microsoft Tai Le"/>
+        <a:font script="Talu" typeface="Microsoft New Tai Lue"/>
+        <a:font script="Tfng" typeface="Ebrima"/>
+      </a:minorFont>
+    </a:fontScheme>
+    <a:fmtScheme name="Office">
+      <a:fillStyleLst>
+        <a:solidFill>
+          <a:schemeClr val="phClr"/>
+        </a:solidFill>
+        <a:gradFill rotWithShape="1">
+          <a:gsLst>
+            <a:gs pos="0">
+              <a:schemeClr val="phClr">
+                <a:lumMod val="110000"/>
+                <a:satMod val="105000"/>
+                <a:tint val="67000"/>
+              </a:schemeClr>
+            </a:gs>
+            <a:gs pos="50000">
+              <a:schemeClr val="phClr">
+                <a:lumMod val="105000"/>
+                <a:satMod val="103000"/>
+                <a:tint val="73000"/>
+              </a:schemeClr>
+            </a:gs>
+            <a:gs pos="100000">
+              <a:schemeClr val="phClr">
+                <a:lumMod val="105000"/>
+                <a:satMod val="109000"/>
+                <a:tint val="81000"/>
+              </a:schemeClr>
+            </a:gs>
+          </a:gsLst>
+          <a:lin ang="5400000" scaled="0"/>
+        </a:gradFill>
+        <a:gradFill rotWithShape="1">
+          <a:gsLst>
+            <a:gs pos="0">
+              <a:schemeClr val="phClr">
+                <a:satMod val="103000"/>
+                <a:lumMod val="102000"/>
+                <a:tint val="94000"/>
+              </a:schemeClr>
+            </a:gs>
+            <a:gs pos="50000">
+              <a:schemeClr val="phClr">
+                <a:satMod val="110000"/>
+                <a:lumMod val="100000"/>
+                <a:shade val="100000"/>
+              </a:schemeClr>
+            </a:gs>
+            <a:gs pos="100000">
+              <a:schemeClr val="phClr">
+                <a:lumMod val="99000"/>
+                <a:satMod val="120000"/>
+                <a:shade val="78000"/>
+              </a:schemeClr>
+            </a:gs>
+          </a:gsLst>
+          <a:lin ang="5400000" scaled="0"/>
+        </a:gradFill>
+      </a:fillStyleLst>
+      <a:lnStyleLst>
+        <a:ln w="12700" cap="flat" cmpd="sng" algn="ctr">
+          <a:solidFill>
+            <a:schemeClr val="phClr"/>
+          </a:solidFill>
+          <a:prstDash val="solid"/>
+          <a:miter lim="800000"/>
+        </a:ln>
+        <a:ln w="19050" cap="flat" cmpd="sng" algn="ctr">
+          <a:solidFill>
+            <a:schemeClr val="phClr"/>
+          </a:solidFill>
+          <a:prstDash val="solid"/>
+          <a:miter lim="800000"/>
+        </a:ln>
+        <a:ln w="25400" cap="flat" cmpd="sng" algn="ctr">
+          <a:solidFill>
+            <a:schemeClr val="phClr"/>
+          </a:solidFill>
+          <a:prstDash val="solid"/>
+          <a:miter lim="800000"/>
+        </a:ln>
+      </a:lnStyleLst>
+      <a:effectStyleLst>
+        <a:effectStyle>
+          <a:effectLst/>
+        </a:effectStyle>
+        <a:effectStyle>
+          <a:effectLst/>
+        </a:effectStyle>
+        <a:effectStyle>
+          <a:effectLst>
+            <a:outerShdw blurRad="57150" dist="19050" dir="5400000" algn="ctr" rotWithShape="0">
+              <a:srgbClr val="000000">
+                <a:alpha val="63000"/>
+              </a:srgbClr>
+            </a:outerShdw>
+          </a:effectLst>
+        </a:effectStyle>
+      </a:effectStyleLst>
+      <a:bgFillStyleLst>
+        <a:solidFill>
+          <a:schemeClr val="phClr"/>
+        </a:solidFill>
+        <a:solidFill>
+          <a:schemeClr val="phClr">
+            <a:tint val="95000"/>
+            <a:satMod val="170000"/>
+          </a:schemeClr>
+        </a:solidFill>
+        <a:gradFill rotWithShape="1">
+          <a:gsLst>
+            <a:gs pos="0">
+              <a:schemeClr val="phClr">
+                <a:tint val="93000"/>
+                <a:satMod val="150000"/>
+                <a:shade val="98000"/>
+                <a:lumMod val="102000"/>
+              </a:schemeClr>
+            </a:gs>
+            <a:gs pos="50000">
+              <a:schemeClr val="phClr">
+                <a:tint val="98000"/>
+                <a:satMod val="130000"/>
+                <a:shade val="90000"/>
+                <a:lumMod val="103000"/>
+              </a:schemeClr>
+            </a:gs>
+            <a:gs pos="100000">
+              <a:schemeClr val="phClr">
+                <a:shade val="63000"/>
+                <a:satMod val="120000"/>
+              </a:schemeClr>
+            </a:gs>
+          </a:gsLst>
+          <a:lin ang="5400000" scaled="0"/>
+        </a:gradFill>
+      </a:bgFillStyleLst>
+    </a:fmtScheme>
+  </a:themeElements>
+  <a:objectDefaults>
+    <a:lnDef>
+      <a:spPr/>
+      <a:bodyPr/>
+      <a:lstStyle/>
+      <a:style>
+        <a:lnRef idx="2">
+          <a:schemeClr val="accent1"/>
+        </a:lnRef>
+        <a:fillRef idx="0">
+          <a:schemeClr val="accent1"/>
+        </a:fillRef>
+        <a:effectRef idx="1">
+          <a:schemeClr val="accent1"/>
+        </a:effectRef>
+        <a:fontRef idx="minor">
+          <a:schemeClr val="tx1"/>
+        </a:fontRef>
+      </a:style>
+    </a:lnDef>
+  </a:objectDefaults>
+  <a:extraClrSchemeLst/>
+  <a:extLst>
+    <a:ext uri="{05A4C25C-085E-4340-85A3-A5531E510DB2}">
+      <thm15:themeFamily xmlns:thm15="http://schemas.microsoft.com/office/thememl/2012/main" name="Office Theme" id="{2E142A2C-CD16-42D6-873A-C26D2A0506FA}" vid="{1BDDFF52-6CD6-40A5-AB3C-68EB2F1E4D0A}"/>
+    </a:ext>
+  </a:extLst>
+</a:theme>
 </file>
</xml_diff>